<commit_message>
Unify profile downloads and sharing assets with QUAN CHENGHAO brand
</commit_message>
<xml_diff>
--- a/downloads/chenghao_physical_ai_self_intro.pptx
+++ b/downloads/chenghao_physical_ai_self_intro.pptx
@@ -2,13 +2,13 @@
 <file path=ppt/presentation.xml><?xml version="1.0" encoding="utf-8"?>
 <p:presentation xmlns:p="http://schemas.openxmlformats.org/presentationml/2006/main">
   <p:sldMasterIdLst>
-    <p:sldMasterId xmlns:r="http://schemas.openxmlformats.org/officeDocument/2006/relationships" id="2147483648" r:id="R963645ed5ea34dff"/>
+    <p:sldMasterId xmlns:r="http://schemas.openxmlformats.org/officeDocument/2006/relationships" id="2147483648" r:id="R9ff10edcb98146e8"/>
   </p:sldMasterIdLst>
   <p:notesMasterIdLst>
-    <p:notesMasterId xmlns:r="http://schemas.openxmlformats.org/officeDocument/2006/relationships" r:id="R9079fa3fe07846d8"/>
+    <p:notesMasterId xmlns:r="http://schemas.openxmlformats.org/officeDocument/2006/relationships" r:id="R89443803f9c44697"/>
   </p:notesMasterIdLst>
   <p:sldIdLst>
-    <p:sldId xmlns:r="http://schemas.openxmlformats.org/officeDocument/2006/relationships" id="256" r:id="Re91250b0be6042e0"/>
+    <p:sldId xmlns:r="http://schemas.openxmlformats.org/officeDocument/2006/relationships" id="256" r:id="Rdd2d6a019a0948ac"/>
   </p:sldIdLst>
   <p:sldSz cx="12192000" cy="6858000"/>
   <p:notesSz cx="6858000" cy="9144000"/>
@@ -497,7 +497,7 @@
           </a:p>
           <a:p xmlns:a="http://schemas.openxmlformats.org/drawingml/2006/main">
             <a:r>
-              <a:t>Biography and operating figures supplied by the presenter. Background: AI-generated concept illustration, not a product photograph.</a:t>
+              <a:t>Biography and operating figures supplied by the presenter. Brand illustration: Nuri, the approved AI-generated cloud-fox companion. Original illustration reused without redesign.</a:t>
             </a:r>
           </a:p>
         </p:txBody>
@@ -565,7 +565,7 @@
   </p:cSld>
   <p:clrMap bg1="lt1" tx1="dk1" bg2="lt2" tx2="dk2" accent1="accent1" accent2="accent2" accent3="accent3" accent4="accent4" accent5="accent5" accent6="accent6" hlink="hlink" folHlink="folHlink"/>
   <p:sldLayoutIdLst>
-    <p:sldLayoutId xmlns:r="http://schemas.openxmlformats.org/officeDocument/2006/relationships" id="2147483649" r:id="R05320fbdcfa148ef"/>
+    <p:sldLayoutId xmlns:r="http://schemas.openxmlformats.org/officeDocument/2006/relationships" id="2147483649" r:id="R4e3d999abbab4d4b"/>
   </p:sldLayoutIdLst>
   <p:txStyles>
     <p:titleStyle>
@@ -1098,7 +1098,7 @@
     <p:bg>
       <p:bgPr>
         <a:solidFill xmlns:a="http://schemas.openxmlformats.org/drawingml/2006/main">
-          <a:srgbClr val="F7FBFF"/>
+          <a:srgbClr val="F5F0E5"/>
         </a:solidFill>
       </p:bgPr>
     </p:bg>
@@ -1111,124 +1111,6 @@
       <p:grpSpPr>
         <a:xfrm xmlns:a="http://schemas.openxmlformats.org/drawingml/2006/main"/>
       </p:grpSpPr>
-      <p:pic>
-        <p:nvPicPr>
-          <p:cNvPr id="25" name=""/>
-          <p:cNvPicPr>
-            <a:picLocks xmlns:a="http://schemas.openxmlformats.org/drawingml/2006/main" noChangeAspect="1"/>
-          </p:cNvPicPr>
-          <p:nvPr/>
-        </p:nvPicPr>
-        <p:blipFill>
-          <a:blip xmlns:r="http://schemas.openxmlformats.org/officeDocument/2006/relationships" xmlns:a="http://schemas.openxmlformats.org/drawingml/2006/main" r:embed="R7fad593ede7a4800"/>
-          <a:srcRect xmlns:a="http://schemas.openxmlformats.org/drawingml/2006/main" l="0" t="27" r="0" b="27"/>
-          <a:stretch xmlns:a="http://schemas.openxmlformats.org/drawingml/2006/main">
-            <a:fillRect l="0" t="0" r="0" b="0"/>
-          </a:stretch>
-        </p:blipFill>
-        <p:spPr>
-          <a:xfrm xmlns:a="http://schemas.openxmlformats.org/drawingml/2006/main">
-            <a:off x="0" y="0"/>
-            <a:ext cx="12192000" cy="6858000"/>
-          </a:xfrm>
-          <a:prstGeom xmlns:a="http://schemas.openxmlformats.org/drawingml/2006/main" prst="rect">
-            <a:avLst/>
-          </a:prstGeom>
-        </p:spPr>
-      </p:pic>
-      <p:sp>
-        <p:nvSpPr>
-          <p:cNvPr id="2" name="left-readability-gradient">
-            <a:extLst xmlns:a="http://schemas.openxmlformats.org/drawingml/2006/main">
-              <a:ext uri="{FF2B5EF4-FFF2-40B4-BE49-F238E27FC236}">
-                <a16:creationId xmlns:a16="http://schemas.microsoft.com/office/drawing/2014/main" id="{72970C16-EAFD-4E7B-BA53-27E52A6437A7}"/>
-              </a:ext>
-            </a:extLst>
-          </p:cNvPr>
-          <p:cNvSpPr>
-            <a:spLocks xmlns:a="http://schemas.openxmlformats.org/drawingml/2006/main" noGrp="1"/>
-          </p:cNvSpPr>
-          <p:nvPr/>
-        </p:nvSpPr>
-        <p:spPr>
-          <a:xfrm xmlns:a="http://schemas.openxmlformats.org/drawingml/2006/main">
-            <a:off x="0" y="0"/>
-            <a:ext cx="8286750" cy="6858000"/>
-          </a:xfrm>
-          <a:prstGeom xmlns:a="http://schemas.openxmlformats.org/drawingml/2006/main" prst="rect">
-            <a:avLst/>
-          </a:prstGeom>
-          <a:gradFill xmlns:a="http://schemas.openxmlformats.org/drawingml/2006/main">
-            <a:gsLst>
-              <a:gs pos="0">
-                <a:srgbClr val="FFFFFF"/>
-              </a:gs>
-              <a:gs pos="58000">
-                <a:srgbClr val="FFFFFF">
-                  <a:alpha val="98000"/>
-                </a:srgbClr>
-              </a:gs>
-              <a:gs pos="78000">
-                <a:srgbClr val="FFFFFF">
-                  <a:alpha val="75000"/>
-                </a:srgbClr>
-              </a:gs>
-              <a:gs pos="100000">
-                <a:srgbClr val="FFFFFF">
-                  <a:alpha val="0"/>
-                </a:srgbClr>
-              </a:gs>
-            </a:gsLst>
-            <a:lin ang="5400000"/>
-          </a:gradFill>
-          <a:ln xmlns:a="http://schemas.openxmlformats.org/drawingml/2006/main" w="0">
-            <a:noFill/>
-            <a:prstDash val="solid"/>
-          </a:ln>
-        </p:spPr>
-      </p:sp>
-      <p:sp>
-        <p:nvSpPr>
-          <p:cNvPr id="3" name="bottom-blue-accent">
-            <a:extLst xmlns:a="http://schemas.openxmlformats.org/drawingml/2006/main">
-              <a:ext uri="{FF2B5EF4-FFF2-40B4-BE49-F238E27FC236}">
-                <a16:creationId xmlns:a16="http://schemas.microsoft.com/office/drawing/2014/main" id="{EF3CE949-8B9B-46CE-9BD9-EB7FF579EEE1}"/>
-              </a:ext>
-            </a:extLst>
-          </p:cNvPr>
-          <p:cNvSpPr>
-            <a:spLocks xmlns:a="http://schemas.openxmlformats.org/drawingml/2006/main" noGrp="1"/>
-          </p:cNvSpPr>
-          <p:nvPr/>
-        </p:nvSpPr>
-        <p:spPr>
-          <a:xfrm xmlns:a="http://schemas.openxmlformats.org/drawingml/2006/main">
-            <a:off x="0" y="6591300"/>
-            <a:ext cx="12192000" cy="266700"/>
-          </a:xfrm>
-          <a:prstGeom xmlns:a="http://schemas.openxmlformats.org/drawingml/2006/main" prst="rect">
-            <a:avLst/>
-          </a:prstGeom>
-          <a:gradFill xmlns:a="http://schemas.openxmlformats.org/drawingml/2006/main">
-            <a:gsLst>
-              <a:gs pos="0">
-                <a:srgbClr val="071957"/>
-              </a:gs>
-              <a:gs pos="50000">
-                <a:srgbClr val="1238C8"/>
-              </a:gs>
-              <a:gs pos="100000">
-                <a:srgbClr val="06B6D4"/>
-              </a:gs>
-            </a:gsLst>
-            <a:lin ang="5400000"/>
-          </a:gradFill>
-          <a:ln xmlns:a="http://schemas.openxmlformats.org/drawingml/2006/main" w="0">
-            <a:noFill/>
-            <a:prstDash val="solid"/>
-          </a:ln>
-        </p:spPr>
-      </p:sp>
       <p:sp>
         <p:nvSpPr>
           <p:cNvPr id="4" name="program-eyebrow">
@@ -1245,8 +1127,8 @@
         </p:nvSpPr>
         <p:spPr>
           <a:xfrm xmlns:a="http://schemas.openxmlformats.org/drawingml/2006/main">
-            <a:off x="666750" y="514350"/>
-            <a:ext cx="4953000" cy="285750"/>
+            <a:off x="609600" y="400050"/>
+            <a:ext cx="7810500" cy="304800"/>
           </a:xfrm>
           <a:prstGeom xmlns:a="http://schemas.openxmlformats.org/drawingml/2006/main" prst="rect">
             <a:avLst/>
@@ -1258,8 +1140,111 @@
           </a:ln>
         </p:spPr>
         <p:txBody>
-          <a:bodyPr xmlns:a="http://schemas.openxmlformats.org/drawingml/2006/main" wrap="square" lIns="0" tIns="0" rIns="0" bIns="0" anchor="t"/>
-          <a:lstStyle xmlns:a="http://schemas.openxmlformats.org/drawingml/2006/main"/>
+          <a:bodyPr xmlns:a="http://schemas.openxmlformats.org/drawingml/2006/main" wrap="square" lIns="0" tIns="0" rIns="0" bIns="0" anchor="t">
+            <a:noAutofit/>
+          </a:bodyPr>
+          <a:lstStyle xmlns:a="http://schemas.openxmlformats.org/drawingml/2006/main">
+            <a:defPPr algn="l">
+              <a:defRPr sz="1350" b="1">
+                <a:solidFill>
+                  <a:srgbClr val="2456D8"/>
+                </a:solidFill>
+                <a:latin typeface="Malgun Gothic"/>
+                <a:ea typeface="Malgun Gothic"/>
+                <a:cs typeface="Malgun Gothic"/>
+              </a:defRPr>
+            </a:defPPr>
+            <a:lvl1pPr algn="l">
+              <a:defRPr sz="1350" b="1">
+                <a:solidFill>
+                  <a:srgbClr val="2456D8"/>
+                </a:solidFill>
+                <a:latin typeface="Malgun Gothic"/>
+                <a:ea typeface="Malgun Gothic"/>
+                <a:cs typeface="Malgun Gothic"/>
+              </a:defRPr>
+            </a:lvl1pPr>
+            <a:lvl2pPr algn="l">
+              <a:defRPr sz="1350" b="1">
+                <a:solidFill>
+                  <a:srgbClr val="2456D8"/>
+                </a:solidFill>
+                <a:latin typeface="Malgun Gothic"/>
+                <a:ea typeface="Malgun Gothic"/>
+                <a:cs typeface="Malgun Gothic"/>
+              </a:defRPr>
+            </a:lvl2pPr>
+            <a:lvl3pPr algn="l">
+              <a:defRPr sz="1350" b="1">
+                <a:solidFill>
+                  <a:srgbClr val="2456D8"/>
+                </a:solidFill>
+                <a:latin typeface="Malgun Gothic"/>
+                <a:ea typeface="Malgun Gothic"/>
+                <a:cs typeface="Malgun Gothic"/>
+              </a:defRPr>
+            </a:lvl3pPr>
+            <a:lvl4pPr algn="l">
+              <a:defRPr sz="1350" b="1">
+                <a:solidFill>
+                  <a:srgbClr val="2456D8"/>
+                </a:solidFill>
+                <a:latin typeface="Malgun Gothic"/>
+                <a:ea typeface="Malgun Gothic"/>
+                <a:cs typeface="Malgun Gothic"/>
+              </a:defRPr>
+            </a:lvl4pPr>
+            <a:lvl5pPr algn="l">
+              <a:defRPr sz="1350" b="1">
+                <a:solidFill>
+                  <a:srgbClr val="2456D8"/>
+                </a:solidFill>
+                <a:latin typeface="Malgun Gothic"/>
+                <a:ea typeface="Malgun Gothic"/>
+                <a:cs typeface="Malgun Gothic"/>
+              </a:defRPr>
+            </a:lvl5pPr>
+            <a:lvl6pPr algn="l">
+              <a:defRPr sz="1350" b="1">
+                <a:solidFill>
+                  <a:srgbClr val="2456D8"/>
+                </a:solidFill>
+                <a:latin typeface="Malgun Gothic"/>
+                <a:ea typeface="Malgun Gothic"/>
+                <a:cs typeface="Malgun Gothic"/>
+              </a:defRPr>
+            </a:lvl6pPr>
+            <a:lvl7pPr algn="l">
+              <a:defRPr sz="1350" b="1">
+                <a:solidFill>
+                  <a:srgbClr val="2456D8"/>
+                </a:solidFill>
+                <a:latin typeface="Malgun Gothic"/>
+                <a:ea typeface="Malgun Gothic"/>
+                <a:cs typeface="Malgun Gothic"/>
+              </a:defRPr>
+            </a:lvl7pPr>
+            <a:lvl8pPr algn="l">
+              <a:defRPr sz="1350" b="1">
+                <a:solidFill>
+                  <a:srgbClr val="2456D8"/>
+                </a:solidFill>
+                <a:latin typeface="Malgun Gothic"/>
+                <a:ea typeface="Malgun Gothic"/>
+                <a:cs typeface="Malgun Gothic"/>
+              </a:defRPr>
+            </a:lvl8pPr>
+            <a:lvl9pPr algn="l">
+              <a:defRPr sz="1350" b="1">
+                <a:solidFill>
+                  <a:srgbClr val="2456D8"/>
+                </a:solidFill>
+                <a:latin typeface="Malgun Gothic"/>
+                <a:ea typeface="Malgun Gothic"/>
+                <a:cs typeface="Malgun Gothic"/>
+              </a:defRPr>
+            </a:lvl9pPr>
+          </a:lstStyle>
           <a:p xmlns:a="http://schemas.openxmlformats.org/drawingml/2006/main">
             <a:pPr algn="l">
               <a:lnSpc>
@@ -1268,7 +1253,7 @@
               <a:buNone/>
               <a:defRPr sz="1350" b="1">
                 <a:solidFill>
-                  <a:srgbClr val="1238C8"/>
+                  <a:srgbClr val="2456D8"/>
                 </a:solidFill>
                 <a:latin typeface="Malgun Gothic"/>
                 <a:ea typeface="Malgun Gothic"/>
@@ -1278,7 +1263,7 @@
             <a:r>
               <a:rPr sz="1350" b="1">
                 <a:solidFill>
-                  <a:srgbClr val="1238C8"/>
+                  <a:srgbClr val="2456D8"/>
                 </a:solidFill>
                 <a:latin typeface="Malgun Gothic"/>
                 <a:ea typeface="Malgun Gothic"/>
@@ -1305,8 +1290,8 @@
         </p:nvSpPr>
         <p:spPr>
           <a:xfrm xmlns:a="http://schemas.openxmlformats.org/drawingml/2006/main">
-            <a:off x="647700" y="990600"/>
-            <a:ext cx="6572250" cy="1733550"/>
+            <a:off x="571500" y="809625"/>
+            <a:ext cx="8096250" cy="742950"/>
           </a:xfrm>
           <a:prstGeom xmlns:a="http://schemas.openxmlformats.org/drawingml/2006/main" prst="rect">
             <a:avLst/>
@@ -1318,87 +1303,136 @@
           </a:ln>
         </p:spPr>
         <p:txBody>
-          <a:bodyPr xmlns:a="http://schemas.openxmlformats.org/drawingml/2006/main" wrap="square" lIns="0" tIns="0" rIns="0" bIns="0" anchor="t"/>
-          <a:lstStyle xmlns:a="http://schemas.openxmlformats.org/drawingml/2006/main"/>
+          <a:bodyPr xmlns:a="http://schemas.openxmlformats.org/drawingml/2006/main" wrap="square" lIns="0" tIns="0" rIns="0" bIns="0" anchor="t">
+            <a:noAutofit/>
+          </a:bodyPr>
+          <a:lstStyle xmlns:a="http://schemas.openxmlformats.org/drawingml/2006/main">
+            <a:defPPr algn="l">
+              <a:defRPr sz="4350" b="1">
+                <a:solidFill>
+                  <a:srgbClr val="14243A"/>
+                </a:solidFill>
+                <a:latin typeface="Segoe UI"/>
+                <a:ea typeface="Segoe UI"/>
+                <a:cs typeface="Segoe UI"/>
+              </a:defRPr>
+            </a:defPPr>
+            <a:lvl1pPr algn="l">
+              <a:defRPr sz="4350" b="1">
+                <a:solidFill>
+                  <a:srgbClr val="14243A"/>
+                </a:solidFill>
+                <a:latin typeface="Segoe UI"/>
+                <a:ea typeface="Segoe UI"/>
+                <a:cs typeface="Segoe UI"/>
+              </a:defRPr>
+            </a:lvl1pPr>
+            <a:lvl2pPr algn="l">
+              <a:defRPr sz="4350" b="1">
+                <a:solidFill>
+                  <a:srgbClr val="14243A"/>
+                </a:solidFill>
+                <a:latin typeface="Segoe UI"/>
+                <a:ea typeface="Segoe UI"/>
+                <a:cs typeface="Segoe UI"/>
+              </a:defRPr>
+            </a:lvl2pPr>
+            <a:lvl3pPr algn="l">
+              <a:defRPr sz="4350" b="1">
+                <a:solidFill>
+                  <a:srgbClr val="14243A"/>
+                </a:solidFill>
+                <a:latin typeface="Segoe UI"/>
+                <a:ea typeface="Segoe UI"/>
+                <a:cs typeface="Segoe UI"/>
+              </a:defRPr>
+            </a:lvl3pPr>
+            <a:lvl4pPr algn="l">
+              <a:defRPr sz="4350" b="1">
+                <a:solidFill>
+                  <a:srgbClr val="14243A"/>
+                </a:solidFill>
+                <a:latin typeface="Segoe UI"/>
+                <a:ea typeface="Segoe UI"/>
+                <a:cs typeface="Segoe UI"/>
+              </a:defRPr>
+            </a:lvl4pPr>
+            <a:lvl5pPr algn="l">
+              <a:defRPr sz="4350" b="1">
+                <a:solidFill>
+                  <a:srgbClr val="14243A"/>
+                </a:solidFill>
+                <a:latin typeface="Segoe UI"/>
+                <a:ea typeface="Segoe UI"/>
+                <a:cs typeface="Segoe UI"/>
+              </a:defRPr>
+            </a:lvl5pPr>
+            <a:lvl6pPr algn="l">
+              <a:defRPr sz="4350" b="1">
+                <a:solidFill>
+                  <a:srgbClr val="14243A"/>
+                </a:solidFill>
+                <a:latin typeface="Segoe UI"/>
+                <a:ea typeface="Segoe UI"/>
+                <a:cs typeface="Segoe UI"/>
+              </a:defRPr>
+            </a:lvl6pPr>
+            <a:lvl7pPr algn="l">
+              <a:defRPr sz="4350" b="1">
+                <a:solidFill>
+                  <a:srgbClr val="14243A"/>
+                </a:solidFill>
+                <a:latin typeface="Segoe UI"/>
+                <a:ea typeface="Segoe UI"/>
+                <a:cs typeface="Segoe UI"/>
+              </a:defRPr>
+            </a:lvl7pPr>
+            <a:lvl8pPr algn="l">
+              <a:defRPr sz="4350" b="1">
+                <a:solidFill>
+                  <a:srgbClr val="14243A"/>
+                </a:solidFill>
+                <a:latin typeface="Segoe UI"/>
+                <a:ea typeface="Segoe UI"/>
+                <a:cs typeface="Segoe UI"/>
+              </a:defRPr>
+            </a:lvl8pPr>
+            <a:lvl9pPr algn="l">
+              <a:defRPr sz="4350" b="1">
+                <a:solidFill>
+                  <a:srgbClr val="14243A"/>
+                </a:solidFill>
+                <a:latin typeface="Segoe UI"/>
+                <a:ea typeface="Segoe UI"/>
+                <a:cs typeface="Segoe UI"/>
+              </a:defRPr>
+            </a:lvl9pPr>
+          </a:lstStyle>
           <a:p xmlns:a="http://schemas.openxmlformats.org/drawingml/2006/main">
             <a:pPr algn="l">
               <a:lnSpc>
                 <a:spcPct val="92000"/>
               </a:lnSpc>
               <a:buNone/>
-              <a:defRPr sz="3750" b="1">
-                <a:solidFill>
-                  <a:srgbClr val="061330"/>
-                </a:solidFill>
-                <a:latin typeface="Malgun Gothic"/>
-                <a:ea typeface="Malgun Gothic"/>
-                <a:cs typeface="Malgun Gothic"/>
+              <a:defRPr sz="4350" b="1">
+                <a:solidFill>
+                  <a:srgbClr val="14243A"/>
+                </a:solidFill>
+                <a:latin typeface="Segoe UI"/>
+                <a:ea typeface="Segoe UI"/>
+                <a:cs typeface="Segoe UI"/>
               </a:defRPr>
             </a:pPr>
             <a:r>
-              <a:rPr sz="3750" b="1">
-                <a:solidFill>
-                  <a:srgbClr val="061330"/>
-                </a:solidFill>
-                <a:latin typeface="Malgun Gothic"/>
-                <a:ea typeface="Malgun Gothic"/>
-                <a:cs typeface="Malgun Gothic"/>
+              <a:rPr sz="4350" b="1">
+                <a:solidFill>
+                  <a:srgbClr val="14243A"/>
+                </a:solidFill>
+                <a:latin typeface="Segoe UI"/>
+                <a:ea typeface="Segoe UI"/>
+                <a:cs typeface="Segoe UI"/>
               </a:rPr>
-              <a:t>AI 시대,</a:t>
-            </a:r>
-          </a:p>
-          <a:p xmlns:a="http://schemas.openxmlformats.org/drawingml/2006/main">
-            <a:pPr algn="l">
-              <a:lnSpc>
-                <a:spcPct val="92000"/>
-              </a:lnSpc>
-              <a:buNone/>
-              <a:defRPr sz="3750" b="1">
-                <a:solidFill>
-                  <a:srgbClr val="061330"/>
-                </a:solidFill>
-                <a:latin typeface="Malgun Gothic"/>
-                <a:ea typeface="Malgun Gothic"/>
-                <a:cs typeface="Malgun Gothic"/>
-              </a:defRPr>
-            </a:pPr>
-            <a:r>
-              <a:rPr sz="3750" b="1">
-                <a:solidFill>
-                  <a:srgbClr val="061330"/>
-                </a:solidFill>
-                <a:latin typeface="Malgun Gothic"/>
-                <a:ea typeface="Malgun Gothic"/>
-                <a:cs typeface="Malgun Gothic"/>
-              </a:rPr>
-              <a:t>순찰 보안 로봇</a:t>
-            </a:r>
-          </a:p>
-          <a:p xmlns:a="http://schemas.openxmlformats.org/drawingml/2006/main">
-            <a:pPr algn="l">
-              <a:lnSpc>
-                <a:spcPct val="92000"/>
-              </a:lnSpc>
-              <a:buNone/>
-              <a:defRPr sz="3750" b="1">
-                <a:solidFill>
-                  <a:srgbClr val="061330"/>
-                </a:solidFill>
-                <a:latin typeface="Malgun Gothic"/>
-                <a:ea typeface="Malgun Gothic"/>
-                <a:cs typeface="Malgun Gothic"/>
-              </a:defRPr>
-            </a:pPr>
-            <a:r>
-              <a:rPr sz="3750" b="1">
-                <a:solidFill>
-                  <a:srgbClr val="061330"/>
-                </a:solidFill>
-                <a:latin typeface="Malgun Gothic"/>
-                <a:ea typeface="Malgun Gothic"/>
-                <a:cs typeface="Malgun Gothic"/>
-              </a:rPr>
-              <a:t>Top 1을 향해</a:t>
+              <a:t>QUAN CHENGHAO</a:t>
             </a:r>
           </a:p>
         </p:txBody>
@@ -1419,8 +1453,8 @@
         </p:nvSpPr>
         <p:spPr>
           <a:xfrm xmlns:a="http://schemas.openxmlformats.org/drawingml/2006/main">
-            <a:off x="685800" y="2895600"/>
-            <a:ext cx="7239000" cy="323850"/>
+            <a:off x="609600" y="2181225"/>
+            <a:ext cx="8001000" cy="333375"/>
           </a:xfrm>
           <a:prstGeom xmlns:a="http://schemas.openxmlformats.org/drawingml/2006/main" prst="rect">
             <a:avLst/>
@@ -1432,17 +1466,120 @@
           </a:ln>
         </p:spPr>
         <p:txBody>
-          <a:bodyPr xmlns:a="http://schemas.openxmlformats.org/drawingml/2006/main" wrap="square" lIns="0" tIns="0" rIns="0" bIns="0" anchor="t"/>
-          <a:lstStyle xmlns:a="http://schemas.openxmlformats.org/drawingml/2006/main"/>
+          <a:bodyPr xmlns:a="http://schemas.openxmlformats.org/drawingml/2006/main" wrap="square" lIns="0" tIns="0" rIns="0" bIns="0" anchor="t">
+            <a:noAutofit/>
+          </a:bodyPr>
+          <a:lstStyle xmlns:a="http://schemas.openxmlformats.org/drawingml/2006/main">
+            <a:defPPr algn="l">
+              <a:defRPr sz="1575" b="1">
+                <a:solidFill>
+                  <a:srgbClr val="14243A"/>
+                </a:solidFill>
+                <a:latin typeface="Malgun Gothic"/>
+                <a:ea typeface="Malgun Gothic"/>
+                <a:cs typeface="Malgun Gothic"/>
+              </a:defRPr>
+            </a:defPPr>
+            <a:lvl1pPr algn="l">
+              <a:defRPr sz="1575" b="1">
+                <a:solidFill>
+                  <a:srgbClr val="14243A"/>
+                </a:solidFill>
+                <a:latin typeface="Malgun Gothic"/>
+                <a:ea typeface="Malgun Gothic"/>
+                <a:cs typeface="Malgun Gothic"/>
+              </a:defRPr>
+            </a:lvl1pPr>
+            <a:lvl2pPr algn="l">
+              <a:defRPr sz="1575" b="1">
+                <a:solidFill>
+                  <a:srgbClr val="14243A"/>
+                </a:solidFill>
+                <a:latin typeface="Malgun Gothic"/>
+                <a:ea typeface="Malgun Gothic"/>
+                <a:cs typeface="Malgun Gothic"/>
+              </a:defRPr>
+            </a:lvl2pPr>
+            <a:lvl3pPr algn="l">
+              <a:defRPr sz="1575" b="1">
+                <a:solidFill>
+                  <a:srgbClr val="14243A"/>
+                </a:solidFill>
+                <a:latin typeface="Malgun Gothic"/>
+                <a:ea typeface="Malgun Gothic"/>
+                <a:cs typeface="Malgun Gothic"/>
+              </a:defRPr>
+            </a:lvl3pPr>
+            <a:lvl4pPr algn="l">
+              <a:defRPr sz="1575" b="1">
+                <a:solidFill>
+                  <a:srgbClr val="14243A"/>
+                </a:solidFill>
+                <a:latin typeface="Malgun Gothic"/>
+                <a:ea typeface="Malgun Gothic"/>
+                <a:cs typeface="Malgun Gothic"/>
+              </a:defRPr>
+            </a:lvl4pPr>
+            <a:lvl5pPr algn="l">
+              <a:defRPr sz="1575" b="1">
+                <a:solidFill>
+                  <a:srgbClr val="14243A"/>
+                </a:solidFill>
+                <a:latin typeface="Malgun Gothic"/>
+                <a:ea typeface="Malgun Gothic"/>
+                <a:cs typeface="Malgun Gothic"/>
+              </a:defRPr>
+            </a:lvl5pPr>
+            <a:lvl6pPr algn="l">
+              <a:defRPr sz="1575" b="1">
+                <a:solidFill>
+                  <a:srgbClr val="14243A"/>
+                </a:solidFill>
+                <a:latin typeface="Malgun Gothic"/>
+                <a:ea typeface="Malgun Gothic"/>
+                <a:cs typeface="Malgun Gothic"/>
+              </a:defRPr>
+            </a:lvl6pPr>
+            <a:lvl7pPr algn="l">
+              <a:defRPr sz="1575" b="1">
+                <a:solidFill>
+                  <a:srgbClr val="14243A"/>
+                </a:solidFill>
+                <a:latin typeface="Malgun Gothic"/>
+                <a:ea typeface="Malgun Gothic"/>
+                <a:cs typeface="Malgun Gothic"/>
+              </a:defRPr>
+            </a:lvl7pPr>
+            <a:lvl8pPr algn="l">
+              <a:defRPr sz="1575" b="1">
+                <a:solidFill>
+                  <a:srgbClr val="14243A"/>
+                </a:solidFill>
+                <a:latin typeface="Malgun Gothic"/>
+                <a:ea typeface="Malgun Gothic"/>
+                <a:cs typeface="Malgun Gothic"/>
+              </a:defRPr>
+            </a:lvl8pPr>
+            <a:lvl9pPr algn="l">
+              <a:defRPr sz="1575" b="1">
+                <a:solidFill>
+                  <a:srgbClr val="14243A"/>
+                </a:solidFill>
+                <a:latin typeface="Malgun Gothic"/>
+                <a:ea typeface="Malgun Gothic"/>
+                <a:cs typeface="Malgun Gothic"/>
+              </a:defRPr>
+            </a:lvl9pPr>
+          </a:lstStyle>
           <a:p xmlns:a="http://schemas.openxmlformats.org/drawingml/2006/main">
             <a:pPr algn="l">
               <a:lnSpc>
                 <a:spcPct val="112000"/>
               </a:lnSpc>
               <a:buNone/>
-              <a:defRPr sz="1650" b="1">
-                <a:solidFill>
-                  <a:srgbClr val="0C2A78"/>
+              <a:defRPr sz="1575" b="1">
+                <a:solidFill>
+                  <a:srgbClr val="14243A"/>
                 </a:solidFill>
                 <a:latin typeface="Malgun Gothic"/>
                 <a:ea typeface="Malgun Gothic"/>
@@ -1450,9 +1587,9 @@
               </a:defRPr>
             </a:pPr>
             <a:r>
-              <a:rPr sz="1650" b="1">
-                <a:solidFill>
-                  <a:srgbClr val="0C2A78"/>
+              <a:rPr sz="1575" b="1">
+                <a:solidFill>
+                  <a:srgbClr val="14243A"/>
                 </a:solidFill>
                 <a:latin typeface="Malgun Gothic"/>
                 <a:ea typeface="Malgun Gothic"/>
@@ -1479,8 +1616,8 @@
         </p:nvSpPr>
         <p:spPr>
           <a:xfrm xmlns:a="http://schemas.openxmlformats.org/drawingml/2006/main">
-            <a:off x="685800" y="3390900"/>
-            <a:ext cx="6477000" cy="514350"/>
+            <a:off x="609600" y="2647950"/>
+            <a:ext cx="7715250" cy="628650"/>
           </a:xfrm>
           <a:prstGeom xmlns:a="http://schemas.openxmlformats.org/drawingml/2006/main" prst="rect">
             <a:avLst/>
@@ -1492,17 +1629,120 @@
           </a:ln>
         </p:spPr>
         <p:txBody>
-          <a:bodyPr xmlns:a="http://schemas.openxmlformats.org/drawingml/2006/main" wrap="square" lIns="0" tIns="0" rIns="0" bIns="0" anchor="t"/>
-          <a:lstStyle xmlns:a="http://schemas.openxmlformats.org/drawingml/2006/main"/>
+          <a:bodyPr xmlns:a="http://schemas.openxmlformats.org/drawingml/2006/main" wrap="square" lIns="0" tIns="0" rIns="0" bIns="0" anchor="t">
+            <a:noAutofit/>
+          </a:bodyPr>
+          <a:lstStyle xmlns:a="http://schemas.openxmlformats.org/drawingml/2006/main">
+            <a:defPPr algn="l">
+              <a:defRPr sz="1500" b="0">
+                <a:solidFill>
+                  <a:srgbClr val="14243A"/>
+                </a:solidFill>
+                <a:latin typeface="Malgun Gothic"/>
+                <a:ea typeface="Malgun Gothic"/>
+                <a:cs typeface="Malgun Gothic"/>
+              </a:defRPr>
+            </a:defPPr>
+            <a:lvl1pPr algn="l">
+              <a:defRPr sz="1500" b="0">
+                <a:solidFill>
+                  <a:srgbClr val="14243A"/>
+                </a:solidFill>
+                <a:latin typeface="Malgun Gothic"/>
+                <a:ea typeface="Malgun Gothic"/>
+                <a:cs typeface="Malgun Gothic"/>
+              </a:defRPr>
+            </a:lvl1pPr>
+            <a:lvl2pPr algn="l">
+              <a:defRPr sz="1500" b="0">
+                <a:solidFill>
+                  <a:srgbClr val="14243A"/>
+                </a:solidFill>
+                <a:latin typeface="Malgun Gothic"/>
+                <a:ea typeface="Malgun Gothic"/>
+                <a:cs typeface="Malgun Gothic"/>
+              </a:defRPr>
+            </a:lvl2pPr>
+            <a:lvl3pPr algn="l">
+              <a:defRPr sz="1500" b="0">
+                <a:solidFill>
+                  <a:srgbClr val="14243A"/>
+                </a:solidFill>
+                <a:latin typeface="Malgun Gothic"/>
+                <a:ea typeface="Malgun Gothic"/>
+                <a:cs typeface="Malgun Gothic"/>
+              </a:defRPr>
+            </a:lvl3pPr>
+            <a:lvl4pPr algn="l">
+              <a:defRPr sz="1500" b="0">
+                <a:solidFill>
+                  <a:srgbClr val="14243A"/>
+                </a:solidFill>
+                <a:latin typeface="Malgun Gothic"/>
+                <a:ea typeface="Malgun Gothic"/>
+                <a:cs typeface="Malgun Gothic"/>
+              </a:defRPr>
+            </a:lvl4pPr>
+            <a:lvl5pPr algn="l">
+              <a:defRPr sz="1500" b="0">
+                <a:solidFill>
+                  <a:srgbClr val="14243A"/>
+                </a:solidFill>
+                <a:latin typeface="Malgun Gothic"/>
+                <a:ea typeface="Malgun Gothic"/>
+                <a:cs typeface="Malgun Gothic"/>
+              </a:defRPr>
+            </a:lvl5pPr>
+            <a:lvl6pPr algn="l">
+              <a:defRPr sz="1500" b="0">
+                <a:solidFill>
+                  <a:srgbClr val="14243A"/>
+                </a:solidFill>
+                <a:latin typeface="Malgun Gothic"/>
+                <a:ea typeface="Malgun Gothic"/>
+                <a:cs typeface="Malgun Gothic"/>
+              </a:defRPr>
+            </a:lvl6pPr>
+            <a:lvl7pPr algn="l">
+              <a:defRPr sz="1500" b="0">
+                <a:solidFill>
+                  <a:srgbClr val="14243A"/>
+                </a:solidFill>
+                <a:latin typeface="Malgun Gothic"/>
+                <a:ea typeface="Malgun Gothic"/>
+                <a:cs typeface="Malgun Gothic"/>
+              </a:defRPr>
+            </a:lvl7pPr>
+            <a:lvl8pPr algn="l">
+              <a:defRPr sz="1500" b="0">
+                <a:solidFill>
+                  <a:srgbClr val="14243A"/>
+                </a:solidFill>
+                <a:latin typeface="Malgun Gothic"/>
+                <a:ea typeface="Malgun Gothic"/>
+                <a:cs typeface="Malgun Gothic"/>
+              </a:defRPr>
+            </a:lvl8pPr>
+            <a:lvl9pPr algn="l">
+              <a:defRPr sz="1500" b="0">
+                <a:solidFill>
+                  <a:srgbClr val="14243A"/>
+                </a:solidFill>
+                <a:latin typeface="Malgun Gothic"/>
+                <a:ea typeface="Malgun Gothic"/>
+                <a:cs typeface="Malgun Gothic"/>
+              </a:defRPr>
+            </a:lvl9pPr>
+          </a:lstStyle>
           <a:p xmlns:a="http://schemas.openxmlformats.org/drawingml/2006/main">
             <a:pPr algn="l">
               <a:lnSpc>
                 <a:spcPct val="118000"/>
               </a:lnSpc>
               <a:buNone/>
-              <a:defRPr sz="1425" b="0">
-                <a:solidFill>
-                  <a:srgbClr val="314260"/>
+              <a:defRPr sz="1500" b="0">
+                <a:solidFill>
+                  <a:srgbClr val="14243A"/>
                 </a:solidFill>
                 <a:latin typeface="Malgun Gothic"/>
                 <a:ea typeface="Malgun Gothic"/>
@@ -1510,9 +1750,9 @@
               </a:defRPr>
             </a:pPr>
             <a:r>
-              <a:rPr sz="1425" b="0">
-                <a:solidFill>
-                  <a:srgbClr val="314260"/>
+              <a:rPr sz="1500" b="0">
+                <a:solidFill>
+                  <a:srgbClr val="14243A"/>
                 </a:solidFill>
                 <a:latin typeface="Malgun Gothic"/>
                 <a:ea typeface="Malgun Gothic"/>
@@ -1539,16 +1779,16 @@
         </p:nvSpPr>
         <p:spPr>
           <a:xfrm xmlns:a="http://schemas.openxmlformats.org/drawingml/2006/main">
-            <a:off x="685800" y="4057650"/>
-            <a:ext cx="6191250" cy="0"/>
+            <a:off x="609600" y="3400425"/>
+            <a:ext cx="7715250" cy="0"/>
           </a:xfrm>
           <a:prstGeom xmlns:a="http://schemas.openxmlformats.org/drawingml/2006/main" prst="line">
             <a:avLst/>
           </a:prstGeom>
           <a:noFill xmlns:a="http://schemas.openxmlformats.org/drawingml/2006/main"/>
-          <a:ln xmlns:a="http://schemas.openxmlformats.org/drawingml/2006/main" w="13335">
+          <a:ln xmlns:a="http://schemas.openxmlformats.org/drawingml/2006/main" w="14288">
             <a:solidFill>
-              <a:srgbClr val="B8C7E6"/>
+              <a:srgbClr val="BBC6D6"/>
             </a:solidFill>
             <a:prstDash val="solid"/>
           </a:ln>
@@ -1570,8 +1810,8 @@
         </p:nvSpPr>
         <p:spPr>
           <a:xfrm xmlns:a="http://schemas.openxmlformats.org/drawingml/2006/main">
-            <a:off x="685800" y="4248150"/>
-            <a:ext cx="914400" cy="285750"/>
+            <a:off x="609600" y="3638550"/>
+            <a:ext cx="904875" cy="314325"/>
           </a:xfrm>
           <a:prstGeom xmlns:a="http://schemas.openxmlformats.org/drawingml/2006/main" prst="rect">
             <a:avLst/>
@@ -1583,17 +1823,120 @@
           </a:ln>
         </p:spPr>
         <p:txBody>
-          <a:bodyPr xmlns:a="http://schemas.openxmlformats.org/drawingml/2006/main" wrap="square" lIns="0" tIns="0" rIns="0" bIns="0" anchor="t"/>
-          <a:lstStyle xmlns:a="http://schemas.openxmlformats.org/drawingml/2006/main"/>
+          <a:bodyPr xmlns:a="http://schemas.openxmlformats.org/drawingml/2006/main" wrap="square" lIns="0" tIns="0" rIns="0" bIns="0" anchor="t">
+            <a:noAutofit/>
+          </a:bodyPr>
+          <a:lstStyle xmlns:a="http://schemas.openxmlformats.org/drawingml/2006/main">
+            <a:defPPr algn="l">
+              <a:defRPr sz="1425" b="1">
+                <a:solidFill>
+                  <a:srgbClr val="2456D8"/>
+                </a:solidFill>
+                <a:latin typeface="Malgun Gothic"/>
+                <a:ea typeface="Malgun Gothic"/>
+                <a:cs typeface="Malgun Gothic"/>
+              </a:defRPr>
+            </a:defPPr>
+            <a:lvl1pPr algn="l">
+              <a:defRPr sz="1425" b="1">
+                <a:solidFill>
+                  <a:srgbClr val="2456D8"/>
+                </a:solidFill>
+                <a:latin typeface="Malgun Gothic"/>
+                <a:ea typeface="Malgun Gothic"/>
+                <a:cs typeface="Malgun Gothic"/>
+              </a:defRPr>
+            </a:lvl1pPr>
+            <a:lvl2pPr algn="l">
+              <a:defRPr sz="1425" b="1">
+                <a:solidFill>
+                  <a:srgbClr val="2456D8"/>
+                </a:solidFill>
+                <a:latin typeface="Malgun Gothic"/>
+                <a:ea typeface="Malgun Gothic"/>
+                <a:cs typeface="Malgun Gothic"/>
+              </a:defRPr>
+            </a:lvl2pPr>
+            <a:lvl3pPr algn="l">
+              <a:defRPr sz="1425" b="1">
+                <a:solidFill>
+                  <a:srgbClr val="2456D8"/>
+                </a:solidFill>
+                <a:latin typeface="Malgun Gothic"/>
+                <a:ea typeface="Malgun Gothic"/>
+                <a:cs typeface="Malgun Gothic"/>
+              </a:defRPr>
+            </a:lvl3pPr>
+            <a:lvl4pPr algn="l">
+              <a:defRPr sz="1425" b="1">
+                <a:solidFill>
+                  <a:srgbClr val="2456D8"/>
+                </a:solidFill>
+                <a:latin typeface="Malgun Gothic"/>
+                <a:ea typeface="Malgun Gothic"/>
+                <a:cs typeface="Malgun Gothic"/>
+              </a:defRPr>
+            </a:lvl4pPr>
+            <a:lvl5pPr algn="l">
+              <a:defRPr sz="1425" b="1">
+                <a:solidFill>
+                  <a:srgbClr val="2456D8"/>
+                </a:solidFill>
+                <a:latin typeface="Malgun Gothic"/>
+                <a:ea typeface="Malgun Gothic"/>
+                <a:cs typeface="Malgun Gothic"/>
+              </a:defRPr>
+            </a:lvl5pPr>
+            <a:lvl6pPr algn="l">
+              <a:defRPr sz="1425" b="1">
+                <a:solidFill>
+                  <a:srgbClr val="2456D8"/>
+                </a:solidFill>
+                <a:latin typeface="Malgun Gothic"/>
+                <a:ea typeface="Malgun Gothic"/>
+                <a:cs typeface="Malgun Gothic"/>
+              </a:defRPr>
+            </a:lvl6pPr>
+            <a:lvl7pPr algn="l">
+              <a:defRPr sz="1425" b="1">
+                <a:solidFill>
+                  <a:srgbClr val="2456D8"/>
+                </a:solidFill>
+                <a:latin typeface="Malgun Gothic"/>
+                <a:ea typeface="Malgun Gothic"/>
+                <a:cs typeface="Malgun Gothic"/>
+              </a:defRPr>
+            </a:lvl7pPr>
+            <a:lvl8pPr algn="l">
+              <a:defRPr sz="1425" b="1">
+                <a:solidFill>
+                  <a:srgbClr val="2456D8"/>
+                </a:solidFill>
+                <a:latin typeface="Malgun Gothic"/>
+                <a:ea typeface="Malgun Gothic"/>
+                <a:cs typeface="Malgun Gothic"/>
+              </a:defRPr>
+            </a:lvl8pPr>
+            <a:lvl9pPr algn="l">
+              <a:defRPr sz="1425" b="1">
+                <a:solidFill>
+                  <a:srgbClr val="2456D8"/>
+                </a:solidFill>
+                <a:latin typeface="Malgun Gothic"/>
+                <a:ea typeface="Malgun Gothic"/>
+                <a:cs typeface="Malgun Gothic"/>
+              </a:defRPr>
+            </a:lvl9pPr>
+          </a:lstStyle>
           <a:p xmlns:a="http://schemas.openxmlformats.org/drawingml/2006/main">
             <a:pPr algn="l">
               <a:lnSpc>
                 <a:spcPct val="112000"/>
               </a:lnSpc>
               <a:buNone/>
-              <a:defRPr sz="1275" b="1">
-                <a:solidFill>
-                  <a:srgbClr val="1238C8"/>
+              <a:defRPr sz="1425" b="1">
+                <a:solidFill>
+                  <a:srgbClr val="2456D8"/>
                 </a:solidFill>
                 <a:latin typeface="Malgun Gothic"/>
                 <a:ea typeface="Malgun Gothic"/>
@@ -1601,9 +1944,9 @@
               </a:defRPr>
             </a:pPr>
             <a:r>
-              <a:rPr sz="1275" b="1">
-                <a:solidFill>
-                  <a:srgbClr val="1238C8"/>
+              <a:rPr sz="1425" b="1">
+                <a:solidFill>
+                  <a:srgbClr val="2456D8"/>
                 </a:solidFill>
                 <a:latin typeface="Malgun Gothic"/>
                 <a:ea typeface="Malgun Gothic"/>
@@ -1630,8 +1973,8 @@
         </p:nvSpPr>
         <p:spPr>
           <a:xfrm xmlns:a="http://schemas.openxmlformats.org/drawingml/2006/main">
-            <a:off x="1695450" y="4238625"/>
-            <a:ext cx="5810250" cy="400050"/>
+            <a:off x="1628775" y="3629025"/>
+            <a:ext cx="6753225" cy="400050"/>
           </a:xfrm>
           <a:prstGeom xmlns:a="http://schemas.openxmlformats.org/drawingml/2006/main" prst="rect">
             <a:avLst/>
@@ -1643,17 +1986,120 @@
           </a:ln>
         </p:spPr>
         <p:txBody>
-          <a:bodyPr xmlns:a="http://schemas.openxmlformats.org/drawingml/2006/main" wrap="square" lIns="0" tIns="0" rIns="0" bIns="0" anchor="t"/>
-          <a:lstStyle xmlns:a="http://schemas.openxmlformats.org/drawingml/2006/main"/>
+          <a:bodyPr xmlns:a="http://schemas.openxmlformats.org/drawingml/2006/main" wrap="square" lIns="0" tIns="0" rIns="0" bIns="0" anchor="t">
+            <a:noAutofit/>
+          </a:bodyPr>
+          <a:lstStyle xmlns:a="http://schemas.openxmlformats.org/drawingml/2006/main">
+            <a:defPPr algn="l">
+              <a:defRPr sz="1500" b="0">
+                <a:solidFill>
+                  <a:srgbClr val="14243A"/>
+                </a:solidFill>
+                <a:latin typeface="Malgun Gothic"/>
+                <a:ea typeface="Malgun Gothic"/>
+                <a:cs typeface="Malgun Gothic"/>
+              </a:defRPr>
+            </a:defPPr>
+            <a:lvl1pPr algn="l">
+              <a:defRPr sz="1500" b="0">
+                <a:solidFill>
+                  <a:srgbClr val="14243A"/>
+                </a:solidFill>
+                <a:latin typeface="Malgun Gothic"/>
+                <a:ea typeface="Malgun Gothic"/>
+                <a:cs typeface="Malgun Gothic"/>
+              </a:defRPr>
+            </a:lvl1pPr>
+            <a:lvl2pPr algn="l">
+              <a:defRPr sz="1500" b="0">
+                <a:solidFill>
+                  <a:srgbClr val="14243A"/>
+                </a:solidFill>
+                <a:latin typeface="Malgun Gothic"/>
+                <a:ea typeface="Malgun Gothic"/>
+                <a:cs typeface="Malgun Gothic"/>
+              </a:defRPr>
+            </a:lvl2pPr>
+            <a:lvl3pPr algn="l">
+              <a:defRPr sz="1500" b="0">
+                <a:solidFill>
+                  <a:srgbClr val="14243A"/>
+                </a:solidFill>
+                <a:latin typeface="Malgun Gothic"/>
+                <a:ea typeface="Malgun Gothic"/>
+                <a:cs typeface="Malgun Gothic"/>
+              </a:defRPr>
+            </a:lvl3pPr>
+            <a:lvl4pPr algn="l">
+              <a:defRPr sz="1500" b="0">
+                <a:solidFill>
+                  <a:srgbClr val="14243A"/>
+                </a:solidFill>
+                <a:latin typeface="Malgun Gothic"/>
+                <a:ea typeface="Malgun Gothic"/>
+                <a:cs typeface="Malgun Gothic"/>
+              </a:defRPr>
+            </a:lvl4pPr>
+            <a:lvl5pPr algn="l">
+              <a:defRPr sz="1500" b="0">
+                <a:solidFill>
+                  <a:srgbClr val="14243A"/>
+                </a:solidFill>
+                <a:latin typeface="Malgun Gothic"/>
+                <a:ea typeface="Malgun Gothic"/>
+                <a:cs typeface="Malgun Gothic"/>
+              </a:defRPr>
+            </a:lvl5pPr>
+            <a:lvl6pPr algn="l">
+              <a:defRPr sz="1500" b="0">
+                <a:solidFill>
+                  <a:srgbClr val="14243A"/>
+                </a:solidFill>
+                <a:latin typeface="Malgun Gothic"/>
+                <a:ea typeface="Malgun Gothic"/>
+                <a:cs typeface="Malgun Gothic"/>
+              </a:defRPr>
+            </a:lvl6pPr>
+            <a:lvl7pPr algn="l">
+              <a:defRPr sz="1500" b="0">
+                <a:solidFill>
+                  <a:srgbClr val="14243A"/>
+                </a:solidFill>
+                <a:latin typeface="Malgun Gothic"/>
+                <a:ea typeface="Malgun Gothic"/>
+                <a:cs typeface="Malgun Gothic"/>
+              </a:defRPr>
+            </a:lvl7pPr>
+            <a:lvl8pPr algn="l">
+              <a:defRPr sz="1500" b="0">
+                <a:solidFill>
+                  <a:srgbClr val="14243A"/>
+                </a:solidFill>
+                <a:latin typeface="Malgun Gothic"/>
+                <a:ea typeface="Malgun Gothic"/>
+                <a:cs typeface="Malgun Gothic"/>
+              </a:defRPr>
+            </a:lvl8pPr>
+            <a:lvl9pPr algn="l">
+              <a:defRPr sz="1500" b="0">
+                <a:solidFill>
+                  <a:srgbClr val="14243A"/>
+                </a:solidFill>
+                <a:latin typeface="Malgun Gothic"/>
+                <a:ea typeface="Malgun Gothic"/>
+                <a:cs typeface="Malgun Gothic"/>
+              </a:defRPr>
+            </a:lvl9pPr>
+          </a:lstStyle>
           <a:p xmlns:a="http://schemas.openxmlformats.org/drawingml/2006/main">
             <a:pPr algn="l">
               <a:lnSpc>
                 <a:spcPct val="116000"/>
               </a:lnSpc>
               <a:buNone/>
-              <a:defRPr sz="1425" b="0">
-                <a:solidFill>
-                  <a:srgbClr val="1B2B4D"/>
+              <a:defRPr sz="1500" b="0">
+                <a:solidFill>
+                  <a:srgbClr val="14243A"/>
                 </a:solidFill>
                 <a:latin typeface="Malgun Gothic"/>
                 <a:ea typeface="Malgun Gothic"/>
@@ -1661,9 +2107,9 @@
               </a:defRPr>
             </a:pPr>
             <a:r>
-              <a:rPr sz="1425" b="0">
-                <a:solidFill>
-                  <a:srgbClr val="1B2B4D"/>
+              <a:rPr sz="1500" b="0">
+                <a:solidFill>
+                  <a:srgbClr val="14243A"/>
                 </a:solidFill>
                 <a:latin typeface="Malgun Gothic"/>
                 <a:ea typeface="Malgun Gothic"/>
@@ -1690,8 +2136,8 @@
         </p:nvSpPr>
         <p:spPr>
           <a:xfrm xmlns:a="http://schemas.openxmlformats.org/drawingml/2006/main">
-            <a:off x="685800" y="4648200"/>
-            <a:ext cx="914400" cy="285750"/>
+            <a:off x="609600" y="4086225"/>
+            <a:ext cx="904875" cy="314325"/>
           </a:xfrm>
           <a:prstGeom xmlns:a="http://schemas.openxmlformats.org/drawingml/2006/main" prst="rect">
             <a:avLst/>
@@ -1703,17 +2149,120 @@
           </a:ln>
         </p:spPr>
         <p:txBody>
-          <a:bodyPr xmlns:a="http://schemas.openxmlformats.org/drawingml/2006/main" wrap="square" lIns="0" tIns="0" rIns="0" bIns="0" anchor="t"/>
-          <a:lstStyle xmlns:a="http://schemas.openxmlformats.org/drawingml/2006/main"/>
+          <a:bodyPr xmlns:a="http://schemas.openxmlformats.org/drawingml/2006/main" wrap="square" lIns="0" tIns="0" rIns="0" bIns="0" anchor="t">
+            <a:noAutofit/>
+          </a:bodyPr>
+          <a:lstStyle xmlns:a="http://schemas.openxmlformats.org/drawingml/2006/main">
+            <a:defPPr algn="l">
+              <a:defRPr sz="1425" b="1">
+                <a:solidFill>
+                  <a:srgbClr val="2456D8"/>
+                </a:solidFill>
+                <a:latin typeface="Malgun Gothic"/>
+                <a:ea typeface="Malgun Gothic"/>
+                <a:cs typeface="Malgun Gothic"/>
+              </a:defRPr>
+            </a:defPPr>
+            <a:lvl1pPr algn="l">
+              <a:defRPr sz="1425" b="1">
+                <a:solidFill>
+                  <a:srgbClr val="2456D8"/>
+                </a:solidFill>
+                <a:latin typeface="Malgun Gothic"/>
+                <a:ea typeface="Malgun Gothic"/>
+                <a:cs typeface="Malgun Gothic"/>
+              </a:defRPr>
+            </a:lvl1pPr>
+            <a:lvl2pPr algn="l">
+              <a:defRPr sz="1425" b="1">
+                <a:solidFill>
+                  <a:srgbClr val="2456D8"/>
+                </a:solidFill>
+                <a:latin typeface="Malgun Gothic"/>
+                <a:ea typeface="Malgun Gothic"/>
+                <a:cs typeface="Malgun Gothic"/>
+              </a:defRPr>
+            </a:lvl2pPr>
+            <a:lvl3pPr algn="l">
+              <a:defRPr sz="1425" b="1">
+                <a:solidFill>
+                  <a:srgbClr val="2456D8"/>
+                </a:solidFill>
+                <a:latin typeface="Malgun Gothic"/>
+                <a:ea typeface="Malgun Gothic"/>
+                <a:cs typeface="Malgun Gothic"/>
+              </a:defRPr>
+            </a:lvl3pPr>
+            <a:lvl4pPr algn="l">
+              <a:defRPr sz="1425" b="1">
+                <a:solidFill>
+                  <a:srgbClr val="2456D8"/>
+                </a:solidFill>
+                <a:latin typeface="Malgun Gothic"/>
+                <a:ea typeface="Malgun Gothic"/>
+                <a:cs typeface="Malgun Gothic"/>
+              </a:defRPr>
+            </a:lvl4pPr>
+            <a:lvl5pPr algn="l">
+              <a:defRPr sz="1425" b="1">
+                <a:solidFill>
+                  <a:srgbClr val="2456D8"/>
+                </a:solidFill>
+                <a:latin typeface="Malgun Gothic"/>
+                <a:ea typeface="Malgun Gothic"/>
+                <a:cs typeface="Malgun Gothic"/>
+              </a:defRPr>
+            </a:lvl5pPr>
+            <a:lvl6pPr algn="l">
+              <a:defRPr sz="1425" b="1">
+                <a:solidFill>
+                  <a:srgbClr val="2456D8"/>
+                </a:solidFill>
+                <a:latin typeface="Malgun Gothic"/>
+                <a:ea typeface="Malgun Gothic"/>
+                <a:cs typeface="Malgun Gothic"/>
+              </a:defRPr>
+            </a:lvl6pPr>
+            <a:lvl7pPr algn="l">
+              <a:defRPr sz="1425" b="1">
+                <a:solidFill>
+                  <a:srgbClr val="2456D8"/>
+                </a:solidFill>
+                <a:latin typeface="Malgun Gothic"/>
+                <a:ea typeface="Malgun Gothic"/>
+                <a:cs typeface="Malgun Gothic"/>
+              </a:defRPr>
+            </a:lvl7pPr>
+            <a:lvl8pPr algn="l">
+              <a:defRPr sz="1425" b="1">
+                <a:solidFill>
+                  <a:srgbClr val="2456D8"/>
+                </a:solidFill>
+                <a:latin typeface="Malgun Gothic"/>
+                <a:ea typeface="Malgun Gothic"/>
+                <a:cs typeface="Malgun Gothic"/>
+              </a:defRPr>
+            </a:lvl8pPr>
+            <a:lvl9pPr algn="l">
+              <a:defRPr sz="1425" b="1">
+                <a:solidFill>
+                  <a:srgbClr val="2456D8"/>
+                </a:solidFill>
+                <a:latin typeface="Malgun Gothic"/>
+                <a:ea typeface="Malgun Gothic"/>
+                <a:cs typeface="Malgun Gothic"/>
+              </a:defRPr>
+            </a:lvl9pPr>
+          </a:lstStyle>
           <a:p xmlns:a="http://schemas.openxmlformats.org/drawingml/2006/main">
             <a:pPr algn="l">
               <a:lnSpc>
                 <a:spcPct val="112000"/>
               </a:lnSpc>
               <a:buNone/>
-              <a:defRPr sz="1275" b="1">
-                <a:solidFill>
-                  <a:srgbClr val="1238C8"/>
+              <a:defRPr sz="1425" b="1">
+                <a:solidFill>
+                  <a:srgbClr val="2456D8"/>
                 </a:solidFill>
                 <a:latin typeface="Malgun Gothic"/>
                 <a:ea typeface="Malgun Gothic"/>
@@ -1721,9 +2270,9 @@
               </a:defRPr>
             </a:pPr>
             <a:r>
-              <a:rPr sz="1275" b="1">
-                <a:solidFill>
-                  <a:srgbClr val="1238C8"/>
+              <a:rPr sz="1425" b="1">
+                <a:solidFill>
+                  <a:srgbClr val="2456D8"/>
                 </a:solidFill>
                 <a:latin typeface="Malgun Gothic"/>
                 <a:ea typeface="Malgun Gothic"/>
@@ -1750,8 +2299,8 @@
         </p:nvSpPr>
         <p:spPr>
           <a:xfrm xmlns:a="http://schemas.openxmlformats.org/drawingml/2006/main">
-            <a:off x="1695450" y="4638675"/>
-            <a:ext cx="5810250" cy="400050"/>
+            <a:off x="1628775" y="4076700"/>
+            <a:ext cx="6753225" cy="400050"/>
           </a:xfrm>
           <a:prstGeom xmlns:a="http://schemas.openxmlformats.org/drawingml/2006/main" prst="rect">
             <a:avLst/>
@@ -1763,17 +2312,120 @@
           </a:ln>
         </p:spPr>
         <p:txBody>
-          <a:bodyPr xmlns:a="http://schemas.openxmlformats.org/drawingml/2006/main" wrap="square" lIns="0" tIns="0" rIns="0" bIns="0" anchor="t"/>
-          <a:lstStyle xmlns:a="http://schemas.openxmlformats.org/drawingml/2006/main"/>
+          <a:bodyPr xmlns:a="http://schemas.openxmlformats.org/drawingml/2006/main" wrap="square" lIns="0" tIns="0" rIns="0" bIns="0" anchor="t">
+            <a:noAutofit/>
+          </a:bodyPr>
+          <a:lstStyle xmlns:a="http://schemas.openxmlformats.org/drawingml/2006/main">
+            <a:defPPr algn="l">
+              <a:defRPr sz="1500" b="0">
+                <a:solidFill>
+                  <a:srgbClr val="14243A"/>
+                </a:solidFill>
+                <a:latin typeface="Malgun Gothic"/>
+                <a:ea typeface="Malgun Gothic"/>
+                <a:cs typeface="Malgun Gothic"/>
+              </a:defRPr>
+            </a:defPPr>
+            <a:lvl1pPr algn="l">
+              <a:defRPr sz="1500" b="0">
+                <a:solidFill>
+                  <a:srgbClr val="14243A"/>
+                </a:solidFill>
+                <a:latin typeface="Malgun Gothic"/>
+                <a:ea typeface="Malgun Gothic"/>
+                <a:cs typeface="Malgun Gothic"/>
+              </a:defRPr>
+            </a:lvl1pPr>
+            <a:lvl2pPr algn="l">
+              <a:defRPr sz="1500" b="0">
+                <a:solidFill>
+                  <a:srgbClr val="14243A"/>
+                </a:solidFill>
+                <a:latin typeface="Malgun Gothic"/>
+                <a:ea typeface="Malgun Gothic"/>
+                <a:cs typeface="Malgun Gothic"/>
+              </a:defRPr>
+            </a:lvl2pPr>
+            <a:lvl3pPr algn="l">
+              <a:defRPr sz="1500" b="0">
+                <a:solidFill>
+                  <a:srgbClr val="14243A"/>
+                </a:solidFill>
+                <a:latin typeface="Malgun Gothic"/>
+                <a:ea typeface="Malgun Gothic"/>
+                <a:cs typeface="Malgun Gothic"/>
+              </a:defRPr>
+            </a:lvl3pPr>
+            <a:lvl4pPr algn="l">
+              <a:defRPr sz="1500" b="0">
+                <a:solidFill>
+                  <a:srgbClr val="14243A"/>
+                </a:solidFill>
+                <a:latin typeface="Malgun Gothic"/>
+                <a:ea typeface="Malgun Gothic"/>
+                <a:cs typeface="Malgun Gothic"/>
+              </a:defRPr>
+            </a:lvl4pPr>
+            <a:lvl5pPr algn="l">
+              <a:defRPr sz="1500" b="0">
+                <a:solidFill>
+                  <a:srgbClr val="14243A"/>
+                </a:solidFill>
+                <a:latin typeface="Malgun Gothic"/>
+                <a:ea typeface="Malgun Gothic"/>
+                <a:cs typeface="Malgun Gothic"/>
+              </a:defRPr>
+            </a:lvl5pPr>
+            <a:lvl6pPr algn="l">
+              <a:defRPr sz="1500" b="0">
+                <a:solidFill>
+                  <a:srgbClr val="14243A"/>
+                </a:solidFill>
+                <a:latin typeface="Malgun Gothic"/>
+                <a:ea typeface="Malgun Gothic"/>
+                <a:cs typeface="Malgun Gothic"/>
+              </a:defRPr>
+            </a:lvl6pPr>
+            <a:lvl7pPr algn="l">
+              <a:defRPr sz="1500" b="0">
+                <a:solidFill>
+                  <a:srgbClr val="14243A"/>
+                </a:solidFill>
+                <a:latin typeface="Malgun Gothic"/>
+                <a:ea typeface="Malgun Gothic"/>
+                <a:cs typeface="Malgun Gothic"/>
+              </a:defRPr>
+            </a:lvl7pPr>
+            <a:lvl8pPr algn="l">
+              <a:defRPr sz="1500" b="0">
+                <a:solidFill>
+                  <a:srgbClr val="14243A"/>
+                </a:solidFill>
+                <a:latin typeface="Malgun Gothic"/>
+                <a:ea typeface="Malgun Gothic"/>
+                <a:cs typeface="Malgun Gothic"/>
+              </a:defRPr>
+            </a:lvl8pPr>
+            <a:lvl9pPr algn="l">
+              <a:defRPr sz="1500" b="0">
+                <a:solidFill>
+                  <a:srgbClr val="14243A"/>
+                </a:solidFill>
+                <a:latin typeface="Malgun Gothic"/>
+                <a:ea typeface="Malgun Gothic"/>
+                <a:cs typeface="Malgun Gothic"/>
+              </a:defRPr>
+            </a:lvl9pPr>
+          </a:lstStyle>
           <a:p xmlns:a="http://schemas.openxmlformats.org/drawingml/2006/main">
             <a:pPr algn="l">
               <a:lnSpc>
                 <a:spcPct val="116000"/>
               </a:lnSpc>
               <a:buNone/>
-              <a:defRPr sz="1425" b="0">
-                <a:solidFill>
-                  <a:srgbClr val="1B2B4D"/>
+              <a:defRPr sz="1500" b="0">
+                <a:solidFill>
+                  <a:srgbClr val="14243A"/>
                 </a:solidFill>
                 <a:latin typeface="Malgun Gothic"/>
                 <a:ea typeface="Malgun Gothic"/>
@@ -1781,9 +2433,9 @@
               </a:defRPr>
             </a:pPr>
             <a:r>
-              <a:rPr sz="1425" b="0">
-                <a:solidFill>
-                  <a:srgbClr val="1B2B4D"/>
+              <a:rPr sz="1500" b="0">
+                <a:solidFill>
+                  <a:srgbClr val="14243A"/>
                 </a:solidFill>
                 <a:latin typeface="Malgun Gothic"/>
                 <a:ea typeface="Malgun Gothic"/>
@@ -1810,8 +2462,8 @@
         </p:nvSpPr>
         <p:spPr>
           <a:xfrm xmlns:a="http://schemas.openxmlformats.org/drawingml/2006/main">
-            <a:off x="685800" y="5048250"/>
-            <a:ext cx="914400" cy="285750"/>
+            <a:off x="609600" y="4533900"/>
+            <a:ext cx="904875" cy="314325"/>
           </a:xfrm>
           <a:prstGeom xmlns:a="http://schemas.openxmlformats.org/drawingml/2006/main" prst="rect">
             <a:avLst/>
@@ -1823,17 +2475,120 @@
           </a:ln>
         </p:spPr>
         <p:txBody>
-          <a:bodyPr xmlns:a="http://schemas.openxmlformats.org/drawingml/2006/main" wrap="square" lIns="0" tIns="0" rIns="0" bIns="0" anchor="t"/>
-          <a:lstStyle xmlns:a="http://schemas.openxmlformats.org/drawingml/2006/main"/>
+          <a:bodyPr xmlns:a="http://schemas.openxmlformats.org/drawingml/2006/main" wrap="square" lIns="0" tIns="0" rIns="0" bIns="0" anchor="t">
+            <a:noAutofit/>
+          </a:bodyPr>
+          <a:lstStyle xmlns:a="http://schemas.openxmlformats.org/drawingml/2006/main">
+            <a:defPPr algn="l">
+              <a:defRPr sz="1425" b="1">
+                <a:solidFill>
+                  <a:srgbClr val="2456D8"/>
+                </a:solidFill>
+                <a:latin typeface="Malgun Gothic"/>
+                <a:ea typeface="Malgun Gothic"/>
+                <a:cs typeface="Malgun Gothic"/>
+              </a:defRPr>
+            </a:defPPr>
+            <a:lvl1pPr algn="l">
+              <a:defRPr sz="1425" b="1">
+                <a:solidFill>
+                  <a:srgbClr val="2456D8"/>
+                </a:solidFill>
+                <a:latin typeface="Malgun Gothic"/>
+                <a:ea typeface="Malgun Gothic"/>
+                <a:cs typeface="Malgun Gothic"/>
+              </a:defRPr>
+            </a:lvl1pPr>
+            <a:lvl2pPr algn="l">
+              <a:defRPr sz="1425" b="1">
+                <a:solidFill>
+                  <a:srgbClr val="2456D8"/>
+                </a:solidFill>
+                <a:latin typeface="Malgun Gothic"/>
+                <a:ea typeface="Malgun Gothic"/>
+                <a:cs typeface="Malgun Gothic"/>
+              </a:defRPr>
+            </a:lvl2pPr>
+            <a:lvl3pPr algn="l">
+              <a:defRPr sz="1425" b="1">
+                <a:solidFill>
+                  <a:srgbClr val="2456D8"/>
+                </a:solidFill>
+                <a:latin typeface="Malgun Gothic"/>
+                <a:ea typeface="Malgun Gothic"/>
+                <a:cs typeface="Malgun Gothic"/>
+              </a:defRPr>
+            </a:lvl3pPr>
+            <a:lvl4pPr algn="l">
+              <a:defRPr sz="1425" b="1">
+                <a:solidFill>
+                  <a:srgbClr val="2456D8"/>
+                </a:solidFill>
+                <a:latin typeface="Malgun Gothic"/>
+                <a:ea typeface="Malgun Gothic"/>
+                <a:cs typeface="Malgun Gothic"/>
+              </a:defRPr>
+            </a:lvl4pPr>
+            <a:lvl5pPr algn="l">
+              <a:defRPr sz="1425" b="1">
+                <a:solidFill>
+                  <a:srgbClr val="2456D8"/>
+                </a:solidFill>
+                <a:latin typeface="Malgun Gothic"/>
+                <a:ea typeface="Malgun Gothic"/>
+                <a:cs typeface="Malgun Gothic"/>
+              </a:defRPr>
+            </a:lvl5pPr>
+            <a:lvl6pPr algn="l">
+              <a:defRPr sz="1425" b="1">
+                <a:solidFill>
+                  <a:srgbClr val="2456D8"/>
+                </a:solidFill>
+                <a:latin typeface="Malgun Gothic"/>
+                <a:ea typeface="Malgun Gothic"/>
+                <a:cs typeface="Malgun Gothic"/>
+              </a:defRPr>
+            </a:lvl6pPr>
+            <a:lvl7pPr algn="l">
+              <a:defRPr sz="1425" b="1">
+                <a:solidFill>
+                  <a:srgbClr val="2456D8"/>
+                </a:solidFill>
+                <a:latin typeface="Malgun Gothic"/>
+                <a:ea typeface="Malgun Gothic"/>
+                <a:cs typeface="Malgun Gothic"/>
+              </a:defRPr>
+            </a:lvl7pPr>
+            <a:lvl8pPr algn="l">
+              <a:defRPr sz="1425" b="1">
+                <a:solidFill>
+                  <a:srgbClr val="2456D8"/>
+                </a:solidFill>
+                <a:latin typeface="Malgun Gothic"/>
+                <a:ea typeface="Malgun Gothic"/>
+                <a:cs typeface="Malgun Gothic"/>
+              </a:defRPr>
+            </a:lvl8pPr>
+            <a:lvl9pPr algn="l">
+              <a:defRPr sz="1425" b="1">
+                <a:solidFill>
+                  <a:srgbClr val="2456D8"/>
+                </a:solidFill>
+                <a:latin typeface="Malgun Gothic"/>
+                <a:ea typeface="Malgun Gothic"/>
+                <a:cs typeface="Malgun Gothic"/>
+              </a:defRPr>
+            </a:lvl9pPr>
+          </a:lstStyle>
           <a:p xmlns:a="http://schemas.openxmlformats.org/drawingml/2006/main">
             <a:pPr algn="l">
               <a:lnSpc>
                 <a:spcPct val="112000"/>
               </a:lnSpc>
               <a:buNone/>
-              <a:defRPr sz="1275" b="1">
-                <a:solidFill>
-                  <a:srgbClr val="1238C8"/>
+              <a:defRPr sz="1425" b="1">
+                <a:solidFill>
+                  <a:srgbClr val="2456D8"/>
                 </a:solidFill>
                 <a:latin typeface="Malgun Gothic"/>
                 <a:ea typeface="Malgun Gothic"/>
@@ -1841,9 +2596,9 @@
               </a:defRPr>
             </a:pPr>
             <a:r>
-              <a:rPr sz="1275" b="1">
-                <a:solidFill>
-                  <a:srgbClr val="1238C8"/>
+              <a:rPr sz="1425" b="1">
+                <a:solidFill>
+                  <a:srgbClr val="2456D8"/>
                 </a:solidFill>
                 <a:latin typeface="Malgun Gothic"/>
                 <a:ea typeface="Malgun Gothic"/>
@@ -1870,8 +2625,8 @@
         </p:nvSpPr>
         <p:spPr>
           <a:xfrm xmlns:a="http://schemas.openxmlformats.org/drawingml/2006/main">
-            <a:off x="1695450" y="5038725"/>
-            <a:ext cx="5810250" cy="400050"/>
+            <a:off x="1628775" y="4524375"/>
+            <a:ext cx="6753225" cy="400050"/>
           </a:xfrm>
           <a:prstGeom xmlns:a="http://schemas.openxmlformats.org/drawingml/2006/main" prst="rect">
             <a:avLst/>
@@ -1883,17 +2638,120 @@
           </a:ln>
         </p:spPr>
         <p:txBody>
-          <a:bodyPr xmlns:a="http://schemas.openxmlformats.org/drawingml/2006/main" wrap="square" lIns="0" tIns="0" rIns="0" bIns="0" anchor="t"/>
-          <a:lstStyle xmlns:a="http://schemas.openxmlformats.org/drawingml/2006/main"/>
+          <a:bodyPr xmlns:a="http://schemas.openxmlformats.org/drawingml/2006/main" wrap="square" lIns="0" tIns="0" rIns="0" bIns="0" anchor="t">
+            <a:noAutofit/>
+          </a:bodyPr>
+          <a:lstStyle xmlns:a="http://schemas.openxmlformats.org/drawingml/2006/main">
+            <a:defPPr algn="l">
+              <a:defRPr sz="1500" b="0">
+                <a:solidFill>
+                  <a:srgbClr val="14243A"/>
+                </a:solidFill>
+                <a:latin typeface="Malgun Gothic"/>
+                <a:ea typeface="Malgun Gothic"/>
+                <a:cs typeface="Malgun Gothic"/>
+              </a:defRPr>
+            </a:defPPr>
+            <a:lvl1pPr algn="l">
+              <a:defRPr sz="1500" b="0">
+                <a:solidFill>
+                  <a:srgbClr val="14243A"/>
+                </a:solidFill>
+                <a:latin typeface="Malgun Gothic"/>
+                <a:ea typeface="Malgun Gothic"/>
+                <a:cs typeface="Malgun Gothic"/>
+              </a:defRPr>
+            </a:lvl1pPr>
+            <a:lvl2pPr algn="l">
+              <a:defRPr sz="1500" b="0">
+                <a:solidFill>
+                  <a:srgbClr val="14243A"/>
+                </a:solidFill>
+                <a:latin typeface="Malgun Gothic"/>
+                <a:ea typeface="Malgun Gothic"/>
+                <a:cs typeface="Malgun Gothic"/>
+              </a:defRPr>
+            </a:lvl2pPr>
+            <a:lvl3pPr algn="l">
+              <a:defRPr sz="1500" b="0">
+                <a:solidFill>
+                  <a:srgbClr val="14243A"/>
+                </a:solidFill>
+                <a:latin typeface="Malgun Gothic"/>
+                <a:ea typeface="Malgun Gothic"/>
+                <a:cs typeface="Malgun Gothic"/>
+              </a:defRPr>
+            </a:lvl3pPr>
+            <a:lvl4pPr algn="l">
+              <a:defRPr sz="1500" b="0">
+                <a:solidFill>
+                  <a:srgbClr val="14243A"/>
+                </a:solidFill>
+                <a:latin typeface="Malgun Gothic"/>
+                <a:ea typeface="Malgun Gothic"/>
+                <a:cs typeface="Malgun Gothic"/>
+              </a:defRPr>
+            </a:lvl4pPr>
+            <a:lvl5pPr algn="l">
+              <a:defRPr sz="1500" b="0">
+                <a:solidFill>
+                  <a:srgbClr val="14243A"/>
+                </a:solidFill>
+                <a:latin typeface="Malgun Gothic"/>
+                <a:ea typeface="Malgun Gothic"/>
+                <a:cs typeface="Malgun Gothic"/>
+              </a:defRPr>
+            </a:lvl5pPr>
+            <a:lvl6pPr algn="l">
+              <a:defRPr sz="1500" b="0">
+                <a:solidFill>
+                  <a:srgbClr val="14243A"/>
+                </a:solidFill>
+                <a:latin typeface="Malgun Gothic"/>
+                <a:ea typeface="Malgun Gothic"/>
+                <a:cs typeface="Malgun Gothic"/>
+              </a:defRPr>
+            </a:lvl6pPr>
+            <a:lvl7pPr algn="l">
+              <a:defRPr sz="1500" b="0">
+                <a:solidFill>
+                  <a:srgbClr val="14243A"/>
+                </a:solidFill>
+                <a:latin typeface="Malgun Gothic"/>
+                <a:ea typeface="Malgun Gothic"/>
+                <a:cs typeface="Malgun Gothic"/>
+              </a:defRPr>
+            </a:lvl7pPr>
+            <a:lvl8pPr algn="l">
+              <a:defRPr sz="1500" b="0">
+                <a:solidFill>
+                  <a:srgbClr val="14243A"/>
+                </a:solidFill>
+                <a:latin typeface="Malgun Gothic"/>
+                <a:ea typeface="Malgun Gothic"/>
+                <a:cs typeface="Malgun Gothic"/>
+              </a:defRPr>
+            </a:lvl8pPr>
+            <a:lvl9pPr algn="l">
+              <a:defRPr sz="1500" b="0">
+                <a:solidFill>
+                  <a:srgbClr val="14243A"/>
+                </a:solidFill>
+                <a:latin typeface="Malgun Gothic"/>
+                <a:ea typeface="Malgun Gothic"/>
+                <a:cs typeface="Malgun Gothic"/>
+              </a:defRPr>
+            </a:lvl9pPr>
+          </a:lstStyle>
           <a:p xmlns:a="http://schemas.openxmlformats.org/drawingml/2006/main">
             <a:pPr algn="l">
               <a:lnSpc>
                 <a:spcPct val="116000"/>
               </a:lnSpc>
               <a:buNone/>
-              <a:defRPr sz="1425" b="0">
-                <a:solidFill>
-                  <a:srgbClr val="1B2B4D"/>
+              <a:defRPr sz="1500" b="0">
+                <a:solidFill>
+                  <a:srgbClr val="14243A"/>
                 </a:solidFill>
                 <a:latin typeface="Malgun Gothic"/>
                 <a:ea typeface="Malgun Gothic"/>
@@ -1901,9 +2759,9 @@
               </a:defRPr>
             </a:pPr>
             <a:r>
-              <a:rPr sz="1425" b="0">
-                <a:solidFill>
-                  <a:srgbClr val="1B2B4D"/>
+              <a:rPr sz="1500" b="0">
+                <a:solidFill>
+                  <a:srgbClr val="14243A"/>
                 </a:solidFill>
                 <a:latin typeface="Malgun Gothic"/>
                 <a:ea typeface="Malgun Gothic"/>
@@ -1930,8 +2788,8 @@
         </p:nvSpPr>
         <p:spPr>
           <a:xfrm xmlns:a="http://schemas.openxmlformats.org/drawingml/2006/main">
-            <a:off x="685800" y="5448300"/>
-            <a:ext cx="914400" cy="285750"/>
+            <a:off x="609600" y="4981575"/>
+            <a:ext cx="904875" cy="314325"/>
           </a:xfrm>
           <a:prstGeom xmlns:a="http://schemas.openxmlformats.org/drawingml/2006/main" prst="rect">
             <a:avLst/>
@@ -1943,17 +2801,120 @@
           </a:ln>
         </p:spPr>
         <p:txBody>
-          <a:bodyPr xmlns:a="http://schemas.openxmlformats.org/drawingml/2006/main" wrap="square" lIns="0" tIns="0" rIns="0" bIns="0" anchor="t"/>
-          <a:lstStyle xmlns:a="http://schemas.openxmlformats.org/drawingml/2006/main"/>
+          <a:bodyPr xmlns:a="http://schemas.openxmlformats.org/drawingml/2006/main" wrap="square" lIns="0" tIns="0" rIns="0" bIns="0" anchor="t">
+            <a:noAutofit/>
+          </a:bodyPr>
+          <a:lstStyle xmlns:a="http://schemas.openxmlformats.org/drawingml/2006/main">
+            <a:defPPr algn="l">
+              <a:defRPr sz="1425" b="1">
+                <a:solidFill>
+                  <a:srgbClr val="2456D8"/>
+                </a:solidFill>
+                <a:latin typeface="Malgun Gothic"/>
+                <a:ea typeface="Malgun Gothic"/>
+                <a:cs typeface="Malgun Gothic"/>
+              </a:defRPr>
+            </a:defPPr>
+            <a:lvl1pPr algn="l">
+              <a:defRPr sz="1425" b="1">
+                <a:solidFill>
+                  <a:srgbClr val="2456D8"/>
+                </a:solidFill>
+                <a:latin typeface="Malgun Gothic"/>
+                <a:ea typeface="Malgun Gothic"/>
+                <a:cs typeface="Malgun Gothic"/>
+              </a:defRPr>
+            </a:lvl1pPr>
+            <a:lvl2pPr algn="l">
+              <a:defRPr sz="1425" b="1">
+                <a:solidFill>
+                  <a:srgbClr val="2456D8"/>
+                </a:solidFill>
+                <a:latin typeface="Malgun Gothic"/>
+                <a:ea typeface="Malgun Gothic"/>
+                <a:cs typeface="Malgun Gothic"/>
+              </a:defRPr>
+            </a:lvl2pPr>
+            <a:lvl3pPr algn="l">
+              <a:defRPr sz="1425" b="1">
+                <a:solidFill>
+                  <a:srgbClr val="2456D8"/>
+                </a:solidFill>
+                <a:latin typeface="Malgun Gothic"/>
+                <a:ea typeface="Malgun Gothic"/>
+                <a:cs typeface="Malgun Gothic"/>
+              </a:defRPr>
+            </a:lvl3pPr>
+            <a:lvl4pPr algn="l">
+              <a:defRPr sz="1425" b="1">
+                <a:solidFill>
+                  <a:srgbClr val="2456D8"/>
+                </a:solidFill>
+                <a:latin typeface="Malgun Gothic"/>
+                <a:ea typeface="Malgun Gothic"/>
+                <a:cs typeface="Malgun Gothic"/>
+              </a:defRPr>
+            </a:lvl4pPr>
+            <a:lvl5pPr algn="l">
+              <a:defRPr sz="1425" b="1">
+                <a:solidFill>
+                  <a:srgbClr val="2456D8"/>
+                </a:solidFill>
+                <a:latin typeface="Malgun Gothic"/>
+                <a:ea typeface="Malgun Gothic"/>
+                <a:cs typeface="Malgun Gothic"/>
+              </a:defRPr>
+            </a:lvl5pPr>
+            <a:lvl6pPr algn="l">
+              <a:defRPr sz="1425" b="1">
+                <a:solidFill>
+                  <a:srgbClr val="2456D8"/>
+                </a:solidFill>
+                <a:latin typeface="Malgun Gothic"/>
+                <a:ea typeface="Malgun Gothic"/>
+                <a:cs typeface="Malgun Gothic"/>
+              </a:defRPr>
+            </a:lvl6pPr>
+            <a:lvl7pPr algn="l">
+              <a:defRPr sz="1425" b="1">
+                <a:solidFill>
+                  <a:srgbClr val="2456D8"/>
+                </a:solidFill>
+                <a:latin typeface="Malgun Gothic"/>
+                <a:ea typeface="Malgun Gothic"/>
+                <a:cs typeface="Malgun Gothic"/>
+              </a:defRPr>
+            </a:lvl7pPr>
+            <a:lvl8pPr algn="l">
+              <a:defRPr sz="1425" b="1">
+                <a:solidFill>
+                  <a:srgbClr val="2456D8"/>
+                </a:solidFill>
+                <a:latin typeface="Malgun Gothic"/>
+                <a:ea typeface="Malgun Gothic"/>
+                <a:cs typeface="Malgun Gothic"/>
+              </a:defRPr>
+            </a:lvl8pPr>
+            <a:lvl9pPr algn="l">
+              <a:defRPr sz="1425" b="1">
+                <a:solidFill>
+                  <a:srgbClr val="2456D8"/>
+                </a:solidFill>
+                <a:latin typeface="Malgun Gothic"/>
+                <a:ea typeface="Malgun Gothic"/>
+                <a:cs typeface="Malgun Gothic"/>
+              </a:defRPr>
+            </a:lvl9pPr>
+          </a:lstStyle>
           <a:p xmlns:a="http://schemas.openxmlformats.org/drawingml/2006/main">
             <a:pPr algn="l">
               <a:lnSpc>
                 <a:spcPct val="112000"/>
               </a:lnSpc>
               <a:buNone/>
-              <a:defRPr sz="1275" b="1">
-                <a:solidFill>
-                  <a:srgbClr val="1238C8"/>
+              <a:defRPr sz="1425" b="1">
+                <a:solidFill>
+                  <a:srgbClr val="2456D8"/>
                 </a:solidFill>
                 <a:latin typeface="Malgun Gothic"/>
                 <a:ea typeface="Malgun Gothic"/>
@@ -1961,9 +2922,9 @@
               </a:defRPr>
             </a:pPr>
             <a:r>
-              <a:rPr sz="1275" b="1">
-                <a:solidFill>
-                  <a:srgbClr val="1238C8"/>
+              <a:rPr sz="1425" b="1">
+                <a:solidFill>
+                  <a:srgbClr val="2456D8"/>
                 </a:solidFill>
                 <a:latin typeface="Malgun Gothic"/>
                 <a:ea typeface="Malgun Gothic"/>
@@ -1990,8 +2951,8 @@
         </p:nvSpPr>
         <p:spPr>
           <a:xfrm xmlns:a="http://schemas.openxmlformats.org/drawingml/2006/main">
-            <a:off x="1695450" y="5438775"/>
-            <a:ext cx="5810250" cy="400050"/>
+            <a:off x="1628775" y="4972050"/>
+            <a:ext cx="6753225" cy="400050"/>
           </a:xfrm>
           <a:prstGeom xmlns:a="http://schemas.openxmlformats.org/drawingml/2006/main" prst="rect">
             <a:avLst/>
@@ -2003,17 +2964,120 @@
           </a:ln>
         </p:spPr>
         <p:txBody>
-          <a:bodyPr xmlns:a="http://schemas.openxmlformats.org/drawingml/2006/main" wrap="square" lIns="0" tIns="0" rIns="0" bIns="0" anchor="t"/>
-          <a:lstStyle xmlns:a="http://schemas.openxmlformats.org/drawingml/2006/main"/>
+          <a:bodyPr xmlns:a="http://schemas.openxmlformats.org/drawingml/2006/main" wrap="square" lIns="0" tIns="0" rIns="0" bIns="0" anchor="t">
+            <a:noAutofit/>
+          </a:bodyPr>
+          <a:lstStyle xmlns:a="http://schemas.openxmlformats.org/drawingml/2006/main">
+            <a:defPPr algn="l">
+              <a:defRPr sz="1500" b="0">
+                <a:solidFill>
+                  <a:srgbClr val="14243A"/>
+                </a:solidFill>
+                <a:latin typeface="Malgun Gothic"/>
+                <a:ea typeface="Malgun Gothic"/>
+                <a:cs typeface="Malgun Gothic"/>
+              </a:defRPr>
+            </a:defPPr>
+            <a:lvl1pPr algn="l">
+              <a:defRPr sz="1500" b="0">
+                <a:solidFill>
+                  <a:srgbClr val="14243A"/>
+                </a:solidFill>
+                <a:latin typeface="Malgun Gothic"/>
+                <a:ea typeface="Malgun Gothic"/>
+                <a:cs typeface="Malgun Gothic"/>
+              </a:defRPr>
+            </a:lvl1pPr>
+            <a:lvl2pPr algn="l">
+              <a:defRPr sz="1500" b="0">
+                <a:solidFill>
+                  <a:srgbClr val="14243A"/>
+                </a:solidFill>
+                <a:latin typeface="Malgun Gothic"/>
+                <a:ea typeface="Malgun Gothic"/>
+                <a:cs typeface="Malgun Gothic"/>
+              </a:defRPr>
+            </a:lvl2pPr>
+            <a:lvl3pPr algn="l">
+              <a:defRPr sz="1500" b="0">
+                <a:solidFill>
+                  <a:srgbClr val="14243A"/>
+                </a:solidFill>
+                <a:latin typeface="Malgun Gothic"/>
+                <a:ea typeface="Malgun Gothic"/>
+                <a:cs typeface="Malgun Gothic"/>
+              </a:defRPr>
+            </a:lvl3pPr>
+            <a:lvl4pPr algn="l">
+              <a:defRPr sz="1500" b="0">
+                <a:solidFill>
+                  <a:srgbClr val="14243A"/>
+                </a:solidFill>
+                <a:latin typeface="Malgun Gothic"/>
+                <a:ea typeface="Malgun Gothic"/>
+                <a:cs typeface="Malgun Gothic"/>
+              </a:defRPr>
+            </a:lvl4pPr>
+            <a:lvl5pPr algn="l">
+              <a:defRPr sz="1500" b="0">
+                <a:solidFill>
+                  <a:srgbClr val="14243A"/>
+                </a:solidFill>
+                <a:latin typeface="Malgun Gothic"/>
+                <a:ea typeface="Malgun Gothic"/>
+                <a:cs typeface="Malgun Gothic"/>
+              </a:defRPr>
+            </a:lvl5pPr>
+            <a:lvl6pPr algn="l">
+              <a:defRPr sz="1500" b="0">
+                <a:solidFill>
+                  <a:srgbClr val="14243A"/>
+                </a:solidFill>
+                <a:latin typeface="Malgun Gothic"/>
+                <a:ea typeface="Malgun Gothic"/>
+                <a:cs typeface="Malgun Gothic"/>
+              </a:defRPr>
+            </a:lvl6pPr>
+            <a:lvl7pPr algn="l">
+              <a:defRPr sz="1500" b="0">
+                <a:solidFill>
+                  <a:srgbClr val="14243A"/>
+                </a:solidFill>
+                <a:latin typeface="Malgun Gothic"/>
+                <a:ea typeface="Malgun Gothic"/>
+                <a:cs typeface="Malgun Gothic"/>
+              </a:defRPr>
+            </a:lvl7pPr>
+            <a:lvl8pPr algn="l">
+              <a:defRPr sz="1500" b="0">
+                <a:solidFill>
+                  <a:srgbClr val="14243A"/>
+                </a:solidFill>
+                <a:latin typeface="Malgun Gothic"/>
+                <a:ea typeface="Malgun Gothic"/>
+                <a:cs typeface="Malgun Gothic"/>
+              </a:defRPr>
+            </a:lvl8pPr>
+            <a:lvl9pPr algn="l">
+              <a:defRPr sz="1500" b="0">
+                <a:solidFill>
+                  <a:srgbClr val="14243A"/>
+                </a:solidFill>
+                <a:latin typeface="Malgun Gothic"/>
+                <a:ea typeface="Malgun Gothic"/>
+                <a:cs typeface="Malgun Gothic"/>
+              </a:defRPr>
+            </a:lvl9pPr>
+          </a:lstStyle>
           <a:p xmlns:a="http://schemas.openxmlformats.org/drawingml/2006/main">
             <a:pPr algn="l">
               <a:lnSpc>
                 <a:spcPct val="116000"/>
               </a:lnSpc>
               <a:buNone/>
-              <a:defRPr sz="1425" b="0">
-                <a:solidFill>
-                  <a:srgbClr val="1B2B4D"/>
+              <a:defRPr sz="1500" b="0">
+                <a:solidFill>
+                  <a:srgbClr val="14243A"/>
                 </a:solidFill>
                 <a:latin typeface="Malgun Gothic"/>
                 <a:ea typeface="Malgun Gothic"/>
@@ -2021,9 +3085,9 @@
               </a:defRPr>
             </a:pPr>
             <a:r>
-              <a:rPr sz="1425" b="0">
-                <a:solidFill>
-                  <a:srgbClr val="1B2B4D"/>
+              <a:rPr sz="1500" b="0">
+                <a:solidFill>
+                  <a:srgbClr val="14243A"/>
                 </a:solidFill>
                 <a:latin typeface="Malgun Gothic"/>
                 <a:ea typeface="Malgun Gothic"/>
@@ -2033,41 +3097,6 @@
             </a:r>
           </a:p>
         </p:txBody>
-      </p:sp>
-      <p:sp>
-        <p:nvSpPr>
-          <p:cNvPr id="17" name="goal-callout">
-            <a:extLst xmlns:a="http://schemas.openxmlformats.org/drawingml/2006/main">
-              <a:ext uri="{FF2B5EF4-FFF2-40B4-BE49-F238E27FC236}">
-                <a16:creationId xmlns:a16="http://schemas.microsoft.com/office/drawing/2014/main" id="{4746266F-4879-47C3-BDCA-5126763DCD92}"/>
-              </a:ext>
-            </a:extLst>
-          </p:cNvPr>
-          <p:cNvSpPr>
-            <a:spLocks xmlns:a="http://schemas.openxmlformats.org/drawingml/2006/main" noGrp="1"/>
-          </p:cNvSpPr>
-          <p:nvPr/>
-        </p:nvSpPr>
-        <p:spPr>
-          <a:xfrm xmlns:a="http://schemas.openxmlformats.org/drawingml/2006/main">
-            <a:off x="685800" y="6038850"/>
-            <a:ext cx="5905500" cy="361950"/>
-          </a:xfrm>
-          <a:prstGeom xmlns:a="http://schemas.openxmlformats.org/drawingml/2006/main" prst="roundRect">
-            <a:avLst>
-              <a:gd name="adj" fmla="val 21053"/>
-            </a:avLst>
-          </a:prstGeom>
-          <a:solidFill xmlns:a="http://schemas.openxmlformats.org/drawingml/2006/main">
-            <a:srgbClr val="071957"/>
-          </a:solidFill>
-          <a:ln xmlns:a="http://schemas.openxmlformats.org/drawingml/2006/main" w="0">
-            <a:solidFill>
-              <a:srgbClr val="071957"/>
-            </a:solidFill>
-            <a:prstDash val="solid"/>
-          </a:ln>
-        </p:spPr>
       </p:sp>
       <p:sp>
         <p:nvSpPr>
@@ -2085,8 +3114,8 @@
         </p:nvSpPr>
         <p:spPr>
           <a:xfrm xmlns:a="http://schemas.openxmlformats.org/drawingml/2006/main">
-            <a:off x="876300" y="6134100"/>
-            <a:ext cx="5524500" cy="190500"/>
+            <a:off x="609600" y="5972175"/>
+            <a:ext cx="7905750" cy="476250"/>
           </a:xfrm>
           <a:prstGeom xmlns:a="http://schemas.openxmlformats.org/drawingml/2006/main" prst="rect">
             <a:avLst/>
@@ -2098,17 +3127,120 @@
           </a:ln>
         </p:spPr>
         <p:txBody>
-          <a:bodyPr xmlns:a="http://schemas.openxmlformats.org/drawingml/2006/main" wrap="square" lIns="0" tIns="0" rIns="0" bIns="0" anchor="t"/>
-          <a:lstStyle xmlns:a="http://schemas.openxmlformats.org/drawingml/2006/main"/>
+          <a:bodyPr xmlns:a="http://schemas.openxmlformats.org/drawingml/2006/main" wrap="square" lIns="0" tIns="0" rIns="0" bIns="0" anchor="t">
+            <a:noAutofit/>
+          </a:bodyPr>
+          <a:lstStyle xmlns:a="http://schemas.openxmlformats.org/drawingml/2006/main">
+            <a:defPPr algn="l">
+              <a:defRPr sz="1350" b="0">
+                <a:solidFill>
+                  <a:srgbClr val="14243A"/>
+                </a:solidFill>
+                <a:latin typeface="Malgun Gothic"/>
+                <a:ea typeface="Malgun Gothic"/>
+                <a:cs typeface="Malgun Gothic"/>
+              </a:defRPr>
+            </a:defPPr>
+            <a:lvl1pPr algn="l">
+              <a:defRPr sz="1350" b="0">
+                <a:solidFill>
+                  <a:srgbClr val="14243A"/>
+                </a:solidFill>
+                <a:latin typeface="Malgun Gothic"/>
+                <a:ea typeface="Malgun Gothic"/>
+                <a:cs typeface="Malgun Gothic"/>
+              </a:defRPr>
+            </a:lvl1pPr>
+            <a:lvl2pPr algn="l">
+              <a:defRPr sz="1350" b="0">
+                <a:solidFill>
+                  <a:srgbClr val="14243A"/>
+                </a:solidFill>
+                <a:latin typeface="Malgun Gothic"/>
+                <a:ea typeface="Malgun Gothic"/>
+                <a:cs typeface="Malgun Gothic"/>
+              </a:defRPr>
+            </a:lvl2pPr>
+            <a:lvl3pPr algn="l">
+              <a:defRPr sz="1350" b="0">
+                <a:solidFill>
+                  <a:srgbClr val="14243A"/>
+                </a:solidFill>
+                <a:latin typeface="Malgun Gothic"/>
+                <a:ea typeface="Malgun Gothic"/>
+                <a:cs typeface="Malgun Gothic"/>
+              </a:defRPr>
+            </a:lvl3pPr>
+            <a:lvl4pPr algn="l">
+              <a:defRPr sz="1350" b="0">
+                <a:solidFill>
+                  <a:srgbClr val="14243A"/>
+                </a:solidFill>
+                <a:latin typeface="Malgun Gothic"/>
+                <a:ea typeface="Malgun Gothic"/>
+                <a:cs typeface="Malgun Gothic"/>
+              </a:defRPr>
+            </a:lvl4pPr>
+            <a:lvl5pPr algn="l">
+              <a:defRPr sz="1350" b="0">
+                <a:solidFill>
+                  <a:srgbClr val="14243A"/>
+                </a:solidFill>
+                <a:latin typeface="Malgun Gothic"/>
+                <a:ea typeface="Malgun Gothic"/>
+                <a:cs typeface="Malgun Gothic"/>
+              </a:defRPr>
+            </a:lvl5pPr>
+            <a:lvl6pPr algn="l">
+              <a:defRPr sz="1350" b="0">
+                <a:solidFill>
+                  <a:srgbClr val="14243A"/>
+                </a:solidFill>
+                <a:latin typeface="Malgun Gothic"/>
+                <a:ea typeface="Malgun Gothic"/>
+                <a:cs typeface="Malgun Gothic"/>
+              </a:defRPr>
+            </a:lvl6pPr>
+            <a:lvl7pPr algn="l">
+              <a:defRPr sz="1350" b="0">
+                <a:solidFill>
+                  <a:srgbClr val="14243A"/>
+                </a:solidFill>
+                <a:latin typeface="Malgun Gothic"/>
+                <a:ea typeface="Malgun Gothic"/>
+                <a:cs typeface="Malgun Gothic"/>
+              </a:defRPr>
+            </a:lvl7pPr>
+            <a:lvl8pPr algn="l">
+              <a:defRPr sz="1350" b="0">
+                <a:solidFill>
+                  <a:srgbClr val="14243A"/>
+                </a:solidFill>
+                <a:latin typeface="Malgun Gothic"/>
+                <a:ea typeface="Malgun Gothic"/>
+                <a:cs typeface="Malgun Gothic"/>
+              </a:defRPr>
+            </a:lvl8pPr>
+            <a:lvl9pPr algn="l">
+              <a:defRPr sz="1350" b="0">
+                <a:solidFill>
+                  <a:srgbClr val="14243A"/>
+                </a:solidFill>
+                <a:latin typeface="Malgun Gothic"/>
+                <a:ea typeface="Malgun Gothic"/>
+                <a:cs typeface="Malgun Gothic"/>
+              </a:defRPr>
+            </a:lvl9pPr>
+          </a:lstStyle>
           <a:p xmlns:a="http://schemas.openxmlformats.org/drawingml/2006/main">
             <a:pPr algn="l">
               <a:lnSpc>
                 <a:spcPct val="112000"/>
               </a:lnSpc>
               <a:buNone/>
-              <a:defRPr sz="1200" b="1">
-                <a:solidFill>
-                  <a:srgbClr val="FFFFFF"/>
+              <a:defRPr sz="1350" b="0">
+                <a:solidFill>
+                  <a:srgbClr val="14243A"/>
                 </a:solidFill>
                 <a:latin typeface="Malgun Gothic"/>
                 <a:ea typeface="Malgun Gothic"/>
@@ -2116,9 +3248,9 @@
               </a:defRPr>
             </a:pPr>
             <a:r>
-              <a:rPr sz="1200" b="1">
-                <a:solidFill>
-                  <a:srgbClr val="FFFFFF"/>
+              <a:rPr sz="1350" b="0">
+                <a:solidFill>
+                  <a:srgbClr val="14243A"/>
                 </a:solidFill>
                 <a:latin typeface="Malgun Gothic"/>
                 <a:ea typeface="Malgun Gothic"/>
@@ -2145,49 +3277,50 @@
         </p:nvSpPr>
         <p:spPr>
           <a:xfrm xmlns:a="http://schemas.openxmlformats.org/drawingml/2006/main">
-            <a:off x="10172700" y="4724400"/>
-            <a:ext cx="1352550" cy="1581150"/>
+            <a:off x="9496425" y="4562475"/>
+            <a:ext cx="1504950" cy="1504950"/>
           </a:xfrm>
-          <a:prstGeom xmlns:a="http://schemas.openxmlformats.org/drawingml/2006/main" prst="roundRect">
+          <a:prstGeom xmlns:a="http://schemas.openxmlformats.org/drawingml/2006/main" prst="rect">
             <a:avLst>
               <a:gd name="adj" fmla="val 5634"/>
             </a:avLst>
           </a:prstGeom>
           <a:solidFill xmlns:a="http://schemas.openxmlformats.org/drawingml/2006/main">
-            <a:srgbClr val="FFFFFF">
-              <a:alpha val="96000"/>
-            </a:srgbClr>
+            <a:srgbClr val="FFFFFF"/>
           </a:solidFill>
-          <a:ln xmlns:a="http://schemas.openxmlformats.org/drawingml/2006/main" w="11430">
-            <a:solidFill>
-              <a:srgbClr val="D8E3F7"/>
-            </a:solidFill>
-            <a:prstDash val="solid"/>
+          <a:ln xmlns:a="http://schemas.openxmlformats.org/drawingml/2006/main" w="0">
+            <a:noFill/>
           </a:ln>
         </p:spPr>
         <p:style>
           <a:lnRef xmlns:a="http://schemas.openxmlformats.org/drawingml/2006/main" idx="0"/>
           <a:fillRef xmlns:a="http://schemas.openxmlformats.org/drawingml/2006/main" idx="0"/>
-          <a:effectRef xmlns:a="http://schemas.openxmlformats.org/drawingml/2006/main" idx="4"/>
+          <a:effectRef xmlns:a="http://schemas.openxmlformats.org/drawingml/2006/main" idx="0"/>
           <a:fontRef xmlns:a="http://schemas.openxmlformats.org/drawingml/2006/main" idx="major"/>
         </p:style>
       </p:sp>
       <p:pic>
         <p:nvPicPr>
-          <p:cNvPr id="44" name=""/>
+          <p:cNvPr id="44" name="">
+            <a:extLst xmlns:a="http://schemas.openxmlformats.org/drawingml/2006/main">
+              <a:ext uri="{FF2B5EF4-FFF2-40B4-BE49-F238E27FC236}">
+                <a16:creationId xmlns:a16="http://schemas.microsoft.com/office/drawing/2014/main" id="{725BE0BA-37AC-486D-9313-5DD0277904AC}"/>
+              </a:ext>
+            </a:extLst>
+          </p:cNvPr>
           <p:cNvPicPr>
             <a:picLocks xmlns:a="http://schemas.openxmlformats.org/drawingml/2006/main" noChangeAspect="1"/>
           </p:cNvPicPr>
           <p:nvPr/>
         </p:nvPicPr>
         <p:blipFill>
-          <a:blip xmlns:r="http://schemas.openxmlformats.org/officeDocument/2006/relationships" xmlns:a="http://schemas.openxmlformats.org/drawingml/2006/main" r:embed="R97d83baf00734dad"/>
+          <a:blip xmlns:r="http://schemas.openxmlformats.org/officeDocument/2006/relationships" xmlns:a="http://schemas.openxmlformats.org/drawingml/2006/main" r:embed="R8ed3116fbee44256"/>
           <a:stretch xmlns:a="http://schemas.openxmlformats.org/drawingml/2006/main"/>
         </p:blipFill>
         <p:spPr>
           <a:xfrm xmlns:a="http://schemas.openxmlformats.org/drawingml/2006/main">
-            <a:off x="10306050" y="4838700"/>
-            <a:ext cx="1085850" cy="1085850"/>
+            <a:off x="9601200" y="4667250"/>
+            <a:ext cx="1295400" cy="1295400"/>
           </a:xfrm>
           <a:prstGeom xmlns:a="http://schemas.openxmlformats.org/drawingml/2006/main" prst="rect">
             <a:avLst/>
@@ -2210,8 +3343,8 @@
         </p:nvSpPr>
         <p:spPr>
           <a:xfrm xmlns:a="http://schemas.openxmlformats.org/drawingml/2006/main">
-            <a:off x="10267950" y="5991225"/>
-            <a:ext cx="1162050" cy="190500"/>
+            <a:off x="9201150" y="6115050"/>
+            <a:ext cx="2095500" cy="228600"/>
           </a:xfrm>
           <a:prstGeom xmlns:a="http://schemas.openxmlformats.org/drawingml/2006/main" prst="rect">
             <a:avLst/>
@@ -2223,17 +3356,120 @@
           </a:ln>
         </p:spPr>
         <p:txBody>
-          <a:bodyPr xmlns:a="http://schemas.openxmlformats.org/drawingml/2006/main" wrap="square" lIns="0" tIns="0" rIns="0" bIns="0" anchor="t"/>
-          <a:lstStyle xmlns:a="http://schemas.openxmlformats.org/drawingml/2006/main"/>
+          <a:bodyPr xmlns:a="http://schemas.openxmlformats.org/drawingml/2006/main" wrap="square" lIns="0" tIns="0" rIns="0" bIns="0" anchor="t">
+            <a:noAutofit/>
+          </a:bodyPr>
+          <a:lstStyle xmlns:a="http://schemas.openxmlformats.org/drawingml/2006/main">
+            <a:defPPr algn="ctr">
+              <a:defRPr sz="1125" b="1">
+                <a:solidFill>
+                  <a:srgbClr val="14243A"/>
+                </a:solidFill>
+                <a:latin typeface="Malgun Gothic"/>
+                <a:ea typeface="Malgun Gothic"/>
+                <a:cs typeface="Malgun Gothic"/>
+              </a:defRPr>
+            </a:defPPr>
+            <a:lvl1pPr algn="ctr">
+              <a:defRPr sz="1125" b="1">
+                <a:solidFill>
+                  <a:srgbClr val="14243A"/>
+                </a:solidFill>
+                <a:latin typeface="Malgun Gothic"/>
+                <a:ea typeface="Malgun Gothic"/>
+                <a:cs typeface="Malgun Gothic"/>
+              </a:defRPr>
+            </a:lvl1pPr>
+            <a:lvl2pPr algn="ctr">
+              <a:defRPr sz="1125" b="1">
+                <a:solidFill>
+                  <a:srgbClr val="14243A"/>
+                </a:solidFill>
+                <a:latin typeface="Malgun Gothic"/>
+                <a:ea typeface="Malgun Gothic"/>
+                <a:cs typeface="Malgun Gothic"/>
+              </a:defRPr>
+            </a:lvl2pPr>
+            <a:lvl3pPr algn="ctr">
+              <a:defRPr sz="1125" b="1">
+                <a:solidFill>
+                  <a:srgbClr val="14243A"/>
+                </a:solidFill>
+                <a:latin typeface="Malgun Gothic"/>
+                <a:ea typeface="Malgun Gothic"/>
+                <a:cs typeface="Malgun Gothic"/>
+              </a:defRPr>
+            </a:lvl3pPr>
+            <a:lvl4pPr algn="ctr">
+              <a:defRPr sz="1125" b="1">
+                <a:solidFill>
+                  <a:srgbClr val="14243A"/>
+                </a:solidFill>
+                <a:latin typeface="Malgun Gothic"/>
+                <a:ea typeface="Malgun Gothic"/>
+                <a:cs typeface="Malgun Gothic"/>
+              </a:defRPr>
+            </a:lvl4pPr>
+            <a:lvl5pPr algn="ctr">
+              <a:defRPr sz="1125" b="1">
+                <a:solidFill>
+                  <a:srgbClr val="14243A"/>
+                </a:solidFill>
+                <a:latin typeface="Malgun Gothic"/>
+                <a:ea typeface="Malgun Gothic"/>
+                <a:cs typeface="Malgun Gothic"/>
+              </a:defRPr>
+            </a:lvl5pPr>
+            <a:lvl6pPr algn="ctr">
+              <a:defRPr sz="1125" b="1">
+                <a:solidFill>
+                  <a:srgbClr val="14243A"/>
+                </a:solidFill>
+                <a:latin typeface="Malgun Gothic"/>
+                <a:ea typeface="Malgun Gothic"/>
+                <a:cs typeface="Malgun Gothic"/>
+              </a:defRPr>
+            </a:lvl6pPr>
+            <a:lvl7pPr algn="ctr">
+              <a:defRPr sz="1125" b="1">
+                <a:solidFill>
+                  <a:srgbClr val="14243A"/>
+                </a:solidFill>
+                <a:latin typeface="Malgun Gothic"/>
+                <a:ea typeface="Malgun Gothic"/>
+                <a:cs typeface="Malgun Gothic"/>
+              </a:defRPr>
+            </a:lvl7pPr>
+            <a:lvl8pPr algn="ctr">
+              <a:defRPr sz="1125" b="1">
+                <a:solidFill>
+                  <a:srgbClr val="14243A"/>
+                </a:solidFill>
+                <a:latin typeface="Malgun Gothic"/>
+                <a:ea typeface="Malgun Gothic"/>
+                <a:cs typeface="Malgun Gothic"/>
+              </a:defRPr>
+            </a:lvl8pPr>
+            <a:lvl9pPr algn="ctr">
+              <a:defRPr sz="1125" b="1">
+                <a:solidFill>
+                  <a:srgbClr val="14243A"/>
+                </a:solidFill>
+                <a:latin typeface="Malgun Gothic"/>
+                <a:ea typeface="Malgun Gothic"/>
+                <a:cs typeface="Malgun Gothic"/>
+              </a:defRPr>
+            </a:lvl9pPr>
+          </a:lstStyle>
           <a:p xmlns:a="http://schemas.openxmlformats.org/drawingml/2006/main">
             <a:pPr algn="ctr">
               <a:lnSpc>
                 <a:spcPct val="112000"/>
               </a:lnSpc>
               <a:buNone/>
-              <a:defRPr sz="975" b="1">
-                <a:solidFill>
-                  <a:srgbClr val="081A4F"/>
+              <a:defRPr sz="1125" b="1">
+                <a:solidFill>
+                  <a:srgbClr val="14243A"/>
                 </a:solidFill>
                 <a:latin typeface="Malgun Gothic"/>
                 <a:ea typeface="Malgun Gothic"/>
@@ -2241,9 +3477,9 @@
               </a:defRPr>
             </a:pPr>
             <a:r>
-              <a:rPr sz="975" b="1">
-                <a:solidFill>
-                  <a:srgbClr val="081A4F"/>
+              <a:rPr sz="1125" b="1">
+                <a:solidFill>
+                  <a:srgbClr val="14243A"/>
                 </a:solidFill>
                 <a:latin typeface="Malgun Gothic"/>
                 <a:ea typeface="Malgun Gothic"/>
@@ -2270,8 +3506,8 @@
         </p:nvSpPr>
         <p:spPr>
           <a:xfrm xmlns:a="http://schemas.openxmlformats.org/drawingml/2006/main">
-            <a:off x="10182225" y="6172200"/>
-            <a:ext cx="1333500" cy="152400"/>
+            <a:off x="9086850" y="6381750"/>
+            <a:ext cx="2324100" cy="180975"/>
           </a:xfrm>
           <a:prstGeom xmlns:a="http://schemas.openxmlformats.org/drawingml/2006/main" prst="rect">
             <a:avLst/>
@@ -2283,33 +3519,796 @@
           </a:ln>
         </p:spPr>
         <p:txBody>
-          <a:bodyPr xmlns:a="http://schemas.openxmlformats.org/drawingml/2006/main" wrap="square" lIns="0" tIns="0" rIns="0" bIns="0" anchor="t"/>
-          <a:lstStyle xmlns:a="http://schemas.openxmlformats.org/drawingml/2006/main"/>
+          <a:bodyPr xmlns:a="http://schemas.openxmlformats.org/drawingml/2006/main" wrap="square" lIns="0" tIns="0" rIns="0" bIns="0" anchor="t">
+            <a:noAutofit/>
+          </a:bodyPr>
+          <a:lstStyle xmlns:a="http://schemas.openxmlformats.org/drawingml/2006/main">
+            <a:defPPr algn="ctr">
+              <a:defRPr sz="900" b="0">
+                <a:solidFill>
+                  <a:srgbClr val="14243A"/>
+                </a:solidFill>
+                <a:latin typeface="Segoe UI"/>
+                <a:ea typeface="Segoe UI"/>
+                <a:cs typeface="Segoe UI"/>
+              </a:defRPr>
+            </a:defPPr>
+            <a:lvl1pPr algn="ctr">
+              <a:defRPr sz="900" b="0">
+                <a:solidFill>
+                  <a:srgbClr val="14243A"/>
+                </a:solidFill>
+                <a:latin typeface="Segoe UI"/>
+                <a:ea typeface="Segoe UI"/>
+                <a:cs typeface="Segoe UI"/>
+              </a:defRPr>
+            </a:lvl1pPr>
+            <a:lvl2pPr algn="ctr">
+              <a:defRPr sz="900" b="0">
+                <a:solidFill>
+                  <a:srgbClr val="14243A"/>
+                </a:solidFill>
+                <a:latin typeface="Segoe UI"/>
+                <a:ea typeface="Segoe UI"/>
+                <a:cs typeface="Segoe UI"/>
+              </a:defRPr>
+            </a:lvl2pPr>
+            <a:lvl3pPr algn="ctr">
+              <a:defRPr sz="900" b="0">
+                <a:solidFill>
+                  <a:srgbClr val="14243A"/>
+                </a:solidFill>
+                <a:latin typeface="Segoe UI"/>
+                <a:ea typeface="Segoe UI"/>
+                <a:cs typeface="Segoe UI"/>
+              </a:defRPr>
+            </a:lvl3pPr>
+            <a:lvl4pPr algn="ctr">
+              <a:defRPr sz="900" b="0">
+                <a:solidFill>
+                  <a:srgbClr val="14243A"/>
+                </a:solidFill>
+                <a:latin typeface="Segoe UI"/>
+                <a:ea typeface="Segoe UI"/>
+                <a:cs typeface="Segoe UI"/>
+              </a:defRPr>
+            </a:lvl4pPr>
+            <a:lvl5pPr algn="ctr">
+              <a:defRPr sz="900" b="0">
+                <a:solidFill>
+                  <a:srgbClr val="14243A"/>
+                </a:solidFill>
+                <a:latin typeface="Segoe UI"/>
+                <a:ea typeface="Segoe UI"/>
+                <a:cs typeface="Segoe UI"/>
+              </a:defRPr>
+            </a:lvl5pPr>
+            <a:lvl6pPr algn="ctr">
+              <a:defRPr sz="900" b="0">
+                <a:solidFill>
+                  <a:srgbClr val="14243A"/>
+                </a:solidFill>
+                <a:latin typeface="Segoe UI"/>
+                <a:ea typeface="Segoe UI"/>
+                <a:cs typeface="Segoe UI"/>
+              </a:defRPr>
+            </a:lvl6pPr>
+            <a:lvl7pPr algn="ctr">
+              <a:defRPr sz="900" b="0">
+                <a:solidFill>
+                  <a:srgbClr val="14243A"/>
+                </a:solidFill>
+                <a:latin typeface="Segoe UI"/>
+                <a:ea typeface="Segoe UI"/>
+                <a:cs typeface="Segoe UI"/>
+              </a:defRPr>
+            </a:lvl7pPr>
+            <a:lvl8pPr algn="ctr">
+              <a:defRPr sz="900" b="0">
+                <a:solidFill>
+                  <a:srgbClr val="14243A"/>
+                </a:solidFill>
+                <a:latin typeface="Segoe UI"/>
+                <a:ea typeface="Segoe UI"/>
+                <a:cs typeface="Segoe UI"/>
+              </a:defRPr>
+            </a:lvl8pPr>
+            <a:lvl9pPr algn="ctr">
+              <a:defRPr sz="900" b="0">
+                <a:solidFill>
+                  <a:srgbClr val="14243A"/>
+                </a:solidFill>
+                <a:latin typeface="Segoe UI"/>
+                <a:ea typeface="Segoe UI"/>
+                <a:cs typeface="Segoe UI"/>
+              </a:defRPr>
+            </a:lvl9pPr>
+          </a:lstStyle>
           <a:p xmlns:a="http://schemas.openxmlformats.org/drawingml/2006/main">
             <a:pPr algn="ctr">
               <a:lnSpc>
                 <a:spcPct val="112000"/>
               </a:lnSpc>
               <a:buNone/>
-              <a:defRPr sz="638" b="0">
-                <a:solidFill>
-                  <a:srgbClr val="4D607D"/>
-                </a:solidFill>
-                <a:latin typeface="Malgun Gothic"/>
-                <a:ea typeface="Malgun Gothic"/>
-                <a:cs typeface="Malgun Gothic"/>
+              <a:defRPr sz="900" b="0">
+                <a:solidFill>
+                  <a:srgbClr val="14243A"/>
+                </a:solidFill>
+                <a:latin typeface="Segoe UI"/>
+                <a:ea typeface="Segoe UI"/>
+                <a:cs typeface="Segoe UI"/>
               </a:defRPr>
             </a:pPr>
             <a:r>
-              <a:rPr sz="638" b="0">
-                <a:solidFill>
-                  <a:srgbClr val="4D607D"/>
-                </a:solidFill>
-                <a:latin typeface="Malgun Gothic"/>
-                <a:ea typeface="Malgun Gothic"/>
-                <a:cs typeface="Malgun Gothic"/>
+              <a:rPr sz="900" b="0">
+                <a:solidFill>
+                  <a:srgbClr val="14243A"/>
+                </a:solidFill>
+                <a:latin typeface="Segoe UI"/>
+                <a:ea typeface="Segoe UI"/>
+                <a:cs typeface="Segoe UI"/>
               </a:rPr>
               <a:t>github.io/CHENGHAO-QUAN</a:t>
+            </a:r>
+          </a:p>
+        </p:txBody>
+      </p:sp>
+      <p:sp>
+        <p:nvSpPr>
+          <p:cNvPr id="45" name="approved-brand-line">
+            <a:extLst xmlns:a="http://schemas.openxmlformats.org/drawingml/2006/main">
+              <a:ext uri="{FF2B5EF4-FFF2-40B4-BE49-F238E27FC236}">
+                <a16:creationId xmlns:a16="http://schemas.microsoft.com/office/drawing/2014/main" id="{F5E6C5A3-1660-44F5-B4D5-6C7050D56A4F}"/>
+              </a:ext>
+            </a:extLst>
+          </p:cNvPr>
+          <p:cNvSpPr>
+            <a:spLocks xmlns:a="http://schemas.openxmlformats.org/drawingml/2006/main" noGrp="1"/>
+          </p:cNvSpPr>
+          <p:nvPr/>
+        </p:nvSpPr>
+        <p:spPr>
+          <a:xfrm xmlns:a="http://schemas.openxmlformats.org/drawingml/2006/main">
+            <a:off x="609600" y="1628775"/>
+            <a:ext cx="7810500" cy="419100"/>
+          </a:xfrm>
+          <a:prstGeom xmlns:a="http://schemas.openxmlformats.org/drawingml/2006/main" prst="rect">
+            <a:avLst/>
+          </a:prstGeom>
+          <a:noFill xmlns:a="http://schemas.openxmlformats.org/drawingml/2006/main"/>
+          <a:ln xmlns:a="http://schemas.openxmlformats.org/drawingml/2006/main" w="0">
+            <a:noFill/>
+          </a:ln>
+        </p:spPr>
+        <p:txBody>
+          <a:bodyPr xmlns:a="http://schemas.openxmlformats.org/drawingml/2006/main" wrap="square" lIns="0" tIns="0" rIns="0" bIns="0" anchor="t">
+            <a:noAutofit/>
+          </a:bodyPr>
+          <a:lstStyle xmlns:a="http://schemas.openxmlformats.org/drawingml/2006/main">
+            <a:defPPr algn="l">
+              <a:defRPr sz="2250" b="1">
+                <a:solidFill>
+                  <a:srgbClr val="2456D8"/>
+                </a:solidFill>
+                <a:latin typeface="Malgun Gothic"/>
+                <a:ea typeface="Malgun Gothic"/>
+                <a:cs typeface="Malgun Gothic"/>
+              </a:defRPr>
+            </a:defPPr>
+            <a:lvl1pPr algn="l">
+              <a:defRPr sz="2250" b="1">
+                <a:solidFill>
+                  <a:srgbClr val="2456D8"/>
+                </a:solidFill>
+                <a:latin typeface="Malgun Gothic"/>
+                <a:ea typeface="Malgun Gothic"/>
+                <a:cs typeface="Malgun Gothic"/>
+              </a:defRPr>
+            </a:lvl1pPr>
+            <a:lvl2pPr algn="l">
+              <a:defRPr sz="2250" b="1">
+                <a:solidFill>
+                  <a:srgbClr val="2456D8"/>
+                </a:solidFill>
+                <a:latin typeface="Malgun Gothic"/>
+                <a:ea typeface="Malgun Gothic"/>
+                <a:cs typeface="Malgun Gothic"/>
+              </a:defRPr>
+            </a:lvl2pPr>
+            <a:lvl3pPr algn="l">
+              <a:defRPr sz="2250" b="1">
+                <a:solidFill>
+                  <a:srgbClr val="2456D8"/>
+                </a:solidFill>
+                <a:latin typeface="Malgun Gothic"/>
+                <a:ea typeface="Malgun Gothic"/>
+                <a:cs typeface="Malgun Gothic"/>
+              </a:defRPr>
+            </a:lvl3pPr>
+            <a:lvl4pPr algn="l">
+              <a:defRPr sz="2250" b="1">
+                <a:solidFill>
+                  <a:srgbClr val="2456D8"/>
+                </a:solidFill>
+                <a:latin typeface="Malgun Gothic"/>
+                <a:ea typeface="Malgun Gothic"/>
+                <a:cs typeface="Malgun Gothic"/>
+              </a:defRPr>
+            </a:lvl4pPr>
+            <a:lvl5pPr algn="l">
+              <a:defRPr sz="2250" b="1">
+                <a:solidFill>
+                  <a:srgbClr val="2456D8"/>
+                </a:solidFill>
+                <a:latin typeface="Malgun Gothic"/>
+                <a:ea typeface="Malgun Gothic"/>
+                <a:cs typeface="Malgun Gothic"/>
+              </a:defRPr>
+            </a:lvl5pPr>
+            <a:lvl6pPr algn="l">
+              <a:defRPr sz="2250" b="1">
+                <a:solidFill>
+                  <a:srgbClr val="2456D8"/>
+                </a:solidFill>
+                <a:latin typeface="Malgun Gothic"/>
+                <a:ea typeface="Malgun Gothic"/>
+                <a:cs typeface="Malgun Gothic"/>
+              </a:defRPr>
+            </a:lvl6pPr>
+            <a:lvl7pPr algn="l">
+              <a:defRPr sz="2250" b="1">
+                <a:solidFill>
+                  <a:srgbClr val="2456D8"/>
+                </a:solidFill>
+                <a:latin typeface="Malgun Gothic"/>
+                <a:ea typeface="Malgun Gothic"/>
+                <a:cs typeface="Malgun Gothic"/>
+              </a:defRPr>
+            </a:lvl7pPr>
+            <a:lvl8pPr algn="l">
+              <a:defRPr sz="2250" b="1">
+                <a:solidFill>
+                  <a:srgbClr val="2456D8"/>
+                </a:solidFill>
+                <a:latin typeface="Malgun Gothic"/>
+                <a:ea typeface="Malgun Gothic"/>
+                <a:cs typeface="Malgun Gothic"/>
+              </a:defRPr>
+            </a:lvl8pPr>
+            <a:lvl9pPr algn="l">
+              <a:defRPr sz="2250" b="1">
+                <a:solidFill>
+                  <a:srgbClr val="2456D8"/>
+                </a:solidFill>
+                <a:latin typeface="Malgun Gothic"/>
+                <a:ea typeface="Malgun Gothic"/>
+                <a:cs typeface="Malgun Gothic"/>
+              </a:defRPr>
+            </a:lvl9pPr>
+          </a:lstStyle>
+          <a:p xmlns:a="http://schemas.openxmlformats.org/drawingml/2006/main">
+            <a:pPr algn="l">
+              <a:defRPr sz="2250" b="1">
+                <a:solidFill>
+                  <a:srgbClr val="2456D8"/>
+                </a:solidFill>
+                <a:latin typeface="Malgun Gothic"/>
+                <a:ea typeface="Malgun Gothic"/>
+                <a:cs typeface="Malgun Gothic"/>
+              </a:defRPr>
+            </a:pPr>
+            <a:r>
+              <a:rPr sz="2250" b="1">
+                <a:solidFill>
+                  <a:srgbClr val="2456D8"/>
+                </a:solidFill>
+                <a:latin typeface="Malgun Gothic"/>
+                <a:ea typeface="Malgun Gothic"/>
+                <a:cs typeface="Malgun Gothic"/>
+              </a:rPr>
+              <a:t>호기심을, 작동하는 시스템으로.</a:t>
+            </a:r>
+          </a:p>
+        </p:txBody>
+      </p:sp>
+      <p:sp>
+        <p:nvSpPr>
+          <p:cNvPr id="46" name="original-ambition">
+            <a:extLst xmlns:a="http://schemas.openxmlformats.org/drawingml/2006/main">
+              <a:ext uri="{FF2B5EF4-FFF2-40B4-BE49-F238E27FC236}">
+                <a16:creationId xmlns:a16="http://schemas.microsoft.com/office/drawing/2014/main" id="{E0A62D5B-2089-404F-85A1-7118A5F1B771}"/>
+              </a:ext>
+            </a:extLst>
+          </p:cNvPr>
+          <p:cNvSpPr>
+            <a:spLocks xmlns:a="http://schemas.openxmlformats.org/drawingml/2006/main" noGrp="1"/>
+          </p:cNvSpPr>
+          <p:nvPr/>
+        </p:nvSpPr>
+        <p:spPr>
+          <a:xfrm xmlns:a="http://schemas.openxmlformats.org/drawingml/2006/main">
+            <a:off x="609600" y="5562600"/>
+            <a:ext cx="7905750" cy="323850"/>
+          </a:xfrm>
+          <a:prstGeom xmlns:a="http://schemas.openxmlformats.org/drawingml/2006/main" prst="rect">
+            <a:avLst/>
+          </a:prstGeom>
+          <a:noFill xmlns:a="http://schemas.openxmlformats.org/drawingml/2006/main"/>
+          <a:ln xmlns:a="http://schemas.openxmlformats.org/drawingml/2006/main" w="0">
+            <a:noFill/>
+          </a:ln>
+        </p:spPr>
+        <p:txBody>
+          <a:bodyPr xmlns:a="http://schemas.openxmlformats.org/drawingml/2006/main" wrap="square" lIns="0" tIns="0" rIns="0" bIns="0" anchor="t">
+            <a:noAutofit/>
+          </a:bodyPr>
+          <a:lstStyle xmlns:a="http://schemas.openxmlformats.org/drawingml/2006/main">
+            <a:defPPr algn="l">
+              <a:defRPr sz="1500" b="1">
+                <a:solidFill>
+                  <a:srgbClr val="2456D8"/>
+                </a:solidFill>
+                <a:latin typeface="Malgun Gothic"/>
+                <a:ea typeface="Malgun Gothic"/>
+                <a:cs typeface="Malgun Gothic"/>
+              </a:defRPr>
+            </a:defPPr>
+            <a:lvl1pPr algn="l">
+              <a:defRPr sz="1500" b="1">
+                <a:solidFill>
+                  <a:srgbClr val="2456D8"/>
+                </a:solidFill>
+                <a:latin typeface="Malgun Gothic"/>
+                <a:ea typeface="Malgun Gothic"/>
+                <a:cs typeface="Malgun Gothic"/>
+              </a:defRPr>
+            </a:lvl1pPr>
+            <a:lvl2pPr algn="l">
+              <a:defRPr sz="1500" b="1">
+                <a:solidFill>
+                  <a:srgbClr val="2456D8"/>
+                </a:solidFill>
+                <a:latin typeface="Malgun Gothic"/>
+                <a:ea typeface="Malgun Gothic"/>
+                <a:cs typeface="Malgun Gothic"/>
+              </a:defRPr>
+            </a:lvl2pPr>
+            <a:lvl3pPr algn="l">
+              <a:defRPr sz="1500" b="1">
+                <a:solidFill>
+                  <a:srgbClr val="2456D8"/>
+                </a:solidFill>
+                <a:latin typeface="Malgun Gothic"/>
+                <a:ea typeface="Malgun Gothic"/>
+                <a:cs typeface="Malgun Gothic"/>
+              </a:defRPr>
+            </a:lvl3pPr>
+            <a:lvl4pPr algn="l">
+              <a:defRPr sz="1500" b="1">
+                <a:solidFill>
+                  <a:srgbClr val="2456D8"/>
+                </a:solidFill>
+                <a:latin typeface="Malgun Gothic"/>
+                <a:ea typeface="Malgun Gothic"/>
+                <a:cs typeface="Malgun Gothic"/>
+              </a:defRPr>
+            </a:lvl4pPr>
+            <a:lvl5pPr algn="l">
+              <a:defRPr sz="1500" b="1">
+                <a:solidFill>
+                  <a:srgbClr val="2456D8"/>
+                </a:solidFill>
+                <a:latin typeface="Malgun Gothic"/>
+                <a:ea typeface="Malgun Gothic"/>
+                <a:cs typeface="Malgun Gothic"/>
+              </a:defRPr>
+            </a:lvl5pPr>
+            <a:lvl6pPr algn="l">
+              <a:defRPr sz="1500" b="1">
+                <a:solidFill>
+                  <a:srgbClr val="2456D8"/>
+                </a:solidFill>
+                <a:latin typeface="Malgun Gothic"/>
+                <a:ea typeface="Malgun Gothic"/>
+                <a:cs typeface="Malgun Gothic"/>
+              </a:defRPr>
+            </a:lvl6pPr>
+            <a:lvl7pPr algn="l">
+              <a:defRPr sz="1500" b="1">
+                <a:solidFill>
+                  <a:srgbClr val="2456D8"/>
+                </a:solidFill>
+                <a:latin typeface="Malgun Gothic"/>
+                <a:ea typeface="Malgun Gothic"/>
+                <a:cs typeface="Malgun Gothic"/>
+              </a:defRPr>
+            </a:lvl7pPr>
+            <a:lvl8pPr algn="l">
+              <a:defRPr sz="1500" b="1">
+                <a:solidFill>
+                  <a:srgbClr val="2456D8"/>
+                </a:solidFill>
+                <a:latin typeface="Malgun Gothic"/>
+                <a:ea typeface="Malgun Gothic"/>
+                <a:cs typeface="Malgun Gothic"/>
+              </a:defRPr>
+            </a:lvl8pPr>
+            <a:lvl9pPr algn="l">
+              <a:defRPr sz="1500" b="1">
+                <a:solidFill>
+                  <a:srgbClr val="2456D8"/>
+                </a:solidFill>
+                <a:latin typeface="Malgun Gothic"/>
+                <a:ea typeface="Malgun Gothic"/>
+                <a:cs typeface="Malgun Gothic"/>
+              </a:defRPr>
+            </a:lvl9pPr>
+          </a:lstStyle>
+          <a:p xmlns:a="http://schemas.openxmlformats.org/drawingml/2006/main">
+            <a:pPr algn="l">
+              <a:defRPr sz="1500" b="1">
+                <a:solidFill>
+                  <a:srgbClr val="2456D8"/>
+                </a:solidFill>
+                <a:latin typeface="Malgun Gothic"/>
+                <a:ea typeface="Malgun Gothic"/>
+                <a:cs typeface="Malgun Gothic"/>
+              </a:defRPr>
+            </a:pPr>
+            <a:r>
+              <a:rPr sz="1500" b="1">
+                <a:solidFill>
+                  <a:srgbClr val="2456D8"/>
+                </a:solidFill>
+                <a:latin typeface="Malgun Gothic"/>
+                <a:ea typeface="Malgun Gothic"/>
+                <a:cs typeface="Malgun Gothic"/>
+              </a:rPr>
+              <a:t>AI 시대, 순찰 보안 로봇 Top 1을 향해</a:t>
+            </a:r>
+          </a:p>
+        </p:txBody>
+      </p:sp>
+      <p:pic>
+        <p:nvPicPr>
+          <p:cNvPr id="47" name="">
+            <a:extLst xmlns:a="http://schemas.openxmlformats.org/drawingml/2006/main">
+              <a:ext uri="{FF2B5EF4-FFF2-40B4-BE49-F238E27FC236}">
+                <a16:creationId xmlns:a16="http://schemas.microsoft.com/office/drawing/2014/main" id="{37697BC5-960A-4E0B-AA60-631304F377DA}"/>
+              </a:ext>
+            </a:extLst>
+          </p:cNvPr>
+          <p:cNvPicPr>
+            <a:picLocks xmlns:a="http://schemas.openxmlformats.org/drawingml/2006/main" noChangeAspect="1"/>
+          </p:cNvPicPr>
+          <p:nvPr/>
+        </p:nvPicPr>
+        <p:blipFill>
+          <a:blip xmlns:r="http://schemas.openxmlformats.org/officeDocument/2006/relationships" xmlns:a="http://schemas.openxmlformats.org/drawingml/2006/main" r:embed="R69cfb47b15364115"/>
+          <a:stretch xmlns:a="http://schemas.openxmlformats.org/drawingml/2006/main"/>
+        </p:blipFill>
+        <p:spPr>
+          <a:xfrm xmlns:a="http://schemas.openxmlformats.org/drawingml/2006/main">
+            <a:off x="8867775" y="577045"/>
+            <a:ext cx="2743200" cy="2884510"/>
+          </a:xfrm>
+          <a:prstGeom xmlns:a="http://schemas.openxmlformats.org/drawingml/2006/main" prst="rect">
+            <a:avLst/>
+          </a:prstGeom>
+        </p:spPr>
+      </p:pic>
+      <p:sp>
+        <p:nvSpPr>
+          <p:cNvPr id="48" name="nuri-caption">
+            <a:extLst xmlns:a="http://schemas.openxmlformats.org/drawingml/2006/main">
+              <a:ext uri="{FF2B5EF4-FFF2-40B4-BE49-F238E27FC236}">
+                <a16:creationId xmlns:a16="http://schemas.microsoft.com/office/drawing/2014/main" id="{62691218-1B5B-45B0-B3D2-A096FD89B07F}"/>
+              </a:ext>
+            </a:extLst>
+          </p:cNvPr>
+          <p:cNvSpPr>
+            <a:spLocks xmlns:a="http://schemas.openxmlformats.org/drawingml/2006/main" noGrp="1"/>
+          </p:cNvSpPr>
+          <p:nvPr/>
+        </p:nvSpPr>
+        <p:spPr>
+          <a:xfrm xmlns:a="http://schemas.openxmlformats.org/drawingml/2006/main">
+            <a:off x="8886825" y="3571875"/>
+            <a:ext cx="2705100" cy="266700"/>
+          </a:xfrm>
+          <a:prstGeom xmlns:a="http://schemas.openxmlformats.org/drawingml/2006/main" prst="rect">
+            <a:avLst/>
+          </a:prstGeom>
+          <a:noFill xmlns:a="http://schemas.openxmlformats.org/drawingml/2006/main"/>
+          <a:ln xmlns:a="http://schemas.openxmlformats.org/drawingml/2006/main" w="0">
+            <a:noFill/>
+          </a:ln>
+        </p:spPr>
+        <p:txBody>
+          <a:bodyPr xmlns:a="http://schemas.openxmlformats.org/drawingml/2006/main" wrap="square" lIns="0" tIns="0" rIns="0" bIns="0" anchor="t">
+            <a:noAutofit/>
+          </a:bodyPr>
+          <a:lstStyle xmlns:a="http://schemas.openxmlformats.org/drawingml/2006/main">
+            <a:defPPr algn="ctr">
+              <a:defRPr sz="1500" b="1">
+                <a:solidFill>
+                  <a:srgbClr val="14243A"/>
+                </a:solidFill>
+                <a:latin typeface="Segoe UI"/>
+                <a:ea typeface="Segoe UI"/>
+                <a:cs typeface="Segoe UI"/>
+              </a:defRPr>
+            </a:defPPr>
+            <a:lvl1pPr algn="ctr">
+              <a:defRPr sz="1500" b="1">
+                <a:solidFill>
+                  <a:srgbClr val="14243A"/>
+                </a:solidFill>
+                <a:latin typeface="Segoe UI"/>
+                <a:ea typeface="Segoe UI"/>
+                <a:cs typeface="Segoe UI"/>
+              </a:defRPr>
+            </a:lvl1pPr>
+            <a:lvl2pPr algn="ctr">
+              <a:defRPr sz="1500" b="1">
+                <a:solidFill>
+                  <a:srgbClr val="14243A"/>
+                </a:solidFill>
+                <a:latin typeface="Segoe UI"/>
+                <a:ea typeface="Segoe UI"/>
+                <a:cs typeface="Segoe UI"/>
+              </a:defRPr>
+            </a:lvl2pPr>
+            <a:lvl3pPr algn="ctr">
+              <a:defRPr sz="1500" b="1">
+                <a:solidFill>
+                  <a:srgbClr val="14243A"/>
+                </a:solidFill>
+                <a:latin typeface="Segoe UI"/>
+                <a:ea typeface="Segoe UI"/>
+                <a:cs typeface="Segoe UI"/>
+              </a:defRPr>
+            </a:lvl3pPr>
+            <a:lvl4pPr algn="ctr">
+              <a:defRPr sz="1500" b="1">
+                <a:solidFill>
+                  <a:srgbClr val="14243A"/>
+                </a:solidFill>
+                <a:latin typeface="Segoe UI"/>
+                <a:ea typeface="Segoe UI"/>
+                <a:cs typeface="Segoe UI"/>
+              </a:defRPr>
+            </a:lvl4pPr>
+            <a:lvl5pPr algn="ctr">
+              <a:defRPr sz="1500" b="1">
+                <a:solidFill>
+                  <a:srgbClr val="14243A"/>
+                </a:solidFill>
+                <a:latin typeface="Segoe UI"/>
+                <a:ea typeface="Segoe UI"/>
+                <a:cs typeface="Segoe UI"/>
+              </a:defRPr>
+            </a:lvl5pPr>
+            <a:lvl6pPr algn="ctr">
+              <a:defRPr sz="1500" b="1">
+                <a:solidFill>
+                  <a:srgbClr val="14243A"/>
+                </a:solidFill>
+                <a:latin typeface="Segoe UI"/>
+                <a:ea typeface="Segoe UI"/>
+                <a:cs typeface="Segoe UI"/>
+              </a:defRPr>
+            </a:lvl6pPr>
+            <a:lvl7pPr algn="ctr">
+              <a:defRPr sz="1500" b="1">
+                <a:solidFill>
+                  <a:srgbClr val="14243A"/>
+                </a:solidFill>
+                <a:latin typeface="Segoe UI"/>
+                <a:ea typeface="Segoe UI"/>
+                <a:cs typeface="Segoe UI"/>
+              </a:defRPr>
+            </a:lvl7pPr>
+            <a:lvl8pPr algn="ctr">
+              <a:defRPr sz="1500" b="1">
+                <a:solidFill>
+                  <a:srgbClr val="14243A"/>
+                </a:solidFill>
+                <a:latin typeface="Segoe UI"/>
+                <a:ea typeface="Segoe UI"/>
+                <a:cs typeface="Segoe UI"/>
+              </a:defRPr>
+            </a:lvl8pPr>
+            <a:lvl9pPr algn="ctr">
+              <a:defRPr sz="1500" b="1">
+                <a:solidFill>
+                  <a:srgbClr val="14243A"/>
+                </a:solidFill>
+                <a:latin typeface="Segoe UI"/>
+                <a:ea typeface="Segoe UI"/>
+                <a:cs typeface="Segoe UI"/>
+              </a:defRPr>
+            </a:lvl9pPr>
+          </a:lstStyle>
+          <a:p xmlns:a="http://schemas.openxmlformats.org/drawingml/2006/main">
+            <a:pPr algn="ctr">
+              <a:defRPr sz="1500" b="1">
+                <a:solidFill>
+                  <a:srgbClr val="14243A"/>
+                </a:solidFill>
+                <a:latin typeface="Segoe UI"/>
+                <a:ea typeface="Segoe UI"/>
+                <a:cs typeface="Segoe UI"/>
+              </a:defRPr>
+            </a:pPr>
+            <a:r>
+              <a:rPr sz="1500" b="1">
+                <a:solidFill>
+                  <a:srgbClr val="14243A"/>
+                </a:solidFill>
+                <a:latin typeface="Segoe UI"/>
+                <a:ea typeface="Segoe UI"/>
+                <a:cs typeface="Segoe UI"/>
+              </a:rPr>
+              <a:t>Nuri</a:t>
+            </a:r>
+          </a:p>
+        </p:txBody>
+      </p:sp>
+      <p:sp>
+        <p:nvSpPr>
+          <p:cNvPr id="49" name="community-caption">
+            <a:extLst xmlns:a="http://schemas.openxmlformats.org/drawingml/2006/main">
+              <a:ext uri="{FF2B5EF4-FFF2-40B4-BE49-F238E27FC236}">
+                <a16:creationId xmlns:a16="http://schemas.microsoft.com/office/drawing/2014/main" id="{92E1B6BA-3807-4E3A-A339-9EF564644433}"/>
+              </a:ext>
+            </a:extLst>
+          </p:cNvPr>
+          <p:cNvSpPr>
+            <a:spLocks xmlns:a="http://schemas.openxmlformats.org/drawingml/2006/main" noGrp="1"/>
+          </p:cNvSpPr>
+          <p:nvPr/>
+        </p:nvSpPr>
+        <p:spPr>
+          <a:xfrm xmlns:a="http://schemas.openxmlformats.org/drawingml/2006/main">
+            <a:off x="8648700" y="3905250"/>
+            <a:ext cx="3190875" cy="247650"/>
+          </a:xfrm>
+          <a:prstGeom xmlns:a="http://schemas.openxmlformats.org/drawingml/2006/main" prst="rect">
+            <a:avLst/>
+          </a:prstGeom>
+          <a:noFill xmlns:a="http://schemas.openxmlformats.org/drawingml/2006/main"/>
+          <a:ln xmlns:a="http://schemas.openxmlformats.org/drawingml/2006/main" w="0">
+            <a:noFill/>
+          </a:ln>
+        </p:spPr>
+        <p:txBody>
+          <a:bodyPr xmlns:a="http://schemas.openxmlformats.org/drawingml/2006/main" wrap="square" lIns="0" tIns="0" rIns="0" bIns="0" anchor="t">
+            <a:noAutofit/>
+          </a:bodyPr>
+          <a:lstStyle xmlns:a="http://schemas.openxmlformats.org/drawingml/2006/main">
+            <a:defPPr algn="ctr">
+              <a:defRPr sz="1200" b="0">
+                <a:solidFill>
+                  <a:srgbClr val="14243A"/>
+                </a:solidFill>
+                <a:latin typeface="Segoe UI"/>
+                <a:ea typeface="Segoe UI"/>
+                <a:cs typeface="Segoe UI"/>
+              </a:defRPr>
+            </a:defPPr>
+            <a:lvl1pPr algn="ctr">
+              <a:defRPr sz="1200" b="0">
+                <a:solidFill>
+                  <a:srgbClr val="14243A"/>
+                </a:solidFill>
+                <a:latin typeface="Segoe UI"/>
+                <a:ea typeface="Segoe UI"/>
+                <a:cs typeface="Segoe UI"/>
+              </a:defRPr>
+            </a:lvl1pPr>
+            <a:lvl2pPr algn="ctr">
+              <a:defRPr sz="1200" b="0">
+                <a:solidFill>
+                  <a:srgbClr val="14243A"/>
+                </a:solidFill>
+                <a:latin typeface="Segoe UI"/>
+                <a:ea typeface="Segoe UI"/>
+                <a:cs typeface="Segoe UI"/>
+              </a:defRPr>
+            </a:lvl2pPr>
+            <a:lvl3pPr algn="ctr">
+              <a:defRPr sz="1200" b="0">
+                <a:solidFill>
+                  <a:srgbClr val="14243A"/>
+                </a:solidFill>
+                <a:latin typeface="Segoe UI"/>
+                <a:ea typeface="Segoe UI"/>
+                <a:cs typeface="Segoe UI"/>
+              </a:defRPr>
+            </a:lvl3pPr>
+            <a:lvl4pPr algn="ctr">
+              <a:defRPr sz="1200" b="0">
+                <a:solidFill>
+                  <a:srgbClr val="14243A"/>
+                </a:solidFill>
+                <a:latin typeface="Segoe UI"/>
+                <a:ea typeface="Segoe UI"/>
+                <a:cs typeface="Segoe UI"/>
+              </a:defRPr>
+            </a:lvl4pPr>
+            <a:lvl5pPr algn="ctr">
+              <a:defRPr sz="1200" b="0">
+                <a:solidFill>
+                  <a:srgbClr val="14243A"/>
+                </a:solidFill>
+                <a:latin typeface="Segoe UI"/>
+                <a:ea typeface="Segoe UI"/>
+                <a:cs typeface="Segoe UI"/>
+              </a:defRPr>
+            </a:lvl5pPr>
+            <a:lvl6pPr algn="ctr">
+              <a:defRPr sz="1200" b="0">
+                <a:solidFill>
+                  <a:srgbClr val="14243A"/>
+                </a:solidFill>
+                <a:latin typeface="Segoe UI"/>
+                <a:ea typeface="Segoe UI"/>
+                <a:cs typeface="Segoe UI"/>
+              </a:defRPr>
+            </a:lvl6pPr>
+            <a:lvl7pPr algn="ctr">
+              <a:defRPr sz="1200" b="0">
+                <a:solidFill>
+                  <a:srgbClr val="14243A"/>
+                </a:solidFill>
+                <a:latin typeface="Segoe UI"/>
+                <a:ea typeface="Segoe UI"/>
+                <a:cs typeface="Segoe UI"/>
+              </a:defRPr>
+            </a:lvl7pPr>
+            <a:lvl8pPr algn="ctr">
+              <a:defRPr sz="1200" b="0">
+                <a:solidFill>
+                  <a:srgbClr val="14243A"/>
+                </a:solidFill>
+                <a:latin typeface="Segoe UI"/>
+                <a:ea typeface="Segoe UI"/>
+                <a:cs typeface="Segoe UI"/>
+              </a:defRPr>
+            </a:lvl8pPr>
+            <a:lvl9pPr algn="ctr">
+              <a:defRPr sz="1200" b="0">
+                <a:solidFill>
+                  <a:srgbClr val="14243A"/>
+                </a:solidFill>
+                <a:latin typeface="Segoe UI"/>
+                <a:ea typeface="Segoe UI"/>
+                <a:cs typeface="Segoe UI"/>
+              </a:defRPr>
+            </a:lvl9pPr>
+          </a:lstStyle>
+          <a:p xmlns:a="http://schemas.openxmlformats.org/drawingml/2006/main">
+            <a:pPr algn="ctr">
+              <a:defRPr sz="1200" b="0">
+                <a:solidFill>
+                  <a:srgbClr val="14243A"/>
+                </a:solidFill>
+                <a:latin typeface="Segoe UI"/>
+                <a:ea typeface="Segoe UI"/>
+                <a:cs typeface="Segoe UI"/>
+              </a:defRPr>
+            </a:pPr>
+            <a:r>
+              <a:rPr sz="1200" b="0">
+                <a:solidFill>
+                  <a:srgbClr val="14243A"/>
+                </a:solidFill>
+                <a:latin typeface="Segoe UI"/>
+                <a:ea typeface="Segoe UI"/>
+                <a:cs typeface="Segoe UI"/>
+              </a:rPr>
+              <a:t>Community: SUNSHINE STUDIO</a:t>
             </a:r>
           </a:p>
         </p:txBody>

</xml_diff>

<commit_message>
Pair QUAN CHENGHAO with Korean name across site and slides
</commit_message>
<xml_diff>
--- a/downloads/chenghao_physical_ai_self_intro.pptx
+++ b/downloads/chenghao_physical_ai_self_intro.pptx
@@ -2,13 +2,13 @@
 <file path=ppt/presentation.xml><?xml version="1.0" encoding="utf-8"?>
 <p:presentation xmlns:p="http://schemas.openxmlformats.org/presentationml/2006/main">
   <p:sldMasterIdLst>
-    <p:sldMasterId xmlns:r="http://schemas.openxmlformats.org/officeDocument/2006/relationships" id="2147483648" r:id="R9ff10edcb98146e8"/>
+    <p:sldMasterId xmlns:r="http://schemas.openxmlformats.org/officeDocument/2006/relationships" id="2147483648" r:id="Rbac27e975e1643a0"/>
   </p:sldMasterIdLst>
   <p:notesMasterIdLst>
-    <p:notesMasterId xmlns:r="http://schemas.openxmlformats.org/officeDocument/2006/relationships" r:id="R89443803f9c44697"/>
+    <p:notesMasterId xmlns:r="http://schemas.openxmlformats.org/officeDocument/2006/relationships" r:id="R10c3d3efe7fb44a0"/>
   </p:notesMasterIdLst>
   <p:sldIdLst>
-    <p:sldId xmlns:r="http://schemas.openxmlformats.org/officeDocument/2006/relationships" id="256" r:id="Rdd2d6a019a0948ac"/>
+    <p:sldId xmlns:r="http://schemas.openxmlformats.org/officeDocument/2006/relationships" id="256" r:id="Ra8433cd225b7489d"/>
   </p:sldIdLst>
   <p:sldSz cx="12192000" cy="6858000"/>
   <p:notesSz cx="6858000" cy="9144000"/>
@@ -565,7 +565,7 @@
   </p:cSld>
   <p:clrMap bg1="lt1" tx1="dk1" bg2="lt2" tx2="dk2" accent1="accent1" accent2="accent2" accent3="accent3" accent4="accent4" accent5="accent5" accent6="accent6" hlink="hlink" folHlink="folHlink"/>
   <p:sldLayoutIdLst>
-    <p:sldLayoutId xmlns:r="http://schemas.openxmlformats.org/officeDocument/2006/relationships" id="2147483649" r:id="R4e3d999abbab4d4b"/>
+    <p:sldLayoutId xmlns:r="http://schemas.openxmlformats.org/officeDocument/2006/relationships" id="2147483649" r:id="Rd0e841d6e49e4e8b"/>
   </p:sldLayoutIdLst>
   <p:txStyles>
     <p:titleStyle>
@@ -1155,6 +1155,7 @@
               </a:defRPr>
             </a:defPPr>
             <a:lvl1pPr algn="l">
+              <a:buNone/>
               <a:defRPr sz="1350" b="1">
                 <a:solidFill>
                   <a:srgbClr val="2456D8"/>
@@ -1165,6 +1166,7 @@
               </a:defRPr>
             </a:lvl1pPr>
             <a:lvl2pPr algn="l">
+              <a:buNone/>
               <a:defRPr sz="1350" b="1">
                 <a:solidFill>
                   <a:srgbClr val="2456D8"/>
@@ -1175,6 +1177,7 @@
               </a:defRPr>
             </a:lvl2pPr>
             <a:lvl3pPr algn="l">
+              <a:buNone/>
               <a:defRPr sz="1350" b="1">
                 <a:solidFill>
                   <a:srgbClr val="2456D8"/>
@@ -1185,6 +1188,7 @@
               </a:defRPr>
             </a:lvl3pPr>
             <a:lvl4pPr algn="l">
+              <a:buNone/>
               <a:defRPr sz="1350" b="1">
                 <a:solidFill>
                   <a:srgbClr val="2456D8"/>
@@ -1195,6 +1199,7 @@
               </a:defRPr>
             </a:lvl4pPr>
             <a:lvl5pPr algn="l">
+              <a:buNone/>
               <a:defRPr sz="1350" b="1">
                 <a:solidFill>
                   <a:srgbClr val="2456D8"/>
@@ -1205,6 +1210,7 @@
               </a:defRPr>
             </a:lvl5pPr>
             <a:lvl6pPr algn="l">
+              <a:buNone/>
               <a:defRPr sz="1350" b="1">
                 <a:solidFill>
                   <a:srgbClr val="2456D8"/>
@@ -1215,6 +1221,7 @@
               </a:defRPr>
             </a:lvl6pPr>
             <a:lvl7pPr algn="l">
+              <a:buNone/>
               <a:defRPr sz="1350" b="1">
                 <a:solidFill>
                   <a:srgbClr val="2456D8"/>
@@ -1225,6 +1232,7 @@
               </a:defRPr>
             </a:lvl7pPr>
             <a:lvl8pPr algn="l">
+              <a:buNone/>
               <a:defRPr sz="1350" b="1">
                 <a:solidFill>
                   <a:srgbClr val="2456D8"/>
@@ -1235,6 +1243,7 @@
               </a:defRPr>
             </a:lvl8pPr>
             <a:lvl9pPr algn="l">
+              <a:buNone/>
               <a:defRPr sz="1350" b="1">
                 <a:solidFill>
                   <a:srgbClr val="2456D8"/>
@@ -1318,6 +1327,7 @@
               </a:defRPr>
             </a:defPPr>
             <a:lvl1pPr algn="l">
+              <a:buNone/>
               <a:defRPr sz="4350" b="1">
                 <a:solidFill>
                   <a:srgbClr val="14243A"/>
@@ -1328,6 +1338,7 @@
               </a:defRPr>
             </a:lvl1pPr>
             <a:lvl2pPr algn="l">
+              <a:buNone/>
               <a:defRPr sz="4350" b="1">
                 <a:solidFill>
                   <a:srgbClr val="14243A"/>
@@ -1338,6 +1349,7 @@
               </a:defRPr>
             </a:lvl2pPr>
             <a:lvl3pPr algn="l">
+              <a:buNone/>
               <a:defRPr sz="4350" b="1">
                 <a:solidFill>
                   <a:srgbClr val="14243A"/>
@@ -1348,6 +1360,7 @@
               </a:defRPr>
             </a:lvl3pPr>
             <a:lvl4pPr algn="l">
+              <a:buNone/>
               <a:defRPr sz="4350" b="1">
                 <a:solidFill>
                   <a:srgbClr val="14243A"/>
@@ -1358,6 +1371,7 @@
               </a:defRPr>
             </a:lvl4pPr>
             <a:lvl5pPr algn="l">
+              <a:buNone/>
               <a:defRPr sz="4350" b="1">
                 <a:solidFill>
                   <a:srgbClr val="14243A"/>
@@ -1368,6 +1382,7 @@
               </a:defRPr>
             </a:lvl5pPr>
             <a:lvl6pPr algn="l">
+              <a:buNone/>
               <a:defRPr sz="4350" b="1">
                 <a:solidFill>
                   <a:srgbClr val="14243A"/>
@@ -1378,6 +1393,7 @@
               </a:defRPr>
             </a:lvl6pPr>
             <a:lvl7pPr algn="l">
+              <a:buNone/>
               <a:defRPr sz="4350" b="1">
                 <a:solidFill>
                   <a:srgbClr val="14243A"/>
@@ -1388,6 +1404,7 @@
               </a:defRPr>
             </a:lvl7pPr>
             <a:lvl8pPr algn="l">
+              <a:buNone/>
               <a:defRPr sz="4350" b="1">
                 <a:solidFill>
                   <a:srgbClr val="14243A"/>
@@ -1398,6 +1415,7 @@
               </a:defRPr>
             </a:lvl8pPr>
             <a:lvl9pPr algn="l">
+              <a:buNone/>
               <a:defRPr sz="4350" b="1">
                 <a:solidFill>
                   <a:srgbClr val="14243A"/>
@@ -1453,8 +1471,8 @@
         </p:nvSpPr>
         <p:spPr>
           <a:xfrm xmlns:a="http://schemas.openxmlformats.org/drawingml/2006/main">
-            <a:off x="609600" y="2181225"/>
-            <a:ext cx="8001000" cy="333375"/>
+            <a:off x="609600" y="2419350"/>
+            <a:ext cx="8001000" cy="304800"/>
           </a:xfrm>
           <a:prstGeom xmlns:a="http://schemas.openxmlformats.org/drawingml/2006/main" prst="rect">
             <a:avLst/>
@@ -1481,6 +1499,7 @@
               </a:defRPr>
             </a:defPPr>
             <a:lvl1pPr algn="l">
+              <a:buNone/>
               <a:defRPr sz="1575" b="1">
                 <a:solidFill>
                   <a:srgbClr val="14243A"/>
@@ -1491,6 +1510,7 @@
               </a:defRPr>
             </a:lvl1pPr>
             <a:lvl2pPr algn="l">
+              <a:buNone/>
               <a:defRPr sz="1575" b="1">
                 <a:solidFill>
                   <a:srgbClr val="14243A"/>
@@ -1501,6 +1521,7 @@
               </a:defRPr>
             </a:lvl2pPr>
             <a:lvl3pPr algn="l">
+              <a:buNone/>
               <a:defRPr sz="1575" b="1">
                 <a:solidFill>
                   <a:srgbClr val="14243A"/>
@@ -1511,6 +1532,7 @@
               </a:defRPr>
             </a:lvl3pPr>
             <a:lvl4pPr algn="l">
+              <a:buNone/>
               <a:defRPr sz="1575" b="1">
                 <a:solidFill>
                   <a:srgbClr val="14243A"/>
@@ -1521,6 +1543,7 @@
               </a:defRPr>
             </a:lvl4pPr>
             <a:lvl5pPr algn="l">
+              <a:buNone/>
               <a:defRPr sz="1575" b="1">
                 <a:solidFill>
                   <a:srgbClr val="14243A"/>
@@ -1531,6 +1554,7 @@
               </a:defRPr>
             </a:lvl5pPr>
             <a:lvl6pPr algn="l">
+              <a:buNone/>
               <a:defRPr sz="1575" b="1">
                 <a:solidFill>
                   <a:srgbClr val="14243A"/>
@@ -1541,6 +1565,7 @@
               </a:defRPr>
             </a:lvl6pPr>
             <a:lvl7pPr algn="l">
+              <a:buNone/>
               <a:defRPr sz="1575" b="1">
                 <a:solidFill>
                   <a:srgbClr val="14243A"/>
@@ -1551,6 +1576,7 @@
               </a:defRPr>
             </a:lvl7pPr>
             <a:lvl8pPr algn="l">
+              <a:buNone/>
               <a:defRPr sz="1575" b="1">
                 <a:solidFill>
                   <a:srgbClr val="14243A"/>
@@ -1561,6 +1587,7 @@
               </a:defRPr>
             </a:lvl8pPr>
             <a:lvl9pPr algn="l">
+              <a:buNone/>
               <a:defRPr sz="1575" b="1">
                 <a:solidFill>
                   <a:srgbClr val="14243A"/>
@@ -1595,7 +1622,7 @@
                 <a:ea typeface="Malgun Gothic"/>
                 <a:cs typeface="Malgun Gothic"/>
               </a:rPr>
-              <a:t>Dr. 권성호 (QUAN CHENGHAO)  |  Dogu Robotics · Dogu X</a:t>
+              <a:t>Dogu Robotics · Dogu X</a:t>
             </a:r>
           </a:p>
         </p:txBody>
@@ -1616,8 +1643,8 @@
         </p:nvSpPr>
         <p:spPr>
           <a:xfrm xmlns:a="http://schemas.openxmlformats.org/drawingml/2006/main">
-            <a:off x="609600" y="2647950"/>
-            <a:ext cx="7715250" cy="628650"/>
+            <a:off x="609600" y="2838450"/>
+            <a:ext cx="7715250" cy="590550"/>
           </a:xfrm>
           <a:prstGeom xmlns:a="http://schemas.openxmlformats.org/drawingml/2006/main" prst="rect">
             <a:avLst/>
@@ -1644,6 +1671,7 @@
               </a:defRPr>
             </a:defPPr>
             <a:lvl1pPr algn="l">
+              <a:buNone/>
               <a:defRPr sz="1500" b="0">
                 <a:solidFill>
                   <a:srgbClr val="14243A"/>
@@ -1654,6 +1682,7 @@
               </a:defRPr>
             </a:lvl1pPr>
             <a:lvl2pPr algn="l">
+              <a:buNone/>
               <a:defRPr sz="1500" b="0">
                 <a:solidFill>
                   <a:srgbClr val="14243A"/>
@@ -1664,6 +1693,7 @@
               </a:defRPr>
             </a:lvl2pPr>
             <a:lvl3pPr algn="l">
+              <a:buNone/>
               <a:defRPr sz="1500" b="0">
                 <a:solidFill>
                   <a:srgbClr val="14243A"/>
@@ -1674,6 +1704,7 @@
               </a:defRPr>
             </a:lvl3pPr>
             <a:lvl4pPr algn="l">
+              <a:buNone/>
               <a:defRPr sz="1500" b="0">
                 <a:solidFill>
                   <a:srgbClr val="14243A"/>
@@ -1684,6 +1715,7 @@
               </a:defRPr>
             </a:lvl4pPr>
             <a:lvl5pPr algn="l">
+              <a:buNone/>
               <a:defRPr sz="1500" b="0">
                 <a:solidFill>
                   <a:srgbClr val="14243A"/>
@@ -1694,6 +1726,7 @@
               </a:defRPr>
             </a:lvl5pPr>
             <a:lvl6pPr algn="l">
+              <a:buNone/>
               <a:defRPr sz="1500" b="0">
                 <a:solidFill>
                   <a:srgbClr val="14243A"/>
@@ -1704,6 +1737,7 @@
               </a:defRPr>
             </a:lvl6pPr>
             <a:lvl7pPr algn="l">
+              <a:buNone/>
               <a:defRPr sz="1500" b="0">
                 <a:solidFill>
                   <a:srgbClr val="14243A"/>
@@ -1714,6 +1748,7 @@
               </a:defRPr>
             </a:lvl7pPr>
             <a:lvl8pPr algn="l">
+              <a:buNone/>
               <a:defRPr sz="1500" b="0">
                 <a:solidFill>
                   <a:srgbClr val="14243A"/>
@@ -1724,6 +1759,7 @@
               </a:defRPr>
             </a:lvl8pPr>
             <a:lvl9pPr algn="l">
+              <a:buNone/>
               <a:defRPr sz="1500" b="0">
                 <a:solidFill>
                   <a:srgbClr val="14243A"/>
@@ -1779,7 +1815,7 @@
         </p:nvSpPr>
         <p:spPr>
           <a:xfrm xmlns:a="http://schemas.openxmlformats.org/drawingml/2006/main">
-            <a:off x="609600" y="3400425"/>
+            <a:off x="609600" y="3514725"/>
             <a:ext cx="7715250" cy="0"/>
           </a:xfrm>
           <a:prstGeom xmlns:a="http://schemas.openxmlformats.org/drawingml/2006/main" prst="line">
@@ -1810,7 +1846,7 @@
         </p:nvSpPr>
         <p:spPr>
           <a:xfrm xmlns:a="http://schemas.openxmlformats.org/drawingml/2006/main">
-            <a:off x="609600" y="3638550"/>
+            <a:off x="609600" y="3724275"/>
             <a:ext cx="904875" cy="314325"/>
           </a:xfrm>
           <a:prstGeom xmlns:a="http://schemas.openxmlformats.org/drawingml/2006/main" prst="rect">
@@ -1838,6 +1874,7 @@
               </a:defRPr>
             </a:defPPr>
             <a:lvl1pPr algn="l">
+              <a:buNone/>
               <a:defRPr sz="1425" b="1">
                 <a:solidFill>
                   <a:srgbClr val="2456D8"/>
@@ -1848,6 +1885,7 @@
               </a:defRPr>
             </a:lvl1pPr>
             <a:lvl2pPr algn="l">
+              <a:buNone/>
               <a:defRPr sz="1425" b="1">
                 <a:solidFill>
                   <a:srgbClr val="2456D8"/>
@@ -1858,6 +1896,7 @@
               </a:defRPr>
             </a:lvl2pPr>
             <a:lvl3pPr algn="l">
+              <a:buNone/>
               <a:defRPr sz="1425" b="1">
                 <a:solidFill>
                   <a:srgbClr val="2456D8"/>
@@ -1868,6 +1907,7 @@
               </a:defRPr>
             </a:lvl3pPr>
             <a:lvl4pPr algn="l">
+              <a:buNone/>
               <a:defRPr sz="1425" b="1">
                 <a:solidFill>
                   <a:srgbClr val="2456D8"/>
@@ -1878,6 +1918,7 @@
               </a:defRPr>
             </a:lvl4pPr>
             <a:lvl5pPr algn="l">
+              <a:buNone/>
               <a:defRPr sz="1425" b="1">
                 <a:solidFill>
                   <a:srgbClr val="2456D8"/>
@@ -1888,6 +1929,7 @@
               </a:defRPr>
             </a:lvl5pPr>
             <a:lvl6pPr algn="l">
+              <a:buNone/>
               <a:defRPr sz="1425" b="1">
                 <a:solidFill>
                   <a:srgbClr val="2456D8"/>
@@ -1898,6 +1940,7 @@
               </a:defRPr>
             </a:lvl6pPr>
             <a:lvl7pPr algn="l">
+              <a:buNone/>
               <a:defRPr sz="1425" b="1">
                 <a:solidFill>
                   <a:srgbClr val="2456D8"/>
@@ -1908,6 +1951,7 @@
               </a:defRPr>
             </a:lvl7pPr>
             <a:lvl8pPr algn="l">
+              <a:buNone/>
               <a:defRPr sz="1425" b="1">
                 <a:solidFill>
                   <a:srgbClr val="2456D8"/>
@@ -1918,6 +1962,7 @@
               </a:defRPr>
             </a:lvl8pPr>
             <a:lvl9pPr algn="l">
+              <a:buNone/>
               <a:defRPr sz="1425" b="1">
                 <a:solidFill>
                   <a:srgbClr val="2456D8"/>
@@ -1973,7 +2018,7 @@
         </p:nvSpPr>
         <p:spPr>
           <a:xfrm xmlns:a="http://schemas.openxmlformats.org/drawingml/2006/main">
-            <a:off x="1628775" y="3629025"/>
+            <a:off x="1628775" y="3714750"/>
             <a:ext cx="6753225" cy="400050"/>
           </a:xfrm>
           <a:prstGeom xmlns:a="http://schemas.openxmlformats.org/drawingml/2006/main" prst="rect">
@@ -2001,6 +2046,7 @@
               </a:defRPr>
             </a:defPPr>
             <a:lvl1pPr algn="l">
+              <a:buNone/>
               <a:defRPr sz="1500" b="0">
                 <a:solidFill>
                   <a:srgbClr val="14243A"/>
@@ -2011,6 +2057,7 @@
               </a:defRPr>
             </a:lvl1pPr>
             <a:lvl2pPr algn="l">
+              <a:buNone/>
               <a:defRPr sz="1500" b="0">
                 <a:solidFill>
                   <a:srgbClr val="14243A"/>
@@ -2021,6 +2068,7 @@
               </a:defRPr>
             </a:lvl2pPr>
             <a:lvl3pPr algn="l">
+              <a:buNone/>
               <a:defRPr sz="1500" b="0">
                 <a:solidFill>
                   <a:srgbClr val="14243A"/>
@@ -2031,6 +2079,7 @@
               </a:defRPr>
             </a:lvl3pPr>
             <a:lvl4pPr algn="l">
+              <a:buNone/>
               <a:defRPr sz="1500" b="0">
                 <a:solidFill>
                   <a:srgbClr val="14243A"/>
@@ -2041,6 +2090,7 @@
               </a:defRPr>
             </a:lvl4pPr>
             <a:lvl5pPr algn="l">
+              <a:buNone/>
               <a:defRPr sz="1500" b="0">
                 <a:solidFill>
                   <a:srgbClr val="14243A"/>
@@ -2051,6 +2101,7 @@
               </a:defRPr>
             </a:lvl5pPr>
             <a:lvl6pPr algn="l">
+              <a:buNone/>
               <a:defRPr sz="1500" b="0">
                 <a:solidFill>
                   <a:srgbClr val="14243A"/>
@@ -2061,6 +2112,7 @@
               </a:defRPr>
             </a:lvl6pPr>
             <a:lvl7pPr algn="l">
+              <a:buNone/>
               <a:defRPr sz="1500" b="0">
                 <a:solidFill>
                   <a:srgbClr val="14243A"/>
@@ -2071,6 +2123,7 @@
               </a:defRPr>
             </a:lvl7pPr>
             <a:lvl8pPr algn="l">
+              <a:buNone/>
               <a:defRPr sz="1500" b="0">
                 <a:solidFill>
                   <a:srgbClr val="14243A"/>
@@ -2081,6 +2134,7 @@
               </a:defRPr>
             </a:lvl8pPr>
             <a:lvl9pPr algn="l">
+              <a:buNone/>
               <a:defRPr sz="1500" b="0">
                 <a:solidFill>
                   <a:srgbClr val="14243A"/>
@@ -2136,7 +2190,7 @@
         </p:nvSpPr>
         <p:spPr>
           <a:xfrm xmlns:a="http://schemas.openxmlformats.org/drawingml/2006/main">
-            <a:off x="609600" y="4086225"/>
+            <a:off x="609600" y="4171950"/>
             <a:ext cx="904875" cy="314325"/>
           </a:xfrm>
           <a:prstGeom xmlns:a="http://schemas.openxmlformats.org/drawingml/2006/main" prst="rect">
@@ -2164,6 +2218,7 @@
               </a:defRPr>
             </a:defPPr>
             <a:lvl1pPr algn="l">
+              <a:buNone/>
               <a:defRPr sz="1425" b="1">
                 <a:solidFill>
                   <a:srgbClr val="2456D8"/>
@@ -2174,6 +2229,7 @@
               </a:defRPr>
             </a:lvl1pPr>
             <a:lvl2pPr algn="l">
+              <a:buNone/>
               <a:defRPr sz="1425" b="1">
                 <a:solidFill>
                   <a:srgbClr val="2456D8"/>
@@ -2184,6 +2240,7 @@
               </a:defRPr>
             </a:lvl2pPr>
             <a:lvl3pPr algn="l">
+              <a:buNone/>
               <a:defRPr sz="1425" b="1">
                 <a:solidFill>
                   <a:srgbClr val="2456D8"/>
@@ -2194,6 +2251,7 @@
               </a:defRPr>
             </a:lvl3pPr>
             <a:lvl4pPr algn="l">
+              <a:buNone/>
               <a:defRPr sz="1425" b="1">
                 <a:solidFill>
                   <a:srgbClr val="2456D8"/>
@@ -2204,6 +2262,7 @@
               </a:defRPr>
             </a:lvl4pPr>
             <a:lvl5pPr algn="l">
+              <a:buNone/>
               <a:defRPr sz="1425" b="1">
                 <a:solidFill>
                   <a:srgbClr val="2456D8"/>
@@ -2214,6 +2273,7 @@
               </a:defRPr>
             </a:lvl5pPr>
             <a:lvl6pPr algn="l">
+              <a:buNone/>
               <a:defRPr sz="1425" b="1">
                 <a:solidFill>
                   <a:srgbClr val="2456D8"/>
@@ -2224,6 +2284,7 @@
               </a:defRPr>
             </a:lvl6pPr>
             <a:lvl7pPr algn="l">
+              <a:buNone/>
               <a:defRPr sz="1425" b="1">
                 <a:solidFill>
                   <a:srgbClr val="2456D8"/>
@@ -2234,6 +2295,7 @@
               </a:defRPr>
             </a:lvl7pPr>
             <a:lvl8pPr algn="l">
+              <a:buNone/>
               <a:defRPr sz="1425" b="1">
                 <a:solidFill>
                   <a:srgbClr val="2456D8"/>
@@ -2244,6 +2306,7 @@
               </a:defRPr>
             </a:lvl8pPr>
             <a:lvl9pPr algn="l">
+              <a:buNone/>
               <a:defRPr sz="1425" b="1">
                 <a:solidFill>
                   <a:srgbClr val="2456D8"/>
@@ -2299,7 +2362,7 @@
         </p:nvSpPr>
         <p:spPr>
           <a:xfrm xmlns:a="http://schemas.openxmlformats.org/drawingml/2006/main">
-            <a:off x="1628775" y="4076700"/>
+            <a:off x="1628775" y="4162425"/>
             <a:ext cx="6753225" cy="400050"/>
           </a:xfrm>
           <a:prstGeom xmlns:a="http://schemas.openxmlformats.org/drawingml/2006/main" prst="rect">
@@ -2327,6 +2390,7 @@
               </a:defRPr>
             </a:defPPr>
             <a:lvl1pPr algn="l">
+              <a:buNone/>
               <a:defRPr sz="1500" b="0">
                 <a:solidFill>
                   <a:srgbClr val="14243A"/>
@@ -2337,6 +2401,7 @@
               </a:defRPr>
             </a:lvl1pPr>
             <a:lvl2pPr algn="l">
+              <a:buNone/>
               <a:defRPr sz="1500" b="0">
                 <a:solidFill>
                   <a:srgbClr val="14243A"/>
@@ -2347,6 +2412,7 @@
               </a:defRPr>
             </a:lvl2pPr>
             <a:lvl3pPr algn="l">
+              <a:buNone/>
               <a:defRPr sz="1500" b="0">
                 <a:solidFill>
                   <a:srgbClr val="14243A"/>
@@ -2357,6 +2423,7 @@
               </a:defRPr>
             </a:lvl3pPr>
             <a:lvl4pPr algn="l">
+              <a:buNone/>
               <a:defRPr sz="1500" b="0">
                 <a:solidFill>
                   <a:srgbClr val="14243A"/>
@@ -2367,6 +2434,7 @@
               </a:defRPr>
             </a:lvl4pPr>
             <a:lvl5pPr algn="l">
+              <a:buNone/>
               <a:defRPr sz="1500" b="0">
                 <a:solidFill>
                   <a:srgbClr val="14243A"/>
@@ -2377,6 +2445,7 @@
               </a:defRPr>
             </a:lvl5pPr>
             <a:lvl6pPr algn="l">
+              <a:buNone/>
               <a:defRPr sz="1500" b="0">
                 <a:solidFill>
                   <a:srgbClr val="14243A"/>
@@ -2387,6 +2456,7 @@
               </a:defRPr>
             </a:lvl6pPr>
             <a:lvl7pPr algn="l">
+              <a:buNone/>
               <a:defRPr sz="1500" b="0">
                 <a:solidFill>
                   <a:srgbClr val="14243A"/>
@@ -2397,6 +2467,7 @@
               </a:defRPr>
             </a:lvl7pPr>
             <a:lvl8pPr algn="l">
+              <a:buNone/>
               <a:defRPr sz="1500" b="0">
                 <a:solidFill>
                   <a:srgbClr val="14243A"/>
@@ -2407,6 +2478,7 @@
               </a:defRPr>
             </a:lvl8pPr>
             <a:lvl9pPr algn="l">
+              <a:buNone/>
               <a:defRPr sz="1500" b="0">
                 <a:solidFill>
                   <a:srgbClr val="14243A"/>
@@ -2462,7 +2534,7 @@
         </p:nvSpPr>
         <p:spPr>
           <a:xfrm xmlns:a="http://schemas.openxmlformats.org/drawingml/2006/main">
-            <a:off x="609600" y="4533900"/>
+            <a:off x="609600" y="4619625"/>
             <a:ext cx="904875" cy="314325"/>
           </a:xfrm>
           <a:prstGeom xmlns:a="http://schemas.openxmlformats.org/drawingml/2006/main" prst="rect">
@@ -2490,6 +2562,7 @@
               </a:defRPr>
             </a:defPPr>
             <a:lvl1pPr algn="l">
+              <a:buNone/>
               <a:defRPr sz="1425" b="1">
                 <a:solidFill>
                   <a:srgbClr val="2456D8"/>
@@ -2500,6 +2573,7 @@
               </a:defRPr>
             </a:lvl1pPr>
             <a:lvl2pPr algn="l">
+              <a:buNone/>
               <a:defRPr sz="1425" b="1">
                 <a:solidFill>
                   <a:srgbClr val="2456D8"/>
@@ -2510,6 +2584,7 @@
               </a:defRPr>
             </a:lvl2pPr>
             <a:lvl3pPr algn="l">
+              <a:buNone/>
               <a:defRPr sz="1425" b="1">
                 <a:solidFill>
                   <a:srgbClr val="2456D8"/>
@@ -2520,6 +2595,7 @@
               </a:defRPr>
             </a:lvl3pPr>
             <a:lvl4pPr algn="l">
+              <a:buNone/>
               <a:defRPr sz="1425" b="1">
                 <a:solidFill>
                   <a:srgbClr val="2456D8"/>
@@ -2530,6 +2606,7 @@
               </a:defRPr>
             </a:lvl4pPr>
             <a:lvl5pPr algn="l">
+              <a:buNone/>
               <a:defRPr sz="1425" b="1">
                 <a:solidFill>
                   <a:srgbClr val="2456D8"/>
@@ -2540,6 +2617,7 @@
               </a:defRPr>
             </a:lvl5pPr>
             <a:lvl6pPr algn="l">
+              <a:buNone/>
               <a:defRPr sz="1425" b="1">
                 <a:solidFill>
                   <a:srgbClr val="2456D8"/>
@@ -2550,6 +2628,7 @@
               </a:defRPr>
             </a:lvl6pPr>
             <a:lvl7pPr algn="l">
+              <a:buNone/>
               <a:defRPr sz="1425" b="1">
                 <a:solidFill>
                   <a:srgbClr val="2456D8"/>
@@ -2560,6 +2639,7 @@
               </a:defRPr>
             </a:lvl7pPr>
             <a:lvl8pPr algn="l">
+              <a:buNone/>
               <a:defRPr sz="1425" b="1">
                 <a:solidFill>
                   <a:srgbClr val="2456D8"/>
@@ -2570,6 +2650,7 @@
               </a:defRPr>
             </a:lvl8pPr>
             <a:lvl9pPr algn="l">
+              <a:buNone/>
               <a:defRPr sz="1425" b="1">
                 <a:solidFill>
                   <a:srgbClr val="2456D8"/>
@@ -2625,7 +2706,7 @@
         </p:nvSpPr>
         <p:spPr>
           <a:xfrm xmlns:a="http://schemas.openxmlformats.org/drawingml/2006/main">
-            <a:off x="1628775" y="4524375"/>
+            <a:off x="1628775" y="4610100"/>
             <a:ext cx="6753225" cy="400050"/>
           </a:xfrm>
           <a:prstGeom xmlns:a="http://schemas.openxmlformats.org/drawingml/2006/main" prst="rect">
@@ -2653,6 +2734,7 @@
               </a:defRPr>
             </a:defPPr>
             <a:lvl1pPr algn="l">
+              <a:buNone/>
               <a:defRPr sz="1500" b="0">
                 <a:solidFill>
                   <a:srgbClr val="14243A"/>
@@ -2663,6 +2745,7 @@
               </a:defRPr>
             </a:lvl1pPr>
             <a:lvl2pPr algn="l">
+              <a:buNone/>
               <a:defRPr sz="1500" b="0">
                 <a:solidFill>
                   <a:srgbClr val="14243A"/>
@@ -2673,6 +2756,7 @@
               </a:defRPr>
             </a:lvl2pPr>
             <a:lvl3pPr algn="l">
+              <a:buNone/>
               <a:defRPr sz="1500" b="0">
                 <a:solidFill>
                   <a:srgbClr val="14243A"/>
@@ -2683,6 +2767,7 @@
               </a:defRPr>
             </a:lvl3pPr>
             <a:lvl4pPr algn="l">
+              <a:buNone/>
               <a:defRPr sz="1500" b="0">
                 <a:solidFill>
                   <a:srgbClr val="14243A"/>
@@ -2693,6 +2778,7 @@
               </a:defRPr>
             </a:lvl4pPr>
             <a:lvl5pPr algn="l">
+              <a:buNone/>
               <a:defRPr sz="1500" b="0">
                 <a:solidFill>
                   <a:srgbClr val="14243A"/>
@@ -2703,6 +2789,7 @@
               </a:defRPr>
             </a:lvl5pPr>
             <a:lvl6pPr algn="l">
+              <a:buNone/>
               <a:defRPr sz="1500" b="0">
                 <a:solidFill>
                   <a:srgbClr val="14243A"/>
@@ -2713,6 +2800,7 @@
               </a:defRPr>
             </a:lvl6pPr>
             <a:lvl7pPr algn="l">
+              <a:buNone/>
               <a:defRPr sz="1500" b="0">
                 <a:solidFill>
                   <a:srgbClr val="14243A"/>
@@ -2723,6 +2811,7 @@
               </a:defRPr>
             </a:lvl7pPr>
             <a:lvl8pPr algn="l">
+              <a:buNone/>
               <a:defRPr sz="1500" b="0">
                 <a:solidFill>
                   <a:srgbClr val="14243A"/>
@@ -2733,6 +2822,7 @@
               </a:defRPr>
             </a:lvl8pPr>
             <a:lvl9pPr algn="l">
+              <a:buNone/>
               <a:defRPr sz="1500" b="0">
                 <a:solidFill>
                   <a:srgbClr val="14243A"/>
@@ -2788,7 +2878,7 @@
         </p:nvSpPr>
         <p:spPr>
           <a:xfrm xmlns:a="http://schemas.openxmlformats.org/drawingml/2006/main">
-            <a:off x="609600" y="4981575"/>
+            <a:off x="609600" y="5067300"/>
             <a:ext cx="904875" cy="314325"/>
           </a:xfrm>
           <a:prstGeom xmlns:a="http://schemas.openxmlformats.org/drawingml/2006/main" prst="rect">
@@ -2816,6 +2906,7 @@
               </a:defRPr>
             </a:defPPr>
             <a:lvl1pPr algn="l">
+              <a:buNone/>
               <a:defRPr sz="1425" b="1">
                 <a:solidFill>
                   <a:srgbClr val="2456D8"/>
@@ -2826,6 +2917,7 @@
               </a:defRPr>
             </a:lvl1pPr>
             <a:lvl2pPr algn="l">
+              <a:buNone/>
               <a:defRPr sz="1425" b="1">
                 <a:solidFill>
                   <a:srgbClr val="2456D8"/>
@@ -2836,6 +2928,7 @@
               </a:defRPr>
             </a:lvl2pPr>
             <a:lvl3pPr algn="l">
+              <a:buNone/>
               <a:defRPr sz="1425" b="1">
                 <a:solidFill>
                   <a:srgbClr val="2456D8"/>
@@ -2846,6 +2939,7 @@
               </a:defRPr>
             </a:lvl3pPr>
             <a:lvl4pPr algn="l">
+              <a:buNone/>
               <a:defRPr sz="1425" b="1">
                 <a:solidFill>
                   <a:srgbClr val="2456D8"/>
@@ -2856,6 +2950,7 @@
               </a:defRPr>
             </a:lvl4pPr>
             <a:lvl5pPr algn="l">
+              <a:buNone/>
               <a:defRPr sz="1425" b="1">
                 <a:solidFill>
                   <a:srgbClr val="2456D8"/>
@@ -2866,6 +2961,7 @@
               </a:defRPr>
             </a:lvl5pPr>
             <a:lvl6pPr algn="l">
+              <a:buNone/>
               <a:defRPr sz="1425" b="1">
                 <a:solidFill>
                   <a:srgbClr val="2456D8"/>
@@ -2876,6 +2972,7 @@
               </a:defRPr>
             </a:lvl6pPr>
             <a:lvl7pPr algn="l">
+              <a:buNone/>
               <a:defRPr sz="1425" b="1">
                 <a:solidFill>
                   <a:srgbClr val="2456D8"/>
@@ -2886,6 +2983,7 @@
               </a:defRPr>
             </a:lvl7pPr>
             <a:lvl8pPr algn="l">
+              <a:buNone/>
               <a:defRPr sz="1425" b="1">
                 <a:solidFill>
                   <a:srgbClr val="2456D8"/>
@@ -2896,6 +2994,7 @@
               </a:defRPr>
             </a:lvl8pPr>
             <a:lvl9pPr algn="l">
+              <a:buNone/>
               <a:defRPr sz="1425" b="1">
                 <a:solidFill>
                   <a:srgbClr val="2456D8"/>
@@ -2951,7 +3050,7 @@
         </p:nvSpPr>
         <p:spPr>
           <a:xfrm xmlns:a="http://schemas.openxmlformats.org/drawingml/2006/main">
-            <a:off x="1628775" y="4972050"/>
+            <a:off x="1628775" y="5057775"/>
             <a:ext cx="6753225" cy="400050"/>
           </a:xfrm>
           <a:prstGeom xmlns:a="http://schemas.openxmlformats.org/drawingml/2006/main" prst="rect">
@@ -2979,6 +3078,7 @@
               </a:defRPr>
             </a:defPPr>
             <a:lvl1pPr algn="l">
+              <a:buNone/>
               <a:defRPr sz="1500" b="0">
                 <a:solidFill>
                   <a:srgbClr val="14243A"/>
@@ -2989,6 +3089,7 @@
               </a:defRPr>
             </a:lvl1pPr>
             <a:lvl2pPr algn="l">
+              <a:buNone/>
               <a:defRPr sz="1500" b="0">
                 <a:solidFill>
                   <a:srgbClr val="14243A"/>
@@ -2999,6 +3100,7 @@
               </a:defRPr>
             </a:lvl2pPr>
             <a:lvl3pPr algn="l">
+              <a:buNone/>
               <a:defRPr sz="1500" b="0">
                 <a:solidFill>
                   <a:srgbClr val="14243A"/>
@@ -3009,6 +3111,7 @@
               </a:defRPr>
             </a:lvl3pPr>
             <a:lvl4pPr algn="l">
+              <a:buNone/>
               <a:defRPr sz="1500" b="0">
                 <a:solidFill>
                   <a:srgbClr val="14243A"/>
@@ -3019,6 +3122,7 @@
               </a:defRPr>
             </a:lvl4pPr>
             <a:lvl5pPr algn="l">
+              <a:buNone/>
               <a:defRPr sz="1500" b="0">
                 <a:solidFill>
                   <a:srgbClr val="14243A"/>
@@ -3029,6 +3133,7 @@
               </a:defRPr>
             </a:lvl5pPr>
             <a:lvl6pPr algn="l">
+              <a:buNone/>
               <a:defRPr sz="1500" b="0">
                 <a:solidFill>
                   <a:srgbClr val="14243A"/>
@@ -3039,6 +3144,7 @@
               </a:defRPr>
             </a:lvl6pPr>
             <a:lvl7pPr algn="l">
+              <a:buNone/>
               <a:defRPr sz="1500" b="0">
                 <a:solidFill>
                   <a:srgbClr val="14243A"/>
@@ -3049,6 +3155,7 @@
               </a:defRPr>
             </a:lvl7pPr>
             <a:lvl8pPr algn="l">
+              <a:buNone/>
               <a:defRPr sz="1500" b="0">
                 <a:solidFill>
                   <a:srgbClr val="14243A"/>
@@ -3059,6 +3166,7 @@
               </a:defRPr>
             </a:lvl8pPr>
             <a:lvl9pPr algn="l">
+              <a:buNone/>
               <a:defRPr sz="1500" b="0">
                 <a:solidFill>
                   <a:srgbClr val="14243A"/>
@@ -3142,6 +3250,7 @@
               </a:defRPr>
             </a:defPPr>
             <a:lvl1pPr algn="l">
+              <a:buNone/>
               <a:defRPr sz="1350" b="0">
                 <a:solidFill>
                   <a:srgbClr val="14243A"/>
@@ -3152,6 +3261,7 @@
               </a:defRPr>
             </a:lvl1pPr>
             <a:lvl2pPr algn="l">
+              <a:buNone/>
               <a:defRPr sz="1350" b="0">
                 <a:solidFill>
                   <a:srgbClr val="14243A"/>
@@ -3162,6 +3272,7 @@
               </a:defRPr>
             </a:lvl2pPr>
             <a:lvl3pPr algn="l">
+              <a:buNone/>
               <a:defRPr sz="1350" b="0">
                 <a:solidFill>
                   <a:srgbClr val="14243A"/>
@@ -3172,6 +3283,7 @@
               </a:defRPr>
             </a:lvl3pPr>
             <a:lvl4pPr algn="l">
+              <a:buNone/>
               <a:defRPr sz="1350" b="0">
                 <a:solidFill>
                   <a:srgbClr val="14243A"/>
@@ -3182,6 +3294,7 @@
               </a:defRPr>
             </a:lvl4pPr>
             <a:lvl5pPr algn="l">
+              <a:buNone/>
               <a:defRPr sz="1350" b="0">
                 <a:solidFill>
                   <a:srgbClr val="14243A"/>
@@ -3192,6 +3305,7 @@
               </a:defRPr>
             </a:lvl5pPr>
             <a:lvl6pPr algn="l">
+              <a:buNone/>
               <a:defRPr sz="1350" b="0">
                 <a:solidFill>
                   <a:srgbClr val="14243A"/>
@@ -3202,6 +3316,7 @@
               </a:defRPr>
             </a:lvl6pPr>
             <a:lvl7pPr algn="l">
+              <a:buNone/>
               <a:defRPr sz="1350" b="0">
                 <a:solidFill>
                   <a:srgbClr val="14243A"/>
@@ -3212,6 +3327,7 @@
               </a:defRPr>
             </a:lvl7pPr>
             <a:lvl8pPr algn="l">
+              <a:buNone/>
               <a:defRPr sz="1350" b="0">
                 <a:solidFill>
                   <a:srgbClr val="14243A"/>
@@ -3222,6 +3338,7 @@
               </a:defRPr>
             </a:lvl8pPr>
             <a:lvl9pPr algn="l">
+              <a:buNone/>
               <a:defRPr sz="1350" b="0">
                 <a:solidFill>
                   <a:srgbClr val="14243A"/>
@@ -3304,7 +3421,7 @@
           <p:cNvPr id="44" name="">
             <a:extLst xmlns:a="http://schemas.openxmlformats.org/drawingml/2006/main">
               <a:ext uri="{FF2B5EF4-FFF2-40B4-BE49-F238E27FC236}">
-                <a16:creationId xmlns:a16="http://schemas.microsoft.com/office/drawing/2014/main" id="{725BE0BA-37AC-486D-9313-5DD0277904AC}"/>
+                <a16:creationId xmlns:a16="http://schemas.microsoft.com/office/drawing/2014/main" id="{8F4789AA-2276-483F-A9D5-455EF48746C1}"/>
               </a:ext>
             </a:extLst>
           </p:cNvPr>
@@ -3314,7 +3431,7 @@
           <p:nvPr/>
         </p:nvPicPr>
         <p:blipFill>
-          <a:blip xmlns:r="http://schemas.openxmlformats.org/officeDocument/2006/relationships" xmlns:a="http://schemas.openxmlformats.org/drawingml/2006/main" r:embed="R8ed3116fbee44256"/>
+          <a:blip xmlns:r="http://schemas.openxmlformats.org/officeDocument/2006/relationships" xmlns:a="http://schemas.openxmlformats.org/drawingml/2006/main" r:embed="Rc82bed1b60f24c75"/>
           <a:stretch xmlns:a="http://schemas.openxmlformats.org/drawingml/2006/main"/>
         </p:blipFill>
         <p:spPr>
@@ -3371,6 +3488,7 @@
               </a:defRPr>
             </a:defPPr>
             <a:lvl1pPr algn="ctr">
+              <a:buNone/>
               <a:defRPr sz="1125" b="1">
                 <a:solidFill>
                   <a:srgbClr val="14243A"/>
@@ -3381,6 +3499,7 @@
               </a:defRPr>
             </a:lvl1pPr>
             <a:lvl2pPr algn="ctr">
+              <a:buNone/>
               <a:defRPr sz="1125" b="1">
                 <a:solidFill>
                   <a:srgbClr val="14243A"/>
@@ -3391,6 +3510,7 @@
               </a:defRPr>
             </a:lvl2pPr>
             <a:lvl3pPr algn="ctr">
+              <a:buNone/>
               <a:defRPr sz="1125" b="1">
                 <a:solidFill>
                   <a:srgbClr val="14243A"/>
@@ -3401,6 +3521,7 @@
               </a:defRPr>
             </a:lvl3pPr>
             <a:lvl4pPr algn="ctr">
+              <a:buNone/>
               <a:defRPr sz="1125" b="1">
                 <a:solidFill>
                   <a:srgbClr val="14243A"/>
@@ -3411,6 +3532,7 @@
               </a:defRPr>
             </a:lvl4pPr>
             <a:lvl5pPr algn="ctr">
+              <a:buNone/>
               <a:defRPr sz="1125" b="1">
                 <a:solidFill>
                   <a:srgbClr val="14243A"/>
@@ -3421,6 +3543,7 @@
               </a:defRPr>
             </a:lvl5pPr>
             <a:lvl6pPr algn="ctr">
+              <a:buNone/>
               <a:defRPr sz="1125" b="1">
                 <a:solidFill>
                   <a:srgbClr val="14243A"/>
@@ -3431,6 +3554,7 @@
               </a:defRPr>
             </a:lvl6pPr>
             <a:lvl7pPr algn="ctr">
+              <a:buNone/>
               <a:defRPr sz="1125" b="1">
                 <a:solidFill>
                   <a:srgbClr val="14243A"/>
@@ -3441,6 +3565,7 @@
               </a:defRPr>
             </a:lvl7pPr>
             <a:lvl8pPr algn="ctr">
+              <a:buNone/>
               <a:defRPr sz="1125" b="1">
                 <a:solidFill>
                   <a:srgbClr val="14243A"/>
@@ -3451,6 +3576,7 @@
               </a:defRPr>
             </a:lvl8pPr>
             <a:lvl9pPr algn="ctr">
+              <a:buNone/>
               <a:defRPr sz="1125" b="1">
                 <a:solidFill>
                   <a:srgbClr val="14243A"/>
@@ -3534,6 +3660,7 @@
               </a:defRPr>
             </a:defPPr>
             <a:lvl1pPr algn="ctr">
+              <a:buNone/>
               <a:defRPr sz="900" b="0">
                 <a:solidFill>
                   <a:srgbClr val="14243A"/>
@@ -3544,6 +3671,7 @@
               </a:defRPr>
             </a:lvl1pPr>
             <a:lvl2pPr algn="ctr">
+              <a:buNone/>
               <a:defRPr sz="900" b="0">
                 <a:solidFill>
                   <a:srgbClr val="14243A"/>
@@ -3554,6 +3682,7 @@
               </a:defRPr>
             </a:lvl2pPr>
             <a:lvl3pPr algn="ctr">
+              <a:buNone/>
               <a:defRPr sz="900" b="0">
                 <a:solidFill>
                   <a:srgbClr val="14243A"/>
@@ -3564,6 +3693,7 @@
               </a:defRPr>
             </a:lvl3pPr>
             <a:lvl4pPr algn="ctr">
+              <a:buNone/>
               <a:defRPr sz="900" b="0">
                 <a:solidFill>
                   <a:srgbClr val="14243A"/>
@@ -3574,6 +3704,7 @@
               </a:defRPr>
             </a:lvl4pPr>
             <a:lvl5pPr algn="ctr">
+              <a:buNone/>
               <a:defRPr sz="900" b="0">
                 <a:solidFill>
                   <a:srgbClr val="14243A"/>
@@ -3584,6 +3715,7 @@
               </a:defRPr>
             </a:lvl5pPr>
             <a:lvl6pPr algn="ctr">
+              <a:buNone/>
               <a:defRPr sz="900" b="0">
                 <a:solidFill>
                   <a:srgbClr val="14243A"/>
@@ -3594,6 +3726,7 @@
               </a:defRPr>
             </a:lvl6pPr>
             <a:lvl7pPr algn="ctr">
+              <a:buNone/>
               <a:defRPr sz="900" b="0">
                 <a:solidFill>
                   <a:srgbClr val="14243A"/>
@@ -3604,6 +3737,7 @@
               </a:defRPr>
             </a:lvl7pPr>
             <a:lvl8pPr algn="ctr">
+              <a:buNone/>
               <a:defRPr sz="900" b="0">
                 <a:solidFill>
                   <a:srgbClr val="14243A"/>
@@ -3614,6 +3748,7 @@
               </a:defRPr>
             </a:lvl8pPr>
             <a:lvl9pPr algn="ctr">
+              <a:buNone/>
               <a:defRPr sz="900" b="0">
                 <a:solidFill>
                   <a:srgbClr val="14243A"/>
@@ -3669,7 +3804,7 @@
         </p:nvSpPr>
         <p:spPr>
           <a:xfrm xmlns:a="http://schemas.openxmlformats.org/drawingml/2006/main">
-            <a:off x="609600" y="1628775"/>
+            <a:off x="609600" y="1943100"/>
             <a:ext cx="7810500" cy="419100"/>
           </a:xfrm>
           <a:prstGeom xmlns:a="http://schemas.openxmlformats.org/drawingml/2006/main" prst="rect">
@@ -3696,6 +3831,7 @@
               </a:defRPr>
             </a:defPPr>
             <a:lvl1pPr algn="l">
+              <a:buNone/>
               <a:defRPr sz="2250" b="1">
                 <a:solidFill>
                   <a:srgbClr val="2456D8"/>
@@ -3706,6 +3842,7 @@
               </a:defRPr>
             </a:lvl1pPr>
             <a:lvl2pPr algn="l">
+              <a:buNone/>
               <a:defRPr sz="2250" b="1">
                 <a:solidFill>
                   <a:srgbClr val="2456D8"/>
@@ -3716,6 +3853,7 @@
               </a:defRPr>
             </a:lvl2pPr>
             <a:lvl3pPr algn="l">
+              <a:buNone/>
               <a:defRPr sz="2250" b="1">
                 <a:solidFill>
                   <a:srgbClr val="2456D8"/>
@@ -3726,6 +3864,7 @@
               </a:defRPr>
             </a:lvl3pPr>
             <a:lvl4pPr algn="l">
+              <a:buNone/>
               <a:defRPr sz="2250" b="1">
                 <a:solidFill>
                   <a:srgbClr val="2456D8"/>
@@ -3736,6 +3875,7 @@
               </a:defRPr>
             </a:lvl4pPr>
             <a:lvl5pPr algn="l">
+              <a:buNone/>
               <a:defRPr sz="2250" b="1">
                 <a:solidFill>
                   <a:srgbClr val="2456D8"/>
@@ -3746,6 +3886,7 @@
               </a:defRPr>
             </a:lvl5pPr>
             <a:lvl6pPr algn="l">
+              <a:buNone/>
               <a:defRPr sz="2250" b="1">
                 <a:solidFill>
                   <a:srgbClr val="2456D8"/>
@@ -3756,6 +3897,7 @@
               </a:defRPr>
             </a:lvl6pPr>
             <a:lvl7pPr algn="l">
+              <a:buNone/>
               <a:defRPr sz="2250" b="1">
                 <a:solidFill>
                   <a:srgbClr val="2456D8"/>
@@ -3766,6 +3908,7 @@
               </a:defRPr>
             </a:lvl7pPr>
             <a:lvl8pPr algn="l">
+              <a:buNone/>
               <a:defRPr sz="2250" b="1">
                 <a:solidFill>
                   <a:srgbClr val="2456D8"/>
@@ -3776,6 +3919,7 @@
               </a:defRPr>
             </a:lvl8pPr>
             <a:lvl9pPr algn="l">
+              <a:buNone/>
               <a:defRPr sz="2250" b="1">
                 <a:solidFill>
                   <a:srgbClr val="2456D8"/>
@@ -3788,6 +3932,7 @@
           </a:lstStyle>
           <a:p xmlns:a="http://schemas.openxmlformats.org/drawingml/2006/main">
             <a:pPr algn="l">
+              <a:buNone/>
               <a:defRPr sz="2250" b="1">
                 <a:solidFill>
                   <a:srgbClr val="2456D8"/>
@@ -3854,6 +3999,7 @@
               </a:defRPr>
             </a:defPPr>
             <a:lvl1pPr algn="l">
+              <a:buNone/>
               <a:defRPr sz="1500" b="1">
                 <a:solidFill>
                   <a:srgbClr val="2456D8"/>
@@ -3864,6 +4010,7 @@
               </a:defRPr>
             </a:lvl1pPr>
             <a:lvl2pPr algn="l">
+              <a:buNone/>
               <a:defRPr sz="1500" b="1">
                 <a:solidFill>
                   <a:srgbClr val="2456D8"/>
@@ -3874,6 +4021,7 @@
               </a:defRPr>
             </a:lvl2pPr>
             <a:lvl3pPr algn="l">
+              <a:buNone/>
               <a:defRPr sz="1500" b="1">
                 <a:solidFill>
                   <a:srgbClr val="2456D8"/>
@@ -3884,6 +4032,7 @@
               </a:defRPr>
             </a:lvl3pPr>
             <a:lvl4pPr algn="l">
+              <a:buNone/>
               <a:defRPr sz="1500" b="1">
                 <a:solidFill>
                   <a:srgbClr val="2456D8"/>
@@ -3894,6 +4043,7 @@
               </a:defRPr>
             </a:lvl4pPr>
             <a:lvl5pPr algn="l">
+              <a:buNone/>
               <a:defRPr sz="1500" b="1">
                 <a:solidFill>
                   <a:srgbClr val="2456D8"/>
@@ -3904,6 +4054,7 @@
               </a:defRPr>
             </a:lvl5pPr>
             <a:lvl6pPr algn="l">
+              <a:buNone/>
               <a:defRPr sz="1500" b="1">
                 <a:solidFill>
                   <a:srgbClr val="2456D8"/>
@@ -3914,6 +4065,7 @@
               </a:defRPr>
             </a:lvl6pPr>
             <a:lvl7pPr algn="l">
+              <a:buNone/>
               <a:defRPr sz="1500" b="1">
                 <a:solidFill>
                   <a:srgbClr val="2456D8"/>
@@ -3924,6 +4076,7 @@
               </a:defRPr>
             </a:lvl7pPr>
             <a:lvl8pPr algn="l">
+              <a:buNone/>
               <a:defRPr sz="1500" b="1">
                 <a:solidFill>
                   <a:srgbClr val="2456D8"/>
@@ -3934,6 +4087,7 @@
               </a:defRPr>
             </a:lvl8pPr>
             <a:lvl9pPr algn="l">
+              <a:buNone/>
               <a:defRPr sz="1500" b="1">
                 <a:solidFill>
                   <a:srgbClr val="2456D8"/>
@@ -3946,6 +4100,7 @@
           </a:lstStyle>
           <a:p xmlns:a="http://schemas.openxmlformats.org/drawingml/2006/main">
             <a:pPr algn="l">
+              <a:buNone/>
               <a:defRPr sz="1500" b="1">
                 <a:solidFill>
                   <a:srgbClr val="2456D8"/>
@@ -3974,7 +4129,7 @@
           <p:cNvPr id="47" name="">
             <a:extLst xmlns:a="http://schemas.openxmlformats.org/drawingml/2006/main">
               <a:ext uri="{FF2B5EF4-FFF2-40B4-BE49-F238E27FC236}">
-                <a16:creationId xmlns:a16="http://schemas.microsoft.com/office/drawing/2014/main" id="{37697BC5-960A-4E0B-AA60-631304F377DA}"/>
+                <a16:creationId xmlns:a16="http://schemas.microsoft.com/office/drawing/2014/main" id="{9F4AF9C1-C393-498D-9F16-F05CCD5678C1}"/>
               </a:ext>
             </a:extLst>
           </p:cNvPr>
@@ -3984,7 +4139,7 @@
           <p:nvPr/>
         </p:nvPicPr>
         <p:blipFill>
-          <a:blip xmlns:r="http://schemas.openxmlformats.org/officeDocument/2006/relationships" xmlns:a="http://schemas.openxmlformats.org/drawingml/2006/main" r:embed="R69cfb47b15364115"/>
+          <a:blip xmlns:r="http://schemas.openxmlformats.org/officeDocument/2006/relationships" xmlns:a="http://schemas.openxmlformats.org/drawingml/2006/main" r:embed="Rd9973b5d80d0427b"/>
           <a:stretch xmlns:a="http://schemas.openxmlformats.org/drawingml/2006/main"/>
         </p:blipFill>
         <p:spPr>
@@ -4040,6 +4195,7 @@
               </a:defRPr>
             </a:defPPr>
             <a:lvl1pPr algn="ctr">
+              <a:buNone/>
               <a:defRPr sz="1500" b="1">
                 <a:solidFill>
                   <a:srgbClr val="14243A"/>
@@ -4050,6 +4206,7 @@
               </a:defRPr>
             </a:lvl1pPr>
             <a:lvl2pPr algn="ctr">
+              <a:buNone/>
               <a:defRPr sz="1500" b="1">
                 <a:solidFill>
                   <a:srgbClr val="14243A"/>
@@ -4060,6 +4217,7 @@
               </a:defRPr>
             </a:lvl2pPr>
             <a:lvl3pPr algn="ctr">
+              <a:buNone/>
               <a:defRPr sz="1500" b="1">
                 <a:solidFill>
                   <a:srgbClr val="14243A"/>
@@ -4070,6 +4228,7 @@
               </a:defRPr>
             </a:lvl3pPr>
             <a:lvl4pPr algn="ctr">
+              <a:buNone/>
               <a:defRPr sz="1500" b="1">
                 <a:solidFill>
                   <a:srgbClr val="14243A"/>
@@ -4080,6 +4239,7 @@
               </a:defRPr>
             </a:lvl4pPr>
             <a:lvl5pPr algn="ctr">
+              <a:buNone/>
               <a:defRPr sz="1500" b="1">
                 <a:solidFill>
                   <a:srgbClr val="14243A"/>
@@ -4090,6 +4250,7 @@
               </a:defRPr>
             </a:lvl5pPr>
             <a:lvl6pPr algn="ctr">
+              <a:buNone/>
               <a:defRPr sz="1500" b="1">
                 <a:solidFill>
                   <a:srgbClr val="14243A"/>
@@ -4100,6 +4261,7 @@
               </a:defRPr>
             </a:lvl6pPr>
             <a:lvl7pPr algn="ctr">
+              <a:buNone/>
               <a:defRPr sz="1500" b="1">
                 <a:solidFill>
                   <a:srgbClr val="14243A"/>
@@ -4110,6 +4272,7 @@
               </a:defRPr>
             </a:lvl7pPr>
             <a:lvl8pPr algn="ctr">
+              <a:buNone/>
               <a:defRPr sz="1500" b="1">
                 <a:solidFill>
                   <a:srgbClr val="14243A"/>
@@ -4120,6 +4283,7 @@
               </a:defRPr>
             </a:lvl8pPr>
             <a:lvl9pPr algn="ctr">
+              <a:buNone/>
               <a:defRPr sz="1500" b="1">
                 <a:solidFill>
                   <a:srgbClr val="14243A"/>
@@ -4132,6 +4296,7 @@
           </a:lstStyle>
           <a:p xmlns:a="http://schemas.openxmlformats.org/drawingml/2006/main">
             <a:pPr algn="ctr">
+              <a:buNone/>
               <a:defRPr sz="1500" b="1">
                 <a:solidFill>
                   <a:srgbClr val="14243A"/>
@@ -4198,6 +4363,7 @@
               </a:defRPr>
             </a:defPPr>
             <a:lvl1pPr algn="ctr">
+              <a:buNone/>
               <a:defRPr sz="1200" b="0">
                 <a:solidFill>
                   <a:srgbClr val="14243A"/>
@@ -4208,6 +4374,7 @@
               </a:defRPr>
             </a:lvl1pPr>
             <a:lvl2pPr algn="ctr">
+              <a:buNone/>
               <a:defRPr sz="1200" b="0">
                 <a:solidFill>
                   <a:srgbClr val="14243A"/>
@@ -4218,6 +4385,7 @@
               </a:defRPr>
             </a:lvl2pPr>
             <a:lvl3pPr algn="ctr">
+              <a:buNone/>
               <a:defRPr sz="1200" b="0">
                 <a:solidFill>
                   <a:srgbClr val="14243A"/>
@@ -4228,6 +4396,7 @@
               </a:defRPr>
             </a:lvl3pPr>
             <a:lvl4pPr algn="ctr">
+              <a:buNone/>
               <a:defRPr sz="1200" b="0">
                 <a:solidFill>
                   <a:srgbClr val="14243A"/>
@@ -4238,6 +4407,7 @@
               </a:defRPr>
             </a:lvl4pPr>
             <a:lvl5pPr algn="ctr">
+              <a:buNone/>
               <a:defRPr sz="1200" b="0">
                 <a:solidFill>
                   <a:srgbClr val="14243A"/>
@@ -4248,6 +4418,7 @@
               </a:defRPr>
             </a:lvl5pPr>
             <a:lvl6pPr algn="ctr">
+              <a:buNone/>
               <a:defRPr sz="1200" b="0">
                 <a:solidFill>
                   <a:srgbClr val="14243A"/>
@@ -4258,6 +4429,7 @@
               </a:defRPr>
             </a:lvl6pPr>
             <a:lvl7pPr algn="ctr">
+              <a:buNone/>
               <a:defRPr sz="1200" b="0">
                 <a:solidFill>
                   <a:srgbClr val="14243A"/>
@@ -4268,6 +4440,7 @@
               </a:defRPr>
             </a:lvl7pPr>
             <a:lvl8pPr algn="ctr">
+              <a:buNone/>
               <a:defRPr sz="1200" b="0">
                 <a:solidFill>
                   <a:srgbClr val="14243A"/>
@@ -4278,6 +4451,7 @@
               </a:defRPr>
             </a:lvl8pPr>
             <a:lvl9pPr algn="ctr">
+              <a:buNone/>
               <a:defRPr sz="1200" b="0">
                 <a:solidFill>
                   <a:srgbClr val="14243A"/>
@@ -4290,6 +4464,7 @@
           </a:lstStyle>
           <a:p xmlns:a="http://schemas.openxmlformats.org/drawingml/2006/main">
             <a:pPr algn="ctr">
+              <a:buNone/>
               <a:defRPr sz="1200" b="0">
                 <a:solidFill>
                   <a:srgbClr val="14243A"/>
@@ -4309,6 +4484,164 @@
                 <a:cs typeface="Segoe UI"/>
               </a:rPr>
               <a:t>Community: SUNSHINE STUDIO</a:t>
+            </a:r>
+          </a:p>
+        </p:txBody>
+      </p:sp>
+      <p:sp>
+        <p:nvSpPr>
+          <p:cNvPr id="50" name="korean-name-line">
+            <a:extLst xmlns:a="http://schemas.openxmlformats.org/drawingml/2006/main">
+              <a:ext uri="{FF2B5EF4-FFF2-40B4-BE49-F238E27FC236}">
+                <a16:creationId xmlns:a16="http://schemas.microsoft.com/office/drawing/2014/main" id="{5C3EC7E1-BBE8-43E4-91BA-428BCC2C0156}"/>
+              </a:ext>
+            </a:extLst>
+          </p:cNvPr>
+          <p:cNvSpPr>
+            <a:spLocks xmlns:a="http://schemas.openxmlformats.org/drawingml/2006/main" noGrp="1"/>
+          </p:cNvSpPr>
+          <p:nvPr/>
+        </p:nvSpPr>
+        <p:spPr>
+          <a:xfrm xmlns:a="http://schemas.openxmlformats.org/drawingml/2006/main">
+            <a:off x="609600" y="1524000"/>
+            <a:ext cx="7810500" cy="323850"/>
+          </a:xfrm>
+          <a:prstGeom xmlns:a="http://schemas.openxmlformats.org/drawingml/2006/main" prst="rect">
+            <a:avLst/>
+          </a:prstGeom>
+          <a:noFill xmlns:a="http://schemas.openxmlformats.org/drawingml/2006/main"/>
+          <a:ln xmlns:a="http://schemas.openxmlformats.org/drawingml/2006/main" w="0">
+            <a:noFill/>
+          </a:ln>
+        </p:spPr>
+        <p:txBody>
+          <a:bodyPr xmlns:a="http://schemas.openxmlformats.org/drawingml/2006/main" wrap="none" lIns="0" tIns="0" rIns="0" bIns="0" anchor="t">
+            <a:noAutofit/>
+          </a:bodyPr>
+          <a:lstStyle xmlns:a="http://schemas.openxmlformats.org/drawingml/2006/main">
+            <a:defPPr>
+              <a:defRPr sz="1800" b="0">
+                <a:solidFill>
+                  <a:srgbClr val="14243A"/>
+                </a:solidFill>
+                <a:latin typeface="Malgun Gothic"/>
+                <a:ea typeface="Malgun Gothic"/>
+                <a:cs typeface="Malgun Gothic"/>
+              </a:defRPr>
+            </a:defPPr>
+            <a:lvl1pPr>
+              <a:defRPr sz="1800" b="0">
+                <a:solidFill>
+                  <a:srgbClr val="14243A"/>
+                </a:solidFill>
+                <a:latin typeface="Malgun Gothic"/>
+                <a:ea typeface="Malgun Gothic"/>
+                <a:cs typeface="Malgun Gothic"/>
+              </a:defRPr>
+            </a:lvl1pPr>
+            <a:lvl2pPr>
+              <a:defRPr sz="1800" b="0">
+                <a:solidFill>
+                  <a:srgbClr val="14243A"/>
+                </a:solidFill>
+                <a:latin typeface="Malgun Gothic"/>
+                <a:ea typeface="Malgun Gothic"/>
+                <a:cs typeface="Malgun Gothic"/>
+              </a:defRPr>
+            </a:lvl2pPr>
+            <a:lvl3pPr>
+              <a:defRPr sz="1800" b="0">
+                <a:solidFill>
+                  <a:srgbClr val="14243A"/>
+                </a:solidFill>
+                <a:latin typeface="Malgun Gothic"/>
+                <a:ea typeface="Malgun Gothic"/>
+                <a:cs typeface="Malgun Gothic"/>
+              </a:defRPr>
+            </a:lvl3pPr>
+            <a:lvl4pPr>
+              <a:defRPr sz="1800" b="0">
+                <a:solidFill>
+                  <a:srgbClr val="14243A"/>
+                </a:solidFill>
+                <a:latin typeface="Malgun Gothic"/>
+                <a:ea typeface="Malgun Gothic"/>
+                <a:cs typeface="Malgun Gothic"/>
+              </a:defRPr>
+            </a:lvl4pPr>
+            <a:lvl5pPr>
+              <a:defRPr sz="1800" b="0">
+                <a:solidFill>
+                  <a:srgbClr val="14243A"/>
+                </a:solidFill>
+                <a:latin typeface="Malgun Gothic"/>
+                <a:ea typeface="Malgun Gothic"/>
+                <a:cs typeface="Malgun Gothic"/>
+              </a:defRPr>
+            </a:lvl5pPr>
+            <a:lvl6pPr>
+              <a:defRPr sz="1800" b="0">
+                <a:solidFill>
+                  <a:srgbClr val="14243A"/>
+                </a:solidFill>
+                <a:latin typeface="Malgun Gothic"/>
+                <a:ea typeface="Malgun Gothic"/>
+                <a:cs typeface="Malgun Gothic"/>
+              </a:defRPr>
+            </a:lvl6pPr>
+            <a:lvl7pPr>
+              <a:defRPr sz="1800" b="0">
+                <a:solidFill>
+                  <a:srgbClr val="14243A"/>
+                </a:solidFill>
+                <a:latin typeface="Malgun Gothic"/>
+                <a:ea typeface="Malgun Gothic"/>
+                <a:cs typeface="Malgun Gothic"/>
+              </a:defRPr>
+            </a:lvl7pPr>
+            <a:lvl8pPr>
+              <a:defRPr sz="1800" b="0">
+                <a:solidFill>
+                  <a:srgbClr val="14243A"/>
+                </a:solidFill>
+                <a:latin typeface="Malgun Gothic"/>
+                <a:ea typeface="Malgun Gothic"/>
+                <a:cs typeface="Malgun Gothic"/>
+              </a:defRPr>
+            </a:lvl8pPr>
+            <a:lvl9pPr>
+              <a:defRPr sz="1800" b="0">
+                <a:solidFill>
+                  <a:srgbClr val="14243A"/>
+                </a:solidFill>
+                <a:latin typeface="Malgun Gothic"/>
+                <a:ea typeface="Malgun Gothic"/>
+                <a:cs typeface="Malgun Gothic"/>
+              </a:defRPr>
+            </a:lvl9pPr>
+          </a:lstStyle>
+          <a:p xmlns:a="http://schemas.openxmlformats.org/drawingml/2006/main">
+            <a:pPr>
+              <a:defRPr sz="1800" b="0">
+                <a:solidFill>
+                  <a:srgbClr val="14243A"/>
+                </a:solidFill>
+                <a:latin typeface="Malgun Gothic"/>
+                <a:ea typeface="Malgun Gothic"/>
+                <a:cs typeface="Malgun Gothic"/>
+              </a:defRPr>
+            </a:pPr>
+            <a:r>
+              <a:rPr sz="1800" b="0">
+                <a:solidFill>
+                  <a:srgbClr val="14243A"/>
+                </a:solidFill>
+                <a:latin typeface="Malgun Gothic"/>
+                <a:ea typeface="Malgun Gothic"/>
+                <a:cs typeface="Malgun Gothic"/>
+              </a:rPr>
+              <a:t>권성호 · Ph.D.</a:t>
             </a:r>
           </a:p>
         </p:txBody>

</xml_diff>